<commit_message>
Upgrade IGL_VisionGuard_AI_Presentation.pptx to a comprehensive 14-slide detailed presentation deck covering all modules, AI pipelines, and API contracts
</commit_message>
<xml_diff>
--- a/docs_and_reports/IGL_VisionGuard_AI_Presentation.pptx
+++ b/docs_and_reports/IGL_VisionGuard_AI_Presentation.pptx
@@ -8,6 +8,17 @@
     <p:sldId id="256" r:id="rId7"/>
     <p:sldId id="257" r:id="rId8"/>
     <p:sldId id="258" r:id="rId9"/>
+    <p:sldId id="259" r:id="rId10"/>
+    <p:sldId id="260" r:id="rId11"/>
+    <p:sldId id="261" r:id="rId12"/>
+    <p:sldId id="262" r:id="rId13"/>
+    <p:sldId id="263" r:id="rId14"/>
+    <p:sldId id="264" r:id="rId15"/>
+    <p:sldId id="265" r:id="rId16"/>
+    <p:sldId id="266" r:id="rId17"/>
+    <p:sldId id="267" r:id="rId18"/>
+    <p:sldId id="268" r:id="rId19"/>
+    <p:sldId id="269" r:id="rId20"/>
   </p:sldIdLst>
   <p:sldSz cx="12191695" cy="6858000" type="screen4x3"/>
   <p:notesSz cx="6858000" cy="9144000"/>
@@ -3086,7 +3097,7 @@
     <p:bg>
       <p:bgPr>
         <a:solidFill>
-          <a:srgbClr val="030712"/>
+          <a:srgbClr val="0F172A"/>
         </a:solidFill>
         <a:effectLst/>
       </p:bgPr>
@@ -3106,8 +3117,8 @@
         </p:nvSpPr>
         <p:spPr>
           <a:xfrm>
-            <a:off x="914400" y="1828800"/>
-            <a:ext cx="10362895" cy="3200400"/>
+            <a:off x="914400" y="1645920"/>
+            <a:ext cx="10332720" cy="4114800"/>
           </a:xfrm>
           <a:prstGeom prst="rect">
             <a:avLst/>
@@ -3133,9 +3144,9 @@
           </a:p>
           <a:p>
             <a:pPr>
-              <a:defRPr sz="2400">
-                <a:solidFill>
-                  <a:srgbClr val="FFFFFF"/>
+              <a:defRPr sz="2400" b="1">
+                <a:solidFill>
+                  <a:srgbClr val="F8FAFC"/>
                 </a:solidFill>
               </a:defRPr>
             </a:pPr>
@@ -3144,15 +3155,813 @@
             </a:r>
           </a:p>
           <a:p>
-            <a:pPr>
-              <a:defRPr sz="1600">
-                <a:solidFill>
-                  <a:srgbClr val="9CA3AF"/>
-                </a:solidFill>
-              </a:defRPr>
-            </a:pPr>
-            <a:r>
-              <a:t>System Architecture, AI Detection Pipeline &amp; Complete Module Presentation</a:t>
+            <a:br/>
+            <a:pPr>
+              <a:defRPr sz="1500">
+                <a:solidFill>
+                  <a:srgbClr val="94A3B8"/>
+                </a:solidFill>
+              </a:defRPr>
+            </a:pPr>
+            <a:r>
+              <a:t>Detailed Technical Architecture, Two-Pass AI Pipeline, Geofence Radar &amp; Packaging Inspection Presentation</a:t>
+            </a:r>
+          </a:p>
+          <a:p>
+            <a:br/>
+            <a:pPr>
+              <a:defRPr sz="1400">
+                <a:solidFill>
+                  <a:srgbClr val="10B981"/>
+                </a:solidFill>
+              </a:defRPr>
+            </a:pPr>
+            <a:r>
+              <a:t>GitHub Repository: https://github.com/Shiv-Kumar005023/IGL.git</a:t>
+            </a:r>
+          </a:p>
+        </p:txBody>
+      </p:sp>
+    </p:spTree>
+  </p:cSld>
+  <p:clrMapOvr>
+    <a:masterClrMapping/>
+  </p:clrMapOvr>
+</p:sld>
+</file>
+
+<file path=ppt/slides/slide10.xml><?xml version="1.0" encoding="utf-8"?>
+<p:sld xmlns:a="http://schemas.openxmlformats.org/drawingml/2006/main" xmlns:p="http://schemas.openxmlformats.org/presentationml/2006/main" xmlns:r="http://schemas.openxmlformats.org/officeDocument/2006/relationships">
+  <p:cSld>
+    <p:bg>
+      <p:bgPr>
+        <a:solidFill>
+          <a:srgbClr val="0F172A"/>
+        </a:solidFill>
+        <a:effectLst/>
+      </p:bgPr>
+    </p:bg>
+    <p:spTree>
+      <p:nvGrpSpPr>
+        <p:cNvPr id="1" name=""/>
+        <p:cNvGrpSpPr/>
+        <p:nvPr/>
+      </p:nvGrpSpPr>
+      <p:grpSpPr/>
+      <p:sp>
+        <p:nvSpPr>
+          <p:cNvPr id="2" name="TextBox 1"/>
+          <p:cNvSpPr txBox="1"/>
+          <p:nvPr/>
+        </p:nvSpPr>
+        <p:spPr>
+          <a:xfrm>
+            <a:off x="731520" y="457200"/>
+            <a:ext cx="10698480" cy="1005840"/>
+          </a:xfrm>
+          <a:prstGeom prst="rect">
+            <a:avLst/>
+          </a:prstGeom>
+          <a:noFill/>
+        </p:spPr>
+        <p:txBody>
+          <a:bodyPr wrap="square">
+            <a:spAutoFit/>
+          </a:bodyPr>
+          <a:lstStyle/>
+          <a:p>
+            <a:pPr>
+              <a:defRPr sz="2400" b="1">
+                <a:solidFill>
+                  <a:srgbClr val="F8FAFC"/>
+                </a:solidFill>
+              </a:defRPr>
+            </a:pPr>
+            <a:r>
+              <a:t>SLIDE 10 | Safety Events &amp; Photo Evidence Capture (Module 6)</a:t>
+            </a:r>
+          </a:p>
+          <a:p>
+            <a:pPr>
+              <a:defRPr sz="1300">
+                <a:solidFill>
+                  <a:srgbClr val="06B6D4"/>
+                </a:solidFill>
+              </a:defRPr>
+            </a:pPr>
+            <a:r>
+              <a:t>SQLite Database Alert Logs &amp; Interactive Evidence Snapshot Modal</a:t>
+            </a:r>
+          </a:p>
+        </p:txBody>
+      </p:sp>
+      <p:sp>
+        <p:nvSpPr>
+          <p:cNvPr id="3" name="TextBox 2"/>
+          <p:cNvSpPr txBox="1"/>
+          <p:nvPr/>
+        </p:nvSpPr>
+        <p:spPr>
+          <a:xfrm>
+            <a:off x="731520" y="1645920"/>
+            <a:ext cx="10698480" cy="4572000"/>
+          </a:xfrm>
+          <a:prstGeom prst="rect">
+            <a:avLst/>
+          </a:prstGeom>
+          <a:noFill/>
+        </p:spPr>
+        <p:txBody>
+          <a:bodyPr wrap="square">
+            <a:spAutoFit/>
+          </a:bodyPr>
+          <a:lstStyle/>
+          <a:p>
+            <a:pPr>
+              <a:defRPr sz="1800" b="1">
+                <a:solidFill>
+                  <a:srgbClr val="06B6D4"/>
+                </a:solidFill>
+              </a:defRPr>
+            </a:pPr>
+            <a:r>
+              <a:t>Safety Alert Management Pipeline</a:t>
+            </a:r>
+          </a:p>
+          <a:p>
+            <a:br/>
+            <a:pPr>
+              <a:defRPr sz="1300">
+                <a:solidFill>
+                  <a:srgbClr val="F8FAFC"/>
+                </a:solidFill>
+              </a:defRPr>
+            </a:pPr>
+            <a:r>
+              <a:t>• Real-Time Alert Log Table: Synchronizes with backend SQLite database (/api/alerts) every 3 seconds.</a:t>
+            </a:r>
+            <a:br/>
+            <a:r>
+              <a:t>• Event Information: Displays event type (PPE_VIOLATION, MOBILE_PHONE_USAGE, NEAR_MISS, RESTRICTED_ZONE), zone name, severity, confidence %, timestamp, and status.</a:t>
+            </a:r>
+            <a:br/>
+            <a:r>
+              <a:t>• Alert Status Lifecycle: Status updates from DETECTED -&gt; ACKNOWLEDGED -&gt; RESOLVED with 1-click status patch endpoints.</a:t>
+            </a:r>
+            <a:br/>
+            <a:r>
+              <a:t>• Photo Evidence Snapshot Modal: Clicking 'View Photo Evidence' opens modal displaying high-res base64 image snapshot captured at the exact moment of breach.</a:t>
+            </a:r>
+          </a:p>
+        </p:txBody>
+      </p:sp>
+    </p:spTree>
+  </p:cSld>
+  <p:clrMapOvr>
+    <a:masterClrMapping/>
+  </p:clrMapOvr>
+</p:sld>
+</file>
+
+<file path=ppt/slides/slide11.xml><?xml version="1.0" encoding="utf-8"?>
+<p:sld xmlns:a="http://schemas.openxmlformats.org/drawingml/2006/main" xmlns:p="http://schemas.openxmlformats.org/presentationml/2006/main" xmlns:r="http://schemas.openxmlformats.org/officeDocument/2006/relationships">
+  <p:cSld>
+    <p:bg>
+      <p:bgPr>
+        <a:solidFill>
+          <a:srgbClr val="0F172A"/>
+        </a:solidFill>
+        <a:effectLst/>
+      </p:bgPr>
+    </p:bg>
+    <p:spTree>
+      <p:nvGrpSpPr>
+        <p:cNvPr id="1" name=""/>
+        <p:cNvGrpSpPr/>
+        <p:nvPr/>
+      </p:nvGrpSpPr>
+      <p:grpSpPr/>
+      <p:sp>
+        <p:nvSpPr>
+          <p:cNvPr id="2" name="TextBox 1"/>
+          <p:cNvSpPr txBox="1"/>
+          <p:nvPr/>
+        </p:nvSpPr>
+        <p:spPr>
+          <a:xfrm>
+            <a:off x="731520" y="457200"/>
+            <a:ext cx="10698480" cy="1005840"/>
+          </a:xfrm>
+          <a:prstGeom prst="rect">
+            <a:avLst/>
+          </a:prstGeom>
+          <a:noFill/>
+        </p:spPr>
+        <p:txBody>
+          <a:bodyPr wrap="square">
+            <a:spAutoFit/>
+          </a:bodyPr>
+          <a:lstStyle/>
+          <a:p>
+            <a:pPr>
+              <a:defRPr sz="2400" b="1">
+                <a:solidFill>
+                  <a:srgbClr val="F8FAFC"/>
+                </a:solidFill>
+              </a:defRPr>
+            </a:pPr>
+            <a:r>
+              <a:t>SLIDE 11 | Personnel Anomaly &amp; Sleeping Detection (Module 7)</a:t>
+            </a:r>
+          </a:p>
+          <a:p>
+            <a:pPr>
+              <a:defRPr sz="1300">
+                <a:solidFill>
+                  <a:srgbClr val="06B6D4"/>
+                </a:solidFill>
+              </a:defRPr>
+            </a:pPr>
+            <a:r>
+              <a:t>Worker Recognition &amp; Duty Inactivity Monitoring</a:t>
+            </a:r>
+          </a:p>
+        </p:txBody>
+      </p:sp>
+      <p:sp>
+        <p:nvSpPr>
+          <p:cNvPr id="3" name="TextBox 2"/>
+          <p:cNvSpPr txBox="1"/>
+          <p:nvPr/>
+        </p:nvSpPr>
+        <p:spPr>
+          <a:xfrm>
+            <a:off x="731520" y="1645920"/>
+            <a:ext cx="10698480" cy="4572000"/>
+          </a:xfrm>
+          <a:prstGeom prst="rect">
+            <a:avLst/>
+          </a:prstGeom>
+          <a:noFill/>
+        </p:spPr>
+        <p:txBody>
+          <a:bodyPr wrap="square">
+            <a:spAutoFit/>
+          </a:bodyPr>
+          <a:lstStyle/>
+          <a:p>
+            <a:pPr>
+              <a:defRPr sz="1800" b="1">
+                <a:solidFill>
+                  <a:srgbClr val="10B981"/>
+                </a:solidFill>
+              </a:defRPr>
+            </a:pPr>
+            <a:r>
+              <a:t>Personnel Safety &amp; Duty Monitoring</a:t>
+            </a:r>
+          </a:p>
+          <a:p>
+            <a:br/>
+            <a:pPr>
+              <a:defRPr sz="1300">
+                <a:solidFill>
+                  <a:srgbClr val="F8FAFC"/>
+                </a:solidFill>
+              </a:defRPr>
+            </a:pPr>
+            <a:r>
+              <a:t>• Worker Authorization Checks: Cross-references detected worker face/body characteristics against registered roster to spot unrecognized personnel.</a:t>
+            </a:r>
+            <a:br/>
+            <a:r>
+              <a:t>• Sleeping-on-Duty Inactivity Alert: Monitors worker head angle &amp; body pose duration to trigger sleeping-on-duty warnings when operators remain inactive in control rooms or plant bays.</a:t>
+            </a:r>
+            <a:br/>
+            <a:r>
+              <a:t>• Audit Log Persistence: Personnel anomaly events are logged to SQLite database with timestamps and severity scores.</a:t>
+            </a:r>
+          </a:p>
+        </p:txBody>
+      </p:sp>
+    </p:spTree>
+  </p:cSld>
+  <p:clrMapOvr>
+    <a:masterClrMapping/>
+  </p:clrMapOvr>
+</p:sld>
+</file>
+
+<file path=ppt/slides/slide12.xml><?xml version="1.0" encoding="utf-8"?>
+<p:sld xmlns:a="http://schemas.openxmlformats.org/drawingml/2006/main" xmlns:p="http://schemas.openxmlformats.org/presentationml/2006/main" xmlns:r="http://schemas.openxmlformats.org/officeDocument/2006/relationships">
+  <p:cSld>
+    <p:bg>
+      <p:bgPr>
+        <a:solidFill>
+          <a:srgbClr val="0F172A"/>
+        </a:solidFill>
+        <a:effectLst/>
+      </p:bgPr>
+    </p:bg>
+    <p:spTree>
+      <p:nvGrpSpPr>
+        <p:cNvPr id="1" name=""/>
+        <p:cNvGrpSpPr/>
+        <p:nvPr/>
+      </p:nvGrpSpPr>
+      <p:grpSpPr/>
+      <p:sp>
+        <p:nvSpPr>
+          <p:cNvPr id="2" name="TextBox 1"/>
+          <p:cNvSpPr txBox="1"/>
+          <p:nvPr/>
+        </p:nvSpPr>
+        <p:spPr>
+          <a:xfrm>
+            <a:off x="731520" y="457200"/>
+            <a:ext cx="10698480" cy="1005840"/>
+          </a:xfrm>
+          <a:prstGeom prst="rect">
+            <a:avLst/>
+          </a:prstGeom>
+          <a:noFill/>
+        </p:spPr>
+        <p:txBody>
+          <a:bodyPr wrap="square">
+            <a:spAutoFit/>
+          </a:bodyPr>
+          <a:lstStyle/>
+          <a:p>
+            <a:pPr>
+              <a:defRPr sz="2400" b="1">
+                <a:solidFill>
+                  <a:srgbClr val="F8FAFC"/>
+                </a:solidFill>
+              </a:defRPr>
+            </a:pPr>
+            <a:r>
+              <a:t>SLIDE 12 | Analytics, Camera Health &amp; Configuration (Modules 8, 9, 10)</a:t>
+            </a:r>
+          </a:p>
+          <a:p>
+            <a:pPr>
+              <a:defRPr sz="1300">
+                <a:solidFill>
+                  <a:srgbClr val="06B6D4"/>
+                </a:solidFill>
+              </a:defRPr>
+            </a:pPr>
+            <a:r>
+              <a:t>System Metrics, Lens Blur Scoring &amp; Polygon Geofence Builder</a:t>
+            </a:r>
+          </a:p>
+        </p:txBody>
+      </p:sp>
+      <p:sp>
+        <p:nvSpPr>
+          <p:cNvPr id="3" name="TextBox 2"/>
+          <p:cNvSpPr txBox="1"/>
+          <p:nvPr/>
+        </p:nvSpPr>
+        <p:spPr>
+          <a:xfrm>
+            <a:off x="731520" y="1645920"/>
+            <a:ext cx="5212080" cy="4572000"/>
+          </a:xfrm>
+          <a:prstGeom prst="rect">
+            <a:avLst/>
+          </a:prstGeom>
+          <a:noFill/>
+        </p:spPr>
+        <p:txBody>
+          <a:bodyPr wrap="square">
+            <a:spAutoFit/>
+          </a:bodyPr>
+          <a:lstStyle/>
+          <a:p>
+            <a:pPr>
+              <a:defRPr sz="1800" b="1">
+                <a:solidFill>
+                  <a:srgbClr val="06B6D4"/>
+                </a:solidFill>
+              </a:defRPr>
+            </a:pPr>
+            <a:r>
+              <a:t>Analytics &amp; Camera Health</a:t>
+            </a:r>
+          </a:p>
+          <a:p>
+            <a:br/>
+            <a:pPr>
+              <a:defRPr sz="1300">
+                <a:solidFill>
+                  <a:srgbClr val="F8FAFC"/>
+                </a:solidFill>
+              </a:defRPr>
+            </a:pPr>
+            <a:r>
+              <a:t>• Analytics Charts (Module 8): Displays historical violation distributions, hourly safety breach trends, and zone risk comparisons.</a:t>
+            </a:r>
+            <a:br/>
+            <a:r>
+              <a:t>• Camera &amp; AI Health Grid (Module 9): Monitors camera online status, FPS stability, mean frame brightness (0-255), and Laplacian blur variance score to flag lens dirt/occlusion.</a:t>
+            </a:r>
+          </a:p>
+        </p:txBody>
+      </p:sp>
+      <p:sp>
+        <p:nvSpPr>
+          <p:cNvPr id="4" name="TextBox 3"/>
+          <p:cNvSpPr txBox="1"/>
+          <p:nvPr/>
+        </p:nvSpPr>
+        <p:spPr>
+          <a:xfrm>
+            <a:off x="6217920" y="1645920"/>
+            <a:ext cx="5212080" cy="4572000"/>
+          </a:xfrm>
+          <a:prstGeom prst="rect">
+            <a:avLst/>
+          </a:prstGeom>
+          <a:noFill/>
+        </p:spPr>
+        <p:txBody>
+          <a:bodyPr wrap="square">
+            <a:spAutoFit/>
+          </a:bodyPr>
+          <a:lstStyle/>
+          <a:p>
+            <a:pPr>
+              <a:defRPr sz="1800" b="1">
+                <a:solidFill>
+                  <a:srgbClr val="F59E0B"/>
+                </a:solidFill>
+              </a:defRPr>
+            </a:pPr>
+            <a:r>
+              <a:t>Configuration &amp; Geofencing</a:t>
+            </a:r>
+          </a:p>
+          <a:p>
+            <a:br/>
+            <a:pPr>
+              <a:defRPr sz="1300">
+                <a:solidFill>
+                  <a:srgbClr val="F8FAFC"/>
+                </a:solidFill>
+              </a:defRPr>
+            </a:pPr>
+            <a:r>
+              <a:t>• Polygon Geofence Builder (Module 10): Interactive ROI drawer allowing site admins to define custom multi-point dangerous zone polygons.</a:t>
+            </a:r>
+            <a:br/>
+            <a:r>
+              <a:t>• Threshold Sliders: Adjustable cutoffs for PPE confidence threshold, phone threshold, min phone duration sec, and max warning escalation limits.</a:t>
+            </a:r>
+          </a:p>
+        </p:txBody>
+      </p:sp>
+    </p:spTree>
+  </p:cSld>
+  <p:clrMapOvr>
+    <a:masterClrMapping/>
+  </p:clrMapOvr>
+</p:sld>
+</file>
+
+<file path=ppt/slides/slide13.xml><?xml version="1.0" encoding="utf-8"?>
+<p:sld xmlns:a="http://schemas.openxmlformats.org/drawingml/2006/main" xmlns:p="http://schemas.openxmlformats.org/presentationml/2006/main" xmlns:r="http://schemas.openxmlformats.org/officeDocument/2006/relationships">
+  <p:cSld>
+    <p:bg>
+      <p:bgPr>
+        <a:solidFill>
+          <a:srgbClr val="0F172A"/>
+        </a:solidFill>
+        <a:effectLst/>
+      </p:bgPr>
+    </p:bg>
+    <p:spTree>
+      <p:nvGrpSpPr>
+        <p:cNvPr id="1" name=""/>
+        <p:cNvGrpSpPr/>
+        <p:nvPr/>
+      </p:nvGrpSpPr>
+      <p:grpSpPr/>
+      <p:sp>
+        <p:nvSpPr>
+          <p:cNvPr id="2" name="TextBox 1"/>
+          <p:cNvSpPr txBox="1"/>
+          <p:nvPr/>
+        </p:nvSpPr>
+        <p:spPr>
+          <a:xfrm>
+            <a:off x="731520" y="457200"/>
+            <a:ext cx="10698480" cy="1005840"/>
+          </a:xfrm>
+          <a:prstGeom prst="rect">
+            <a:avLst/>
+          </a:prstGeom>
+          <a:noFill/>
+        </p:spPr>
+        <p:txBody>
+          <a:bodyPr wrap="square">
+            <a:spAutoFit/>
+          </a:bodyPr>
+          <a:lstStyle/>
+          <a:p>
+            <a:pPr>
+              <a:defRPr sz="2400" b="1">
+                <a:solidFill>
+                  <a:srgbClr val="F8FAFC"/>
+                </a:solidFill>
+              </a:defRPr>
+            </a:pPr>
+            <a:r>
+              <a:t>SLIDE 13 | SQLite Database &amp; FastAPI REST API Contracts</a:t>
+            </a:r>
+          </a:p>
+          <a:p>
+            <a:pPr>
+              <a:defRPr sz="1300">
+                <a:solidFill>
+                  <a:srgbClr val="06B6D4"/>
+                </a:solidFill>
+              </a:defRPr>
+            </a:pPr>
+            <a:r>
+              <a:t>Production Persistence &amp; Backend Server API Architecture</a:t>
+            </a:r>
+          </a:p>
+        </p:txBody>
+      </p:sp>
+      <p:sp>
+        <p:nvSpPr>
+          <p:cNvPr id="3" name="TextBox 2"/>
+          <p:cNvSpPr txBox="1"/>
+          <p:nvPr/>
+        </p:nvSpPr>
+        <p:spPr>
+          <a:xfrm>
+            <a:off x="731520" y="1645920"/>
+            <a:ext cx="5212080" cy="4572000"/>
+          </a:xfrm>
+          <a:prstGeom prst="rect">
+            <a:avLst/>
+          </a:prstGeom>
+          <a:noFill/>
+        </p:spPr>
+        <p:txBody>
+          <a:bodyPr wrap="square">
+            <a:spAutoFit/>
+          </a:bodyPr>
+          <a:lstStyle/>
+          <a:p>
+            <a:pPr>
+              <a:defRPr sz="1800" b="1">
+                <a:solidFill>
+                  <a:srgbClr val="10B981"/>
+                </a:solidFill>
+              </a:defRPr>
+            </a:pPr>
+            <a:r>
+              <a:t>SQLite Database Schemas (igl_safety.db)</a:t>
+            </a:r>
+          </a:p>
+          <a:p>
+            <a:br/>
+            <a:pPr>
+              <a:defRPr sz="1300">
+                <a:solidFill>
+                  <a:srgbClr val="F8FAFC"/>
+                </a:solidFill>
+              </a:defRPr>
+            </a:pPr>
+            <a:r>
+              <a:t>• Table: alerts (id, event_type, zone_name, severity, confidence, status, detected_at, evidence_image_base64, metadata_json)</a:t>
+            </a:r>
+            <a:br/>
+            <a:r>
+              <a:t>• Table: cameras (id, name, type, status, resolution, fps, last_seen)</a:t>
+            </a:r>
+            <a:br/>
+            <a:r>
+              <a:t>• Table: observations (id, timestamp, person_count, active_violations)</a:t>
+            </a:r>
+            <a:br/>
+            <a:r>
+              <a:t>• Table: restricted_zones (id, zone_name, polygon_coords_json)</a:t>
+            </a:r>
+          </a:p>
+        </p:txBody>
+      </p:sp>
+      <p:sp>
+        <p:nvSpPr>
+          <p:cNvPr id="4" name="TextBox 3"/>
+          <p:cNvSpPr txBox="1"/>
+          <p:nvPr/>
+        </p:nvSpPr>
+        <p:spPr>
+          <a:xfrm>
+            <a:off x="6217920" y="1645920"/>
+            <a:ext cx="5212080" cy="4572000"/>
+          </a:xfrm>
+          <a:prstGeom prst="rect">
+            <a:avLst/>
+          </a:prstGeom>
+          <a:noFill/>
+        </p:spPr>
+        <p:txBody>
+          <a:bodyPr wrap="square">
+            <a:spAutoFit/>
+          </a:bodyPr>
+          <a:lstStyle/>
+          <a:p>
+            <a:pPr>
+              <a:defRPr sz="1800" b="1">
+                <a:solidFill>
+                  <a:srgbClr val="06B6D4"/>
+                </a:solidFill>
+              </a:defRPr>
+            </a:pPr>
+            <a:r>
+              <a:t>FastAPI Endpoints (Port 8000)</a:t>
+            </a:r>
+          </a:p>
+          <a:p>
+            <a:br/>
+            <a:pPr>
+              <a:defRPr sz="1300">
+                <a:solidFill>
+                  <a:srgbClr val="F8FAFC"/>
+                </a:solidFill>
+              </a:defRPr>
+            </a:pPr>
+            <a:r>
+              <a:t>• GET /api/dashboard/stats : Live stats calculated directly from SQLite tables.</a:t>
+            </a:r>
+            <a:br/>
+            <a:r>
+              <a:t>• GET &amp; POST /api/cameras : List and register new camera stream feeds.</a:t>
+            </a:r>
+            <a:br/>
+            <a:r>
+              <a:t>• GET &amp; POST /api/alerts : Retrieve alert logs &amp; post violation with base64 snapshot.</a:t>
+            </a:r>
+            <a:br/>
+            <a:r>
+              <a:t>• PATCH /api/alerts/{id}/status : Update alert status to ACKNOWLEDGED or RESOLVED.</a:t>
+            </a:r>
+          </a:p>
+        </p:txBody>
+      </p:sp>
+    </p:spTree>
+  </p:cSld>
+  <p:clrMapOvr>
+    <a:masterClrMapping/>
+  </p:clrMapOvr>
+</p:sld>
+</file>
+
+<file path=ppt/slides/slide14.xml><?xml version="1.0" encoding="utf-8"?>
+<p:sld xmlns:a="http://schemas.openxmlformats.org/drawingml/2006/main" xmlns:p="http://schemas.openxmlformats.org/presentationml/2006/main" xmlns:r="http://schemas.openxmlformats.org/officeDocument/2006/relationships">
+  <p:cSld>
+    <p:bg>
+      <p:bgPr>
+        <a:solidFill>
+          <a:srgbClr val="0F172A"/>
+        </a:solidFill>
+        <a:effectLst/>
+      </p:bgPr>
+    </p:bg>
+    <p:spTree>
+      <p:nvGrpSpPr>
+        <p:cNvPr id="1" name=""/>
+        <p:cNvGrpSpPr/>
+        <p:nvPr/>
+      </p:nvGrpSpPr>
+      <p:grpSpPr/>
+      <p:sp>
+        <p:nvSpPr>
+          <p:cNvPr id="2" name="TextBox 1"/>
+          <p:cNvSpPr txBox="1"/>
+          <p:nvPr/>
+        </p:nvSpPr>
+        <p:spPr>
+          <a:xfrm>
+            <a:off x="731520" y="457200"/>
+            <a:ext cx="10698480" cy="1005840"/>
+          </a:xfrm>
+          <a:prstGeom prst="rect">
+            <a:avLst/>
+          </a:prstGeom>
+          <a:noFill/>
+        </p:spPr>
+        <p:txBody>
+          <a:bodyPr wrap="square">
+            <a:spAutoFit/>
+          </a:bodyPr>
+          <a:lstStyle/>
+          <a:p>
+            <a:pPr>
+              <a:defRPr sz="2400" b="1">
+                <a:solidFill>
+                  <a:srgbClr val="F8FAFC"/>
+                </a:solidFill>
+              </a:defRPr>
+            </a:pPr>
+            <a:r>
+              <a:t>SLIDE 14 | Deployment, Execution Guide &amp; GitHub Repository</a:t>
+            </a:r>
+          </a:p>
+          <a:p>
+            <a:pPr>
+              <a:defRPr sz="1300">
+                <a:solidFill>
+                  <a:srgbClr val="06B6D4"/>
+                </a:solidFill>
+              </a:defRPr>
+            </a:pPr>
+            <a:r>
+              <a:t>Local Startup Commands &amp; Repository Commits Sync</a:t>
+            </a:r>
+          </a:p>
+        </p:txBody>
+      </p:sp>
+      <p:sp>
+        <p:nvSpPr>
+          <p:cNvPr id="3" name="TextBox 2"/>
+          <p:cNvSpPr txBox="1"/>
+          <p:nvPr/>
+        </p:nvSpPr>
+        <p:spPr>
+          <a:xfrm>
+            <a:off x="731520" y="1645920"/>
+            <a:ext cx="10698480" cy="4572000"/>
+          </a:xfrm>
+          <a:prstGeom prst="rect">
+            <a:avLst/>
+          </a:prstGeom>
+          <a:noFill/>
+        </p:spPr>
+        <p:txBody>
+          <a:bodyPr wrap="square">
+            <a:spAutoFit/>
+          </a:bodyPr>
+          <a:lstStyle/>
+          <a:p>
+            <a:pPr>
+              <a:defRPr sz="1800" b="1">
+                <a:solidFill>
+                  <a:srgbClr val="10B981"/>
+                </a:solidFill>
+              </a:defRPr>
+            </a:pPr>
+            <a:r>
+              <a:t>Deployment &amp; Execution Guide</a:t>
+            </a:r>
+          </a:p>
+          <a:p>
+            <a:br/>
+            <a:pPr>
+              <a:defRPr sz="1300">
+                <a:solidFill>
+                  <a:srgbClr val="F8FAFC"/>
+                </a:solidFill>
+              </a:defRPr>
+            </a:pPr>
+            <a:r>
+              <a:t>• Backend Execution:</a:t>
+            </a:r>
+            <a:br/>
+            <a:r>
+              <a:t>   cd backend &amp;&amp; python main.py  (Runs FastAPI on http://localhost:8000)</a:t>
+            </a:r>
+            <a:br/>
+            <a:br/>
+            <a:r>
+              <a:t>• Frontend Execution:</a:t>
+            </a:r>
+            <a:br/>
+            <a:r>
+              <a:t>   cd frontend &amp;&amp; npm run dev  (Runs Vite React App on http://localhost:3000)</a:t>
+            </a:r>
+            <a:br/>
+            <a:br/>
+            <a:r>
+              <a:t>• GitHub Repository Sync:</a:t>
+            </a:r>
+            <a:br/>
+            <a:r>
+              <a:t>   https://github.com/Shiv-Kumar005023/IGL.git  (Branch: main, All commits pushed &amp; clean)</a:t>
+            </a:r>
+            <a:br/>
+            <a:br/>
+            <a:r>
+              <a:t>• Documentation &amp; Presentation Assets:</a:t>
+            </a:r>
+            <a:br/>
+            <a:r>
+              <a:t>   Located in project directory under docs_and_reports/</a:t>
             </a:r>
           </a:p>
         </p:txBody>
@@ -3171,7 +3980,7 @@
     <p:bg>
       <p:bgPr>
         <a:solidFill>
-          <a:srgbClr val="030712"/>
+          <a:srgbClr val="0F172A"/>
         </a:solidFill>
         <a:effectLst/>
       </p:bgPr>
@@ -3191,8 +4000,8 @@
         </p:nvSpPr>
         <p:spPr>
           <a:xfrm>
-            <a:off x="914400" y="731520"/>
-            <a:ext cx="10362895" cy="914400"/>
+            <a:off x="731520" y="457200"/>
+            <a:ext cx="10698480" cy="1005840"/>
           </a:xfrm>
           <a:prstGeom prst="rect">
             <a:avLst/>
@@ -3200,20 +4009,32 @@
           <a:noFill/>
         </p:spPr>
         <p:txBody>
-          <a:bodyPr wrap="none">
+          <a:bodyPr wrap="square">
             <a:spAutoFit/>
           </a:bodyPr>
           <a:lstStyle/>
           <a:p>
             <a:pPr>
-              <a:defRPr sz="2800" b="1">
-                <a:solidFill>
-                  <a:srgbClr val="FFFFFF"/>
-                </a:solidFill>
-              </a:defRPr>
-            </a:pPr>
-            <a:r>
-              <a:t>⚡ Real-Time AI Computer Vision Engines</a:t>
+              <a:defRPr sz="2400" b="1">
+                <a:solidFill>
+                  <a:srgbClr val="F8FAFC"/>
+                </a:solidFill>
+              </a:defRPr>
+            </a:pPr>
+            <a:r>
+              <a:t>SLIDE 02 | Complete 10-Module Application Sitemap</a:t>
+            </a:r>
+          </a:p>
+          <a:p>
+            <a:pPr>
+              <a:defRPr sz="1300">
+                <a:solidFill>
+                  <a:srgbClr val="06B6D4"/>
+                </a:solidFill>
+              </a:defRPr>
+            </a:pPr>
+            <a:r>
+              <a:t>Comprehensive Application Navigation &amp; Architecture Breakdown</a:t>
             </a:r>
           </a:p>
         </p:txBody>
@@ -3226,8 +4047,8 @@
         </p:nvSpPr>
         <p:spPr>
           <a:xfrm>
-            <a:off x="914400" y="2011680"/>
-            <a:ext cx="4937760" cy="4114800"/>
+            <a:off x="731520" y="1554480"/>
+            <a:ext cx="5212080" cy="868680"/>
           </a:xfrm>
           <a:prstGeom prst="rect">
             <a:avLst/>
@@ -3241,38 +4062,26 @@
           <a:lstStyle/>
           <a:p>
             <a:pPr>
-              <a:defRPr sz="2000" b="1">
-                <a:solidFill>
-                  <a:srgbClr val="06B6D4"/>
-                </a:solidFill>
-              </a:defRPr>
-            </a:pPr>
-            <a:r>
-              <a:t>Two-Pass Mobile Phone Detection</a:t>
-            </a:r>
-          </a:p>
-          <a:p>
-            <a:pPr>
-              <a:defRPr sz="1400">
-                <a:solidFill>
-                  <a:srgbClr val="9CA3AF"/>
-                </a:solidFill>
-              </a:defRPr>
-            </a:pPr>
-            <a:r>
-              <a:t>• Pass 1: Full-Frame COCO-SSD Inference (Score 0.15)</a:t>
-            </a:r>
-            <a:br/>
-            <a:r>
-              <a:t>• Pass 2: Upper-Body ROI Crop (360x360 upscaled) for small phones</a:t>
-            </a:r>
-            <a:br/>
-            <a:r>
-              <a:t>• IoU Deduplication (&gt;0.30 overlap merging)</a:t>
-            </a:r>
-            <a:br/>
-            <a:r>
-              <a:t>• Siren Alarm Escalation (Warning Levels 1, 2, 3)</a:t>
+              <a:defRPr sz="1300" b="1">
+                <a:solidFill>
+                  <a:srgbClr val="F8FAFC"/>
+                </a:solidFill>
+              </a:defRPr>
+            </a:pPr>
+            <a:r>
+              <a:t>1. Overview (DashboardView.jsx)</a:t>
+            </a:r>
+          </a:p>
+          <a:p>
+            <a:pPr>
+              <a:defRPr sz="1100">
+                <a:solidFill>
+                  <a:srgbClr val="94A3B8"/>
+                </a:solidFill>
+              </a:defRPr>
+            </a:pPr>
+            <a:r>
+              <a:t>System KPIs, live alert feed, camera status summary</a:t>
             </a:r>
           </a:p>
         </p:txBody>
@@ -3285,8 +4094,8 @@
         </p:nvSpPr>
         <p:spPr>
           <a:xfrm>
-            <a:off x="6309360" y="2011680"/>
-            <a:ext cx="4937760" cy="4114800"/>
+            <a:off x="6126480" y="1554480"/>
+            <a:ext cx="5212080" cy="868680"/>
           </a:xfrm>
           <a:prstGeom prst="rect">
             <a:avLst/>
@@ -3300,38 +4109,402 @@
           <a:lstStyle/>
           <a:p>
             <a:pPr>
-              <a:defRPr sz="2000" b="1">
-                <a:solidFill>
-                  <a:srgbClr val="10B981"/>
-                </a:solidFill>
-              </a:defRPr>
-            </a:pPr>
-            <a:r>
-              <a:t>Dedicated ML Helmet &amp; Safety Rules</a:t>
-            </a:r>
-          </a:p>
-          <a:p>
-            <a:pPr>
-              <a:defRPr sz="1400">
-                <a:solidFill>
-                  <a:srgbClr val="9CA3AF"/>
-                </a:solidFill>
-              </a:defRPr>
-            </a:pPr>
-            <a:r>
-              <a:t>• Head ROI Crop &amp; 224x224 Tensor Processing</a:t>
-            </a:r>
-            <a:br/>
-            <a:r>
-              <a:t>• Strict Conservative Default (hasHelmet = false)</a:t>
-            </a:r>
-            <a:br/>
-            <a:r>
-              <a:t>• Temporal Memory (3 persistence + 3 miss grace frames)</a:t>
-            </a:r>
-            <a:br/>
-            <a:r>
-              <a:t>• Zero Person Count when camera frame is empty</a:t>
+              <a:defRPr sz="1300" b="1">
+                <a:solidFill>
+                  <a:srgbClr val="F8FAFC"/>
+                </a:solidFill>
+              </a:defRPr>
+            </a:pPr>
+            <a:r>
+              <a:t>2. Camera Setup (CameraInputView.jsx)</a:t>
+            </a:r>
+          </a:p>
+          <a:p>
+            <a:pPr>
+              <a:defRPr sz="1100">
+                <a:solidFill>
+                  <a:srgbClr val="94A3B8"/>
+                </a:solidFill>
+              </a:defRPr>
+            </a:pPr>
+            <a:r>
+              <a:t>Webcam, RTSP CCTV, Video Upload + Mirror View toggle</a:t>
+            </a:r>
+          </a:p>
+        </p:txBody>
+      </p:sp>
+      <p:sp>
+        <p:nvSpPr>
+          <p:cNvPr id="5" name="TextBox 4"/>
+          <p:cNvSpPr txBox="1"/>
+          <p:nvPr/>
+        </p:nvSpPr>
+        <p:spPr>
+          <a:xfrm>
+            <a:off x="731520" y="2514600"/>
+            <a:ext cx="5212080" cy="868680"/>
+          </a:xfrm>
+          <a:prstGeom prst="rect">
+            <a:avLst/>
+          </a:prstGeom>
+          <a:noFill/>
+        </p:spPr>
+        <p:txBody>
+          <a:bodyPr wrap="square">
+            <a:spAutoFit/>
+          </a:bodyPr>
+          <a:lstStyle/>
+          <a:p>
+            <a:pPr>
+              <a:defRPr sz="1300" b="1">
+                <a:solidFill>
+                  <a:srgbClr val="F8FAFC"/>
+                </a:solidFill>
+              </a:defRPr>
+            </a:pPr>
+            <a:r>
+              <a:t>3. Live Monitoring (LiveMonitoringView.jsx)</a:t>
+            </a:r>
+          </a:p>
+          <a:p>
+            <a:pPr>
+              <a:defRPr sz="1100">
+                <a:solidFill>
+                  <a:srgbClr val="94A3B8"/>
+                </a:solidFill>
+              </a:defRPr>
+            </a:pPr>
+            <a:r>
+              <a:t>60 FPS AI inference, person tracking, phone siren, overlays</a:t>
+            </a:r>
+          </a:p>
+        </p:txBody>
+      </p:sp>
+      <p:sp>
+        <p:nvSpPr>
+          <p:cNvPr id="6" name="TextBox 5"/>
+          <p:cNvSpPr txBox="1"/>
+          <p:nvPr/>
+        </p:nvSpPr>
+        <p:spPr>
+          <a:xfrm>
+            <a:off x="6126480" y="2514600"/>
+            <a:ext cx="5212080" cy="868680"/>
+          </a:xfrm>
+          <a:prstGeom prst="rect">
+            <a:avLst/>
+          </a:prstGeom>
+          <a:noFill/>
+        </p:spPr>
+        <p:txBody>
+          <a:bodyPr wrap="square">
+            <a:spAutoFit/>
+          </a:bodyPr>
+          <a:lstStyle/>
+          <a:p>
+            <a:pPr>
+              <a:defRPr sz="1300" b="1">
+                <a:solidFill>
+                  <a:srgbClr val="06B6D4"/>
+                </a:solidFill>
+              </a:defRPr>
+            </a:pPr>
+            <a:r>
+              <a:t>4. Packaging Inspection (PackagingInspectionView.jsx)</a:t>
+            </a:r>
+          </a:p>
+          <a:p>
+            <a:pPr>
+              <a:defRPr sz="1100">
+                <a:solidFill>
+                  <a:srgbClr val="94A3B8"/>
+                </a:solidFill>
+              </a:defRPr>
+            </a:pPr>
+            <a:r>
+              <a:t>High-speed conveyor viewport, fill-level, cap &amp; bottle defect QC</a:t>
+            </a:r>
+          </a:p>
+        </p:txBody>
+      </p:sp>
+      <p:sp>
+        <p:nvSpPr>
+          <p:cNvPr id="7" name="TextBox 6"/>
+          <p:cNvSpPr txBox="1"/>
+          <p:nvPr/>
+        </p:nvSpPr>
+        <p:spPr>
+          <a:xfrm>
+            <a:off x="731520" y="3474720"/>
+            <a:ext cx="5212080" cy="868680"/>
+          </a:xfrm>
+          <a:prstGeom prst="rect">
+            <a:avLst/>
+          </a:prstGeom>
+          <a:noFill/>
+        </p:spPr>
+        <p:txBody>
+          <a:bodyPr wrap="square">
+            <a:spAutoFit/>
+          </a:bodyPr>
+          <a:lstStyle/>
+          <a:p>
+            <a:pPr>
+              <a:defRPr sz="1300" b="1">
+                <a:solidFill>
+                  <a:srgbClr val="F8FAFC"/>
+                </a:solidFill>
+              </a:defRPr>
+            </a:pPr>
+            <a:r>
+              <a:t>5. Safety Events (AlertsView.jsx)</a:t>
+            </a:r>
+          </a:p>
+          <a:p>
+            <a:pPr>
+              <a:defRPr sz="1100">
+                <a:solidFill>
+                  <a:srgbClr val="94A3B8"/>
+                </a:solidFill>
+              </a:defRPr>
+            </a:pPr>
+            <a:r>
+              <a:t>Active safety alerts table &amp; base64 photo evidence modal</a:t>
+            </a:r>
+          </a:p>
+        </p:txBody>
+      </p:sp>
+      <p:sp>
+        <p:nvSpPr>
+          <p:cNvPr id="8" name="TextBox 7"/>
+          <p:cNvSpPr txBox="1"/>
+          <p:nvPr/>
+        </p:nvSpPr>
+        <p:spPr>
+          <a:xfrm>
+            <a:off x="6126480" y="3474720"/>
+            <a:ext cx="5212080" cy="868680"/>
+          </a:xfrm>
+          <a:prstGeom prst="rect">
+            <a:avLst/>
+          </a:prstGeom>
+          <a:noFill/>
+        </p:spPr>
+        <p:txBody>
+          <a:bodyPr wrap="square">
+            <a:spAutoFit/>
+          </a:bodyPr>
+          <a:lstStyle/>
+          <a:p>
+            <a:pPr>
+              <a:defRPr sz="1300" b="1">
+                <a:solidFill>
+                  <a:srgbClr val="F8FAFC"/>
+                </a:solidFill>
+              </a:defRPr>
+            </a:pPr>
+            <a:r>
+              <a:t>6. Near Miss (NearMissView.jsx)</a:t>
+            </a:r>
+          </a:p>
+          <a:p>
+            <a:pPr>
+              <a:defRPr sz="1100">
+                <a:solidFill>
+                  <a:srgbClr val="94A3B8"/>
+                </a:solidFill>
+              </a:defRPr>
+            </a:pPr>
+            <a:r>
+              <a:t>2.0m Dangerous Zone Boundary Box &amp; distance radar slider</a:t>
+            </a:r>
+          </a:p>
+        </p:txBody>
+      </p:sp>
+      <p:sp>
+        <p:nvSpPr>
+          <p:cNvPr id="9" name="TextBox 8"/>
+          <p:cNvSpPr txBox="1"/>
+          <p:nvPr/>
+        </p:nvSpPr>
+        <p:spPr>
+          <a:xfrm>
+            <a:off x="731520" y="4434840"/>
+            <a:ext cx="5212080" cy="868680"/>
+          </a:xfrm>
+          <a:prstGeom prst="rect">
+            <a:avLst/>
+          </a:prstGeom>
+          <a:noFill/>
+        </p:spPr>
+        <p:txBody>
+          <a:bodyPr wrap="square">
+            <a:spAutoFit/>
+          </a:bodyPr>
+          <a:lstStyle/>
+          <a:p>
+            <a:pPr>
+              <a:defRPr sz="1300" b="1">
+                <a:solidFill>
+                  <a:srgbClr val="F8FAFC"/>
+                </a:solidFill>
+              </a:defRPr>
+            </a:pPr>
+            <a:r>
+              <a:t>7. Incidents (PersonnelAnomalyView.jsx)</a:t>
+            </a:r>
+          </a:p>
+          <a:p>
+            <a:pPr>
+              <a:defRPr sz="1100">
+                <a:solidFill>
+                  <a:srgbClr val="94A3B8"/>
+                </a:solidFill>
+              </a:defRPr>
+            </a:pPr>
+            <a:r>
+              <a:t>Personnel authorization checks &amp; sleeping-on-duty alerts</a:t>
+            </a:r>
+          </a:p>
+        </p:txBody>
+      </p:sp>
+      <p:sp>
+        <p:nvSpPr>
+          <p:cNvPr id="10" name="TextBox 9"/>
+          <p:cNvSpPr txBox="1"/>
+          <p:nvPr/>
+        </p:nvSpPr>
+        <p:spPr>
+          <a:xfrm>
+            <a:off x="6126480" y="4434840"/>
+            <a:ext cx="5212080" cy="868680"/>
+          </a:xfrm>
+          <a:prstGeom prst="rect">
+            <a:avLst/>
+          </a:prstGeom>
+          <a:noFill/>
+        </p:spPr>
+        <p:txBody>
+          <a:bodyPr wrap="square">
+            <a:spAutoFit/>
+          </a:bodyPr>
+          <a:lstStyle/>
+          <a:p>
+            <a:pPr>
+              <a:defRPr sz="1300" b="1">
+                <a:solidFill>
+                  <a:srgbClr val="F8FAFC"/>
+                </a:solidFill>
+              </a:defRPr>
+            </a:pPr>
+            <a:r>
+              <a:t>8. Analytics (AnalyticsView.jsx)</a:t>
+            </a:r>
+          </a:p>
+          <a:p>
+            <a:pPr>
+              <a:defRPr sz="1100">
+                <a:solidFill>
+                  <a:srgbClr val="94A3B8"/>
+                </a:solidFill>
+              </a:defRPr>
+            </a:pPr>
+            <a:r>
+              <a:t>Historical breach trends, PPE charts &amp; time distribution</a:t>
+            </a:r>
+          </a:p>
+        </p:txBody>
+      </p:sp>
+      <p:sp>
+        <p:nvSpPr>
+          <p:cNvPr id="11" name="TextBox 10"/>
+          <p:cNvSpPr txBox="1"/>
+          <p:nvPr/>
+        </p:nvSpPr>
+        <p:spPr>
+          <a:xfrm>
+            <a:off x="731520" y="5394960"/>
+            <a:ext cx="5212080" cy="868680"/>
+          </a:xfrm>
+          <a:prstGeom prst="rect">
+            <a:avLst/>
+          </a:prstGeom>
+          <a:noFill/>
+        </p:spPr>
+        <p:txBody>
+          <a:bodyPr wrap="square">
+            <a:spAutoFit/>
+          </a:bodyPr>
+          <a:lstStyle/>
+          <a:p>
+            <a:pPr>
+              <a:defRPr sz="1300" b="1">
+                <a:solidFill>
+                  <a:srgbClr val="F8FAFC"/>
+                </a:solidFill>
+              </a:defRPr>
+            </a:pPr>
+            <a:r>
+              <a:t>9. Camera Health (CameraHealthView.jsx)</a:t>
+            </a:r>
+          </a:p>
+          <a:p>
+            <a:pPr>
+              <a:defRPr sz="1100">
+                <a:solidFill>
+                  <a:srgbClr val="94A3B8"/>
+                </a:solidFill>
+              </a:defRPr>
+            </a:pPr>
+            <a:r>
+              <a:t>FPS stability, brightness scoring &amp; lens blur variance</a:t>
+            </a:r>
+          </a:p>
+        </p:txBody>
+      </p:sp>
+      <p:sp>
+        <p:nvSpPr>
+          <p:cNvPr id="12" name="TextBox 11"/>
+          <p:cNvSpPr txBox="1"/>
+          <p:nvPr/>
+        </p:nvSpPr>
+        <p:spPr>
+          <a:xfrm>
+            <a:off x="6126480" y="5394960"/>
+            <a:ext cx="5212080" cy="868680"/>
+          </a:xfrm>
+          <a:prstGeom prst="rect">
+            <a:avLst/>
+          </a:prstGeom>
+          <a:noFill/>
+        </p:spPr>
+        <p:txBody>
+          <a:bodyPr wrap="square">
+            <a:spAutoFit/>
+          </a:bodyPr>
+          <a:lstStyle/>
+          <a:p>
+            <a:pPr>
+              <a:defRPr sz="1300" b="1">
+                <a:solidFill>
+                  <a:srgbClr val="F8FAFC"/>
+                </a:solidFill>
+              </a:defRPr>
+            </a:pPr>
+            <a:r>
+              <a:t>10. Configuration (ConfigurationView.jsx)</a:t>
+            </a:r>
+          </a:p>
+          <a:p>
+            <a:pPr>
+              <a:defRPr sz="1100">
+                <a:solidFill>
+                  <a:srgbClr val="94A3B8"/>
+                </a:solidFill>
+              </a:defRPr>
+            </a:pPr>
+            <a:r>
+              <a:t>Geofence polygon ROI boundary drawer &amp; threshold controls</a:t>
             </a:r>
           </a:p>
         </p:txBody>
@@ -3350,7 +4523,7 @@
     <p:bg>
       <p:bgPr>
         <a:solidFill>
-          <a:srgbClr val="030712"/>
+          <a:srgbClr val="0F172A"/>
         </a:solidFill>
         <a:effectLst/>
       </p:bgPr>
@@ -3370,8 +4543,8 @@
         </p:nvSpPr>
         <p:spPr>
           <a:xfrm>
-            <a:off x="914400" y="731520"/>
-            <a:ext cx="10362895" cy="914400"/>
+            <a:off x="731520" y="457200"/>
+            <a:ext cx="10698480" cy="1005840"/>
           </a:xfrm>
           <a:prstGeom prst="rect">
             <a:avLst/>
@@ -3379,20 +4552,32 @@
           <a:noFill/>
         </p:spPr>
         <p:txBody>
-          <a:bodyPr wrap="none">
+          <a:bodyPr wrap="square">
             <a:spAutoFit/>
           </a:bodyPr>
           <a:lstStyle/>
           <a:p>
             <a:pPr>
-              <a:defRPr sz="2800" b="1">
-                <a:solidFill>
-                  <a:srgbClr val="FFFFFF"/>
-                </a:solidFill>
-              </a:defRPr>
-            </a:pPr>
-            <a:r>
-              <a:t>📦 Packaging Inspection &amp; Dangerous Zone Radar</a:t>
+              <a:defRPr sz="2400" b="1">
+                <a:solidFill>
+                  <a:srgbClr val="F8FAFC"/>
+                </a:solidFill>
+              </a:defRPr>
+            </a:pPr>
+            <a:r>
+              <a:t>SLIDE 03 | Real-Time Person Detection &amp; Centroid Tracker</a:t>
+            </a:r>
+          </a:p>
+          <a:p>
+            <a:pPr>
+              <a:defRPr sz="1300">
+                <a:solidFill>
+                  <a:srgbClr val="06B6D4"/>
+                </a:solidFill>
+              </a:defRPr>
+            </a:pPr>
+            <a:r>
+              <a:t>Strict AI Inference Pipeline with Zero Heuristic Fallbacks</a:t>
             </a:r>
           </a:p>
         </p:txBody>
@@ -3405,8 +4590,8 @@
         </p:nvSpPr>
         <p:spPr>
           <a:xfrm>
-            <a:off x="914400" y="2011680"/>
-            <a:ext cx="4937760" cy="4114800"/>
+            <a:off x="731520" y="1645920"/>
+            <a:ext cx="5212080" cy="4572000"/>
           </a:xfrm>
           <a:prstGeom prst="rect">
             <a:avLst/>
@@ -3420,42 +4605,39 @@
           <a:lstStyle/>
           <a:p>
             <a:pPr>
-              <a:defRPr sz="2000" b="1">
-                <a:solidFill>
-                  <a:srgbClr val="A855F7"/>
-                </a:solidFill>
-              </a:defRPr>
-            </a:pPr>
-            <a:r>
-              <a:t>Conveyor Packaging Quality Control</a:t>
-            </a:r>
-          </a:p>
-          <a:p>
-            <a:pPr>
-              <a:defRPr sz="1400">
-                <a:solidFill>
-                  <a:srgbClr val="9CA3AF"/>
-                </a:solidFill>
-              </a:defRPr>
-            </a:pPr>
-            <a:r>
-              <a:t>• Bottle Fill-Level (PASS / LOW / HIGH)</a:t>
-            </a:r>
-            <a:br/>
-            <a:r>
-              <a:t>• Cap Integrity (PASS / MISSING / DAMAGED)</a:t>
-            </a:r>
-            <a:br/>
-            <a:r>
-              <a:t>• Bottle Surface &amp; Body Anomaly Detection</a:t>
-            </a:r>
-            <a:br/>
-            <a:r>
-              <a:t>• Automated Air-Jet Reject Ejector Output</a:t>
-            </a:r>
-            <a:br/>
-            <a:r>
-              <a:t>• Modular Hardware API (packagingProcessor.js)</a:t>
+              <a:defRPr sz="1800" b="1">
+                <a:solidFill>
+                  <a:srgbClr val="10B981"/>
+                </a:solidFill>
+              </a:defRPr>
+            </a:pPr>
+            <a:r>
+              <a:t>Strict Person Count Rule</a:t>
+            </a:r>
+          </a:p>
+          <a:p>
+            <a:br/>
+            <a:pPr>
+              <a:defRPr sz="1300">
+                <a:solidFill>
+                  <a:srgbClr val="F8FAFC"/>
+                </a:solidFill>
+              </a:defRPr>
+            </a:pPr>
+            <a:r>
+              <a:t>• Strict AI Requirement: The person counter displays '0 Persons' when no human is present in frame.</a:t>
+            </a:r>
+            <a:br/>
+            <a:r>
+              <a:t>• Heuristic &amp; Dummy Fallbacks Removed: Completely eliminated '|| 1' fallbacks, fake tracking IDs, or simulated persons.</a:t>
+            </a:r>
+            <a:br/>
+            <a:r>
+              <a:t>• Direct AI Driver: Person counts are 100% driven by TensorFlow.js COCO-SSD prediction score &gt;= minConfidence (0.35).</a:t>
+            </a:r>
+            <a:br/>
+            <a:r>
+              <a:t>• Clear Reset State: When 0 persons are detected, active tracks and phone misuse states automatically reset.</a:t>
             </a:r>
           </a:p>
         </p:txBody>
@@ -3468,8 +4650,8 @@
         </p:nvSpPr>
         <p:spPr>
           <a:xfrm>
-            <a:off x="6309360" y="2011680"/>
-            <a:ext cx="4937760" cy="4114800"/>
+            <a:off x="6217920" y="1645920"/>
+            <a:ext cx="5212080" cy="4572000"/>
           </a:xfrm>
           <a:prstGeom prst="rect">
             <a:avLst/>
@@ -3483,38 +4665,1089 @@
           <a:lstStyle/>
           <a:p>
             <a:pPr>
-              <a:defRPr sz="2000" b="1">
+              <a:defRPr sz="1800" b="1">
+                <a:solidFill>
+                  <a:srgbClr val="06B6D4"/>
+                </a:solidFill>
+              </a:defRPr>
+            </a:pPr>
+            <a:r>
+              <a:t>Centroid Multi-Person Tracker</a:t>
+            </a:r>
+          </a:p>
+          <a:p>
+            <a:br/>
+            <a:pPr>
+              <a:defRPr sz="1300">
+                <a:solidFill>
+                  <a:srgbClr val="F8FAFC"/>
+                </a:solidFill>
+              </a:defRPr>
+            </a:pPr>
+            <a:r>
+              <a:t>• Track ID Assignment: Generates unique persistent track IDs (TRK-P101, TRK-P102, etc.) for each detected worker.</a:t>
+            </a:r>
+            <a:br/>
+            <a:r>
+              <a:t>• Centroid Distance Matching: Matches bounding box centers across frames with max distance tolerance 0.25.</a:t>
+            </a:r>
+            <a:br/>
+            <a:r>
+              <a:t>• Track Disappearance Memory: Active tracks are maintained for 3000ms before expiration if momentarily occluded.</a:t>
+            </a:r>
+            <a:br/>
+            <a:r>
+              <a:t>• State Synchronization: Links per-worker helmet verification and mobile phone misuse escalation states.</a:t>
+            </a:r>
+          </a:p>
+        </p:txBody>
+      </p:sp>
+    </p:spTree>
+  </p:cSld>
+  <p:clrMapOvr>
+    <a:masterClrMapping/>
+  </p:clrMapOvr>
+</p:sld>
+</file>
+
+<file path=ppt/slides/slide4.xml><?xml version="1.0" encoding="utf-8"?>
+<p:sld xmlns:a="http://schemas.openxmlformats.org/drawingml/2006/main" xmlns:p="http://schemas.openxmlformats.org/presentationml/2006/main" xmlns:r="http://schemas.openxmlformats.org/officeDocument/2006/relationships">
+  <p:cSld>
+    <p:bg>
+      <p:bgPr>
+        <a:solidFill>
+          <a:srgbClr val="0F172A"/>
+        </a:solidFill>
+        <a:effectLst/>
+      </p:bgPr>
+    </p:bg>
+    <p:spTree>
+      <p:nvGrpSpPr>
+        <p:cNvPr id="1" name=""/>
+        <p:cNvGrpSpPr/>
+        <p:nvPr/>
+      </p:nvGrpSpPr>
+      <p:grpSpPr/>
+      <p:sp>
+        <p:nvSpPr>
+          <p:cNvPr id="2" name="TextBox 1"/>
+          <p:cNvSpPr txBox="1"/>
+          <p:nvPr/>
+        </p:nvSpPr>
+        <p:spPr>
+          <a:xfrm>
+            <a:off x="731520" y="457200"/>
+            <a:ext cx="10698480" cy="1005840"/>
+          </a:xfrm>
+          <a:prstGeom prst="rect">
+            <a:avLst/>
+          </a:prstGeom>
+          <a:noFill/>
+        </p:spPr>
+        <p:txBody>
+          <a:bodyPr wrap="square">
+            <a:spAutoFit/>
+          </a:bodyPr>
+          <a:lstStyle/>
+          <a:p>
+            <a:pPr>
+              <a:defRPr sz="2400" b="1">
+                <a:solidFill>
+                  <a:srgbClr val="F8FAFC"/>
+                </a:solidFill>
+              </a:defRPr>
+            </a:pPr>
+            <a:r>
+              <a:t>SLIDE 04 | Two-Pass Mobile Phone Misuse Detection Engine</a:t>
+            </a:r>
+          </a:p>
+          <a:p>
+            <a:pPr>
+              <a:defRPr sz="1300">
+                <a:solidFill>
+                  <a:srgbClr val="06B6D4"/>
+                </a:solidFill>
+              </a:defRPr>
+            </a:pPr>
+            <a:r>
+              <a:t>Small Object Capture, Upscaled ROI Crop &amp; Siren Escalation</a:t>
+            </a:r>
+          </a:p>
+        </p:txBody>
+      </p:sp>
+      <p:sp>
+        <p:nvSpPr>
+          <p:cNvPr id="3" name="TextBox 2"/>
+          <p:cNvSpPr txBox="1"/>
+          <p:nvPr/>
+        </p:nvSpPr>
+        <p:spPr>
+          <a:xfrm>
+            <a:off x="731520" y="1645920"/>
+            <a:ext cx="5212080" cy="4572000"/>
+          </a:xfrm>
+          <a:prstGeom prst="rect">
+            <a:avLst/>
+          </a:prstGeom>
+          <a:noFill/>
+        </p:spPr>
+        <p:txBody>
+          <a:bodyPr wrap="square">
+            <a:spAutoFit/>
+          </a:bodyPr>
+          <a:lstStyle/>
+          <a:p>
+            <a:pPr>
+              <a:defRPr sz="1800" b="1">
+                <a:solidFill>
+                  <a:srgbClr val="F59E0B"/>
+                </a:solidFill>
+              </a:defRPr>
+            </a:pPr>
+            <a:r>
+              <a:t>Two-Pass Architecture</a:t>
+            </a:r>
+          </a:p>
+          <a:p>
+            <a:br/>
+            <a:pPr>
+              <a:defRPr sz="1300">
+                <a:solidFill>
+                  <a:srgbClr val="F8FAFC"/>
+                </a:solidFill>
+              </a:defRPr>
+            </a:pPr>
+            <a:r>
+              <a:t>1. Pass 1 (Full Frame): COCO-SSD runs at low internal threshold (0.15) to capture initial phone candidates.</a:t>
+            </a:r>
+            <a:br/>
+            <a:r>
+              <a:t>2. Pass 2 (Enlarged Upper-Body ROI): For each detected person, head, ears, face, chest &amp; hands region (+20% margins) is cropped, upscaled to 360x360 offscreen canvas, and re-inspected.</a:t>
+            </a:r>
+            <a:br/>
+            <a:r>
+              <a:t>3. Coordinate Re-mapping: ROI phone bounding boxes are scaled back into full-frame pixel coordinates.</a:t>
+            </a:r>
+            <a:br/>
+            <a:r>
+              <a:t>4. IoU Deduplication: Merges overlapping detections (&gt;0.30 IoU) into a clean combined detection list.</a:t>
+            </a:r>
+          </a:p>
+        </p:txBody>
+      </p:sp>
+      <p:sp>
+        <p:nvSpPr>
+          <p:cNvPr id="4" name="TextBox 3"/>
+          <p:cNvSpPr txBox="1"/>
+          <p:nvPr/>
+        </p:nvSpPr>
+        <p:spPr>
+          <a:xfrm>
+            <a:off x="6217920" y="1645920"/>
+            <a:ext cx="5212080" cy="4572000"/>
+          </a:xfrm>
+          <a:prstGeom prst="rect">
+            <a:avLst/>
+          </a:prstGeom>
+          <a:noFill/>
+        </p:spPr>
+        <p:txBody>
+          <a:bodyPr wrap="square">
+            <a:spAutoFit/>
+          </a:bodyPr>
+          <a:lstStyle/>
+          <a:p>
+            <a:pPr>
+              <a:defRPr sz="1800" b="1">
                 <a:solidFill>
                   <a:srgbClr val="EF4444"/>
                 </a:solidFill>
               </a:defRPr>
             </a:pPr>
             <a:r>
-              <a:t>Dangerous Zone &amp; Distance Radar</a:t>
-            </a:r>
-          </a:p>
-          <a:p>
-            <a:pPr>
-              <a:defRPr sz="1400">
-                <a:solidFill>
-                  <a:srgbClr val="9CA3AF"/>
-                </a:solidFill>
-              </a:defRPr>
-            </a:pPr>
-            <a:r>
-              <a:t>• 2.0m Safety Boundary Box around machinery</a:t>
-            </a:r>
-            <a:br/>
-            <a:r>
-              <a:t>• Dynamic Distance Slider (0.2m DANGER to 3.0m SAFE)</a:t>
-            </a:r>
-            <a:br/>
-            <a:r>
-              <a:t>• Ray-Casting Polygon Geofence Builder</a:t>
-            </a:r>
-            <a:br/>
-            <a:r>
-              <a:t>• Real-Time Intrusion Alert &amp; Evidence Capture</a:t>
+              <a:t>Warning Escalation &amp; Siren Machine</a:t>
+            </a:r>
+          </a:p>
+          <a:p>
+            <a:br/>
+            <a:pPr>
+              <a:defRPr sz="1300">
+                <a:solidFill>
+                  <a:srgbClr val="F8FAFC"/>
+                </a:solidFill>
+              </a:defRPr>
+            </a:pPr>
+            <a:r>
+              <a:t>• Spatial Upper-Body Association: Associates phones with nearest person's upper body (max distance = height * 0.70).</a:t>
+            </a:r>
+            <a:br/>
+            <a:r>
+              <a:t>• Persistence &amp; Grace Frames: Requires 3 consecutive persistence frames + 3 miss grace frames to filter noise.</a:t>
+            </a:r>
+            <a:br/>
+            <a:r>
+              <a:t>• Escalation Levels:</a:t>
+            </a:r>
+            <a:br/>
+            <a:r>
+              <a:t>   - Level 1 (Duration &gt;= 2s): Initial Warning Alert.</a:t>
+            </a:r>
+            <a:br/>
+            <a:r>
+              <a:t>   - Level 2 (Interval 4s): Second Warning Alert.</a:t>
+            </a:r>
+            <a:br/>
+            <a:r>
+              <a:t>   - Level 3 (Max Warnings): Web Audio Siren Alarm Activated!</a:t>
+            </a:r>
+          </a:p>
+        </p:txBody>
+      </p:sp>
+    </p:spTree>
+  </p:cSld>
+  <p:clrMapOvr>
+    <a:masterClrMapping/>
+  </p:clrMapOvr>
+</p:sld>
+</file>
+
+<file path=ppt/slides/slide5.xml><?xml version="1.0" encoding="utf-8"?>
+<p:sld xmlns:a="http://schemas.openxmlformats.org/drawingml/2006/main" xmlns:p="http://schemas.openxmlformats.org/presentationml/2006/main" xmlns:r="http://schemas.openxmlformats.org/officeDocument/2006/relationships">
+  <p:cSld>
+    <p:bg>
+      <p:bgPr>
+        <a:solidFill>
+          <a:srgbClr val="0F172A"/>
+        </a:solidFill>
+        <a:effectLst/>
+      </p:bgPr>
+    </p:bg>
+    <p:spTree>
+      <p:nvGrpSpPr>
+        <p:cNvPr id="1" name=""/>
+        <p:cNvGrpSpPr/>
+        <p:nvPr/>
+      </p:nvGrpSpPr>
+      <p:grpSpPr/>
+      <p:sp>
+        <p:nvSpPr>
+          <p:cNvPr id="2" name="TextBox 1"/>
+          <p:cNvSpPr txBox="1"/>
+          <p:nvPr/>
+        </p:nvSpPr>
+        <p:spPr>
+          <a:xfrm>
+            <a:off x="731520" y="457200"/>
+            <a:ext cx="10698480" cy="1005840"/>
+          </a:xfrm>
+          <a:prstGeom prst="rect">
+            <a:avLst/>
+          </a:prstGeom>
+          <a:noFill/>
+        </p:spPr>
+        <p:txBody>
+          <a:bodyPr wrap="square">
+            <a:spAutoFit/>
+          </a:bodyPr>
+          <a:lstStyle/>
+          <a:p>
+            <a:pPr>
+              <a:defRPr sz="2400" b="1">
+                <a:solidFill>
+                  <a:srgbClr val="F8FAFC"/>
+                </a:solidFill>
+              </a:defRPr>
+            </a:pPr>
+            <a:r>
+              <a:t>SLIDE 05 | Dedicated ML Helmet Verification System</a:t>
+            </a:r>
+          </a:p>
+          <a:p>
+            <a:pPr>
+              <a:defRPr sz="1300">
+                <a:solidFill>
+                  <a:srgbClr val="06B6D4"/>
+                </a:solidFill>
+              </a:defRPr>
+            </a:pPr>
+            <a:r>
+              <a:t>Tensor Head Crop Inference with Strict Conservative Safety Fallback</a:t>
+            </a:r>
+          </a:p>
+        </p:txBody>
+      </p:sp>
+      <p:sp>
+        <p:nvSpPr>
+          <p:cNvPr id="3" name="TextBox 2"/>
+          <p:cNvSpPr txBox="1"/>
+          <p:nvPr/>
+        </p:nvSpPr>
+        <p:spPr>
+          <a:xfrm>
+            <a:off x="731520" y="1645920"/>
+            <a:ext cx="10698480" cy="4572000"/>
+          </a:xfrm>
+          <a:prstGeom prst="rect">
+            <a:avLst/>
+          </a:prstGeom>
+          <a:noFill/>
+        </p:spPr>
+        <p:txBody>
+          <a:bodyPr wrap="square">
+            <a:spAutoFit/>
+          </a:bodyPr>
+          <a:lstStyle/>
+          <a:p>
+            <a:pPr>
+              <a:defRPr sz="1800" b="1">
+                <a:solidFill>
+                  <a:srgbClr val="10B981"/>
+                </a:solidFill>
+              </a:defRPr>
+            </a:pPr>
+            <a:r>
+              <a:t>Dedicated Helmet ML Architecture &amp; Safety Rules</a:t>
+            </a:r>
+          </a:p>
+          <a:p>
+            <a:br/>
+            <a:pPr>
+              <a:defRPr sz="1300">
+                <a:solidFill>
+                  <a:srgbClr val="F8FAFC"/>
+                </a:solidFill>
+              </a:defRPr>
+            </a:pPr>
+            <a:r>
+              <a:t>• Head Crop Tensor Preprocessing: Extracts top 25% head ROI from person bounding box, converts to RGB tensor, resizes to 224x224, and normalizes pixel values [0, 1].</a:t>
+            </a:r>
+            <a:br/>
+            <a:r>
+              <a:t>• Dedicated Model Handler (detectHelmetForPerson): Asynchronously loads custom trained TFJS model (/models/helmet/model.json).</a:t>
+            </a:r>
+            <a:br/>
+            <a:r>
+              <a:t>• Strict Conservative Safety Rule: If custom model files are unsupplied, model fails to load, or score &lt; HELMET_CONFIDENCE_THRESHOLD (0.65), system strictly defaults to hasHelmet: false with clear reason ('Dedicated ML model files unsupplied').</a:t>
+            </a:r>
+            <a:br/>
+            <a:r>
+              <a:t>• Explicit Tensor Memory Disposal: Executes tf.dispose([cropTensor, resizedTensor, normTensor, prediction]) on every frame to guarantee zero GPU memory leaks.</a:t>
+            </a:r>
+            <a:br/>
+            <a:r>
+              <a:t>• Temporal Persistence: Uses HELMET_PERSISTENCE_FRAMES = 3 and HELMET_MISS_GRACE_FRAMES = 3 to eliminate single-frame flickering.</a:t>
+            </a:r>
+          </a:p>
+        </p:txBody>
+      </p:sp>
+    </p:spTree>
+  </p:cSld>
+  <p:clrMapOvr>
+    <a:masterClrMapping/>
+  </p:clrMapOvr>
+</p:sld>
+</file>
+
+<file path=ppt/slides/slide6.xml><?xml version="1.0" encoding="utf-8"?>
+<p:sld xmlns:a="http://schemas.openxmlformats.org/drawingml/2006/main" xmlns:p="http://schemas.openxmlformats.org/presentationml/2006/main" xmlns:r="http://schemas.openxmlformats.org/officeDocument/2006/relationships">
+  <p:cSld>
+    <p:bg>
+      <p:bgPr>
+        <a:solidFill>
+          <a:srgbClr val="0F172A"/>
+        </a:solidFill>
+        <a:effectLst/>
+      </p:bgPr>
+    </p:bg>
+    <p:spTree>
+      <p:nvGrpSpPr>
+        <p:cNvPr id="1" name=""/>
+        <p:cNvGrpSpPr/>
+        <p:nvPr/>
+      </p:nvGrpSpPr>
+      <p:grpSpPr/>
+      <p:sp>
+        <p:nvSpPr>
+          <p:cNvPr id="2" name="TextBox 1"/>
+          <p:cNvSpPr txBox="1"/>
+          <p:nvPr/>
+        </p:nvSpPr>
+        <p:spPr>
+          <a:xfrm>
+            <a:off x="731520" y="457200"/>
+            <a:ext cx="10698480" cy="1005840"/>
+          </a:xfrm>
+          <a:prstGeom prst="rect">
+            <a:avLst/>
+          </a:prstGeom>
+          <a:noFill/>
+        </p:spPr>
+        <p:txBody>
+          <a:bodyPr wrap="square">
+            <a:spAutoFit/>
+          </a:bodyPr>
+          <a:lstStyle/>
+          <a:p>
+            <a:pPr>
+              <a:defRPr sz="2400" b="1">
+                <a:solidFill>
+                  <a:srgbClr val="F8FAFC"/>
+                </a:solidFill>
+              </a:defRPr>
+            </a:pPr>
+            <a:r>
+              <a:t>SLIDE 06 | Camera Setup &amp; Camera Mirroring Controls</a:t>
+            </a:r>
+          </a:p>
+          <a:p>
+            <a:pPr>
+              <a:defRPr sz="1300">
+                <a:solidFill>
+                  <a:srgbClr val="06B6D4"/>
+                </a:solidFill>
+              </a:defRPr>
+            </a:pPr>
+            <a:r>
+              <a:t>Flexible Input Channels &amp; Selfie Mirror View Transformation</a:t>
+            </a:r>
+          </a:p>
+        </p:txBody>
+      </p:sp>
+      <p:sp>
+        <p:nvSpPr>
+          <p:cNvPr id="3" name="TextBox 2"/>
+          <p:cNvSpPr txBox="1"/>
+          <p:nvPr/>
+        </p:nvSpPr>
+        <p:spPr>
+          <a:xfrm>
+            <a:off x="731520" y="1645920"/>
+            <a:ext cx="5212080" cy="4572000"/>
+          </a:xfrm>
+          <a:prstGeom prst="rect">
+            <a:avLst/>
+          </a:prstGeom>
+          <a:noFill/>
+        </p:spPr>
+        <p:txBody>
+          <a:bodyPr wrap="square">
+            <a:spAutoFit/>
+          </a:bodyPr>
+          <a:lstStyle/>
+          <a:p>
+            <a:pPr>
+              <a:defRPr sz="1800" b="1">
+                <a:solidFill>
+                  <a:srgbClr val="06B6D4"/>
+                </a:solidFill>
+              </a:defRPr>
+            </a:pPr>
+            <a:r>
+              <a:t>Input Stream Channels</a:t>
+            </a:r>
+          </a:p>
+          <a:p>
+            <a:br/>
+            <a:pPr>
+              <a:defRPr sz="1300">
+                <a:solidFill>
+                  <a:srgbClr val="F8FAFC"/>
+                </a:solidFill>
+              </a:defRPr>
+            </a:pPr>
+            <a:r>
+              <a:t>1. Webcam Feed: Connects device physical webcams via navigator.mediaDevices.getUserMedia.</a:t>
+            </a:r>
+            <a:br/>
+            <a:r>
+              <a:t>2. IP CCTV RTSP Stream: Connects factory network cameras (rtsp://192.168.1.100:554/ch01).</a:t>
+            </a:r>
+            <a:br/>
+            <a:r>
+              <a:t>3. Recorded MP4 Video File: Upload local recorded inspection video for testing.</a:t>
+            </a:r>
+            <a:br/>
+            <a:r>
+              <a:t>4. Frame Quality Analysis: Real-time scoring for brightness (0-255), blur variance (Laplacian score), resolution, and FPS stability.</a:t>
+            </a:r>
+          </a:p>
+        </p:txBody>
+      </p:sp>
+      <p:sp>
+        <p:nvSpPr>
+          <p:cNvPr id="4" name="TextBox 3"/>
+          <p:cNvSpPr txBox="1"/>
+          <p:nvPr/>
+        </p:nvSpPr>
+        <p:spPr>
+          <a:xfrm>
+            <a:off x="6217920" y="1645920"/>
+            <a:ext cx="5212080" cy="4572000"/>
+          </a:xfrm>
+          <a:prstGeom prst="rect">
+            <a:avLst/>
+          </a:prstGeom>
+          <a:noFill/>
+        </p:spPr>
+        <p:txBody>
+          <a:bodyPr wrap="square">
+            <a:spAutoFit/>
+          </a:bodyPr>
+          <a:lstStyle/>
+          <a:p>
+            <a:pPr>
+              <a:defRPr sz="1800" b="1">
+                <a:solidFill>
+                  <a:srgbClr val="10B981"/>
+                </a:solidFill>
+              </a:defRPr>
+            </a:pPr>
+            <a:r>
+              <a:t>Horizontal Camera Mirroring (Selfie View)</a:t>
+            </a:r>
+          </a:p>
+          <a:p>
+            <a:br/>
+            <a:pPr>
+              <a:defRPr sz="1300">
+                <a:solidFill>
+                  <a:srgbClr val="F8FAFC"/>
+                </a:solidFill>
+              </a:defRPr>
+            </a:pPr>
+            <a:r>
+              <a:t>• Root Cause Resolved: Browser raw camera stream does not mirror video, causing left/right inversion. Added selfie mirror transformation (scaleX(-1)).</a:t>
+            </a:r>
+            <a:br/>
+            <a:r>
+              <a:t>• 1-Click Toggle Button: Added 'Mirror View (ON / OFF)' button in both Camera Setup and Live Monitoring headers.</a:t>
+            </a:r>
+            <a:br/>
+            <a:r>
+              <a:t>• Auto-Aligned Bounding Box Math: Bounding boxes auto-align to flipped video (px = width - (x + w)*width), while text tags remain 100% readable &amp; non-flipped!</a:t>
+            </a:r>
+          </a:p>
+        </p:txBody>
+      </p:sp>
+    </p:spTree>
+  </p:cSld>
+  <p:clrMapOvr>
+    <a:masterClrMapping/>
+  </p:clrMapOvr>
+</p:sld>
+</file>
+
+<file path=ppt/slides/slide7.xml><?xml version="1.0" encoding="utf-8"?>
+<p:sld xmlns:a="http://schemas.openxmlformats.org/drawingml/2006/main" xmlns:p="http://schemas.openxmlformats.org/presentationml/2006/main" xmlns:r="http://schemas.openxmlformats.org/officeDocument/2006/relationships">
+  <p:cSld>
+    <p:bg>
+      <p:bgPr>
+        <a:solidFill>
+          <a:srgbClr val="0F172A"/>
+        </a:solidFill>
+        <a:effectLst/>
+      </p:bgPr>
+    </p:bg>
+    <p:spTree>
+      <p:nvGrpSpPr>
+        <p:cNvPr id="1" name=""/>
+        <p:cNvGrpSpPr/>
+        <p:nvPr/>
+      </p:nvGrpSpPr>
+      <p:grpSpPr/>
+      <p:sp>
+        <p:nvSpPr>
+          <p:cNvPr id="2" name="TextBox 1"/>
+          <p:cNvSpPr txBox="1"/>
+          <p:nvPr/>
+        </p:nvSpPr>
+        <p:spPr>
+          <a:xfrm>
+            <a:off x="731520" y="457200"/>
+            <a:ext cx="10698480" cy="1005840"/>
+          </a:xfrm>
+          <a:prstGeom prst="rect">
+            <a:avLst/>
+          </a:prstGeom>
+          <a:noFill/>
+        </p:spPr>
+        <p:txBody>
+          <a:bodyPr wrap="square">
+            <a:spAutoFit/>
+          </a:bodyPr>
+          <a:lstStyle/>
+          <a:p>
+            <a:pPr>
+              <a:defRPr sz="2400" b="1">
+                <a:solidFill>
+                  <a:srgbClr val="F8FAFC"/>
+                </a:solidFill>
+              </a:defRPr>
+            </a:pPr>
+            <a:r>
+              <a:t>SLIDE 07 | Live AI Monitoring &amp; Decoupled 60 FPS Engine</a:t>
+            </a:r>
+          </a:p>
+          <a:p>
+            <a:pPr>
+              <a:defRPr sz="1300">
+                <a:solidFill>
+                  <a:srgbClr val="06B6D4"/>
+                </a:solidFill>
+              </a:defRPr>
+            </a:pPr>
+            <a:r>
+              <a:t>High-Speed Canvas Rendering with Throttled Async Inference</a:t>
+            </a:r>
+          </a:p>
+        </p:txBody>
+      </p:sp>
+      <p:sp>
+        <p:nvSpPr>
+          <p:cNvPr id="3" name="TextBox 2"/>
+          <p:cNvSpPr txBox="1"/>
+          <p:nvPr/>
+        </p:nvSpPr>
+        <p:spPr>
+          <a:xfrm>
+            <a:off x="731520" y="1645920"/>
+            <a:ext cx="10698480" cy="4572000"/>
+          </a:xfrm>
+          <a:prstGeom prst="rect">
+            <a:avLst/>
+          </a:prstGeom>
+          <a:noFill/>
+        </p:spPr>
+        <p:txBody>
+          <a:bodyPr wrap="square">
+            <a:spAutoFit/>
+          </a:bodyPr>
+          <a:lstStyle/>
+          <a:p>
+            <a:pPr>
+              <a:defRPr sz="1800" b="1">
+                <a:solidFill>
+                  <a:srgbClr val="06B6D4"/>
+                </a:solidFill>
+              </a:defRPr>
+            </a:pPr>
+            <a:r>
+              <a:t>Performance &amp; Architecture Innovations</a:t>
+            </a:r>
+          </a:p>
+          <a:p>
+            <a:br/>
+            <a:pPr>
+              <a:defRPr sz="1300">
+                <a:solidFill>
+                  <a:srgbClr val="F8FAFC"/>
+                </a:solidFill>
+              </a:defRPr>
+            </a:pPr>
+            <a:r>
+              <a:t>• Decoupled Render Loop: requestAnimationFrame runs smooth 60 FPS video canvas rendering, completely decoupled from async TensorFlow inference.</a:t>
+            </a:r>
+            <a:br/>
+            <a:r>
+              <a:t>• Throttled Async Inference: AI object detection runs every ~150ms using a boolean concurrency lock (isDetectingRef) to prevent promise queueing &amp; UI freezes.</a:t>
+            </a:r>
+            <a:br/>
+            <a:r>
+              <a:t>• Visual Overlay Layers: Draws Person bounding boxes, Helmet OK/NO HELMET tags, Cell Phone bboxes, Proximity distance lines, and Restricted Zone polygons.</a:t>
+            </a:r>
+            <a:br/>
+            <a:r>
+              <a:t>• Real-Time AI Debug Inspector: Live on-screen console card showing raw prediction counts, phone candidates, and associated worker track IDs.</a:t>
+            </a:r>
+            <a:br/>
+            <a:r>
+              <a:t>• Manual Evidence Alert Capture: 1-click button captures canvas snapshot as base64 string and triggers instant safety alert to database.</a:t>
+            </a:r>
+          </a:p>
+        </p:txBody>
+      </p:sp>
+    </p:spTree>
+  </p:cSld>
+  <p:clrMapOvr>
+    <a:masterClrMapping/>
+  </p:clrMapOvr>
+</p:sld>
+</file>
+
+<file path=ppt/slides/slide8.xml><?xml version="1.0" encoding="utf-8"?>
+<p:sld xmlns:a="http://schemas.openxmlformats.org/drawingml/2006/main" xmlns:p="http://schemas.openxmlformats.org/presentationml/2006/main" xmlns:r="http://schemas.openxmlformats.org/officeDocument/2006/relationships">
+  <p:cSld>
+    <p:bg>
+      <p:bgPr>
+        <a:solidFill>
+          <a:srgbClr val="0F172A"/>
+        </a:solidFill>
+        <a:effectLst/>
+      </p:bgPr>
+    </p:bg>
+    <p:spTree>
+      <p:nvGrpSpPr>
+        <p:cNvPr id="1" name=""/>
+        <p:cNvGrpSpPr/>
+        <p:nvPr/>
+      </p:nvGrpSpPr>
+      <p:grpSpPr/>
+      <p:sp>
+        <p:nvSpPr>
+          <p:cNvPr id="2" name="TextBox 1"/>
+          <p:cNvSpPr txBox="1"/>
+          <p:nvPr/>
+        </p:nvSpPr>
+        <p:spPr>
+          <a:xfrm>
+            <a:off x="731520" y="457200"/>
+            <a:ext cx="10698480" cy="1005840"/>
+          </a:xfrm>
+          <a:prstGeom prst="rect">
+            <a:avLst/>
+          </a:prstGeom>
+          <a:noFill/>
+        </p:spPr>
+        <p:txBody>
+          <a:bodyPr wrap="square">
+            <a:spAutoFit/>
+          </a:bodyPr>
+          <a:lstStyle/>
+          <a:p>
+            <a:pPr>
+              <a:defRPr sz="2400" b="1">
+                <a:solidFill>
+                  <a:srgbClr val="F8FAFC"/>
+                </a:solidFill>
+              </a:defRPr>
+            </a:pPr>
+            <a:r>
+              <a:t>SLIDE 08 | Conveyor Bottle Packaging Quality Control (Module 4)</a:t>
+            </a:r>
+          </a:p>
+          <a:p>
+            <a:pPr>
+              <a:defRPr sz="1300">
+                <a:solidFill>
+                  <a:srgbClr val="06B6D4"/>
+                </a:solidFill>
+              </a:defRPr>
+            </a:pPr>
+            <a:r>
+              <a:t>Automated Fill-Level, Cap Integrity, Surface Defect Inspection &amp; Reject Ejector</a:t>
+            </a:r>
+          </a:p>
+        </p:txBody>
+      </p:sp>
+      <p:sp>
+        <p:nvSpPr>
+          <p:cNvPr id="3" name="TextBox 2"/>
+          <p:cNvSpPr txBox="1"/>
+          <p:nvPr/>
+        </p:nvSpPr>
+        <p:spPr>
+          <a:xfrm>
+            <a:off x="731520" y="1645920"/>
+            <a:ext cx="5212080" cy="4572000"/>
+          </a:xfrm>
+          <a:prstGeom prst="rect">
+            <a:avLst/>
+          </a:prstGeom>
+          <a:noFill/>
+        </p:spPr>
+        <p:txBody>
+          <a:bodyPr wrap="square">
+            <a:spAutoFit/>
+          </a:bodyPr>
+          <a:lstStyle/>
+          <a:p>
+            <a:pPr>
+              <a:defRPr sz="1800" b="1">
+                <a:solidFill>
+                  <a:srgbClr val="A855F7"/>
+                </a:solidFill>
+              </a:defRPr>
+            </a:pPr>
+            <a:r>
+              <a:t>Quad Inspection Checks</a:t>
+            </a:r>
+          </a:p>
+          <a:p>
+            <a:br/>
+            <a:pPr>
+              <a:defRPr sz="1300">
+                <a:solidFill>
+                  <a:srgbClr val="F8FAFC"/>
+                </a:solidFill>
+              </a:defRPr>
+            </a:pPr>
+            <a:r>
+              <a:t>1. Bottle Detection &amp; ID: Tracks bottles moving through conveyor (BTL-9840, BTL-9841, etc.).</a:t>
+            </a:r>
+            <a:br/>
+            <a:r>
+              <a:t>2. Fill-Level Inspection: PASS (88-95%), LOW FILL (60-77%), HIGH FILL (98-100%) with liquid level bar gauge.</a:t>
+            </a:r>
+            <a:br/>
+            <a:r>
+              <a:t>3. Cap Integrity Check: PASS, MISSING, MISALIGNED, or DAMAGED.</a:t>
+            </a:r>
+            <a:br/>
+            <a:r>
+              <a:t>4. Bottle Surface &amp; Body Anomaly: PASS, SURFACE DEFECT, SHAPE ANOMALY.</a:t>
+            </a:r>
+          </a:p>
+        </p:txBody>
+      </p:sp>
+      <p:sp>
+        <p:nvSpPr>
+          <p:cNvPr id="4" name="TextBox 3"/>
+          <p:cNvSpPr txBox="1"/>
+          <p:nvPr/>
+        </p:nvSpPr>
+        <p:spPr>
+          <a:xfrm>
+            <a:off x="6217920" y="1645920"/>
+            <a:ext cx="5212080" cy="4572000"/>
+          </a:xfrm>
+          <a:prstGeom prst="rect">
+            <a:avLst/>
+          </a:prstGeom>
+          <a:noFill/>
+        </p:spPr>
+        <p:txBody>
+          <a:bodyPr wrap="square">
+            <a:spAutoFit/>
+          </a:bodyPr>
+          <a:lstStyle/>
+          <a:p>
+            <a:pPr>
+              <a:defRPr sz="1800" b="1">
+                <a:solidFill>
+                  <a:srgbClr val="10B981"/>
+                </a:solidFill>
+              </a:defRPr>
+            </a:pPr>
+            <a:r>
+              <a:t>Overall Decision &amp; Modular Hardware API</a:t>
+            </a:r>
+          </a:p>
+          <a:p>
+            <a:br/>
+            <a:pPr>
+              <a:defRPr sz="1300">
+                <a:solidFill>
+                  <a:srgbClr val="F8FAFC"/>
+                </a:solidFill>
+              </a:defRPr>
+            </a:pPr>
+            <a:r>
+              <a:t>• Overall Decision: PASS / ACCEPT (all checks pass) vs REJECT / DISCARD (critical check fails).</a:t>
+            </a:r>
+            <a:br/>
+            <a:r>
+              <a:t>• Air-Jet Ejector Output: Automated reject trigger state logged on inspection failure.</a:t>
+            </a:r>
+            <a:br/>
+            <a:r>
+              <a:t>• Conveyor Live Viewport: Animated conveyor belt, 3D laser scanner beam, and real-time liquid level graphics.</a:t>
+            </a:r>
+            <a:br/>
+            <a:r>
+              <a:t>• Modular Hardware API: Service packagingProcessor.js structured for seamless replacement with real 3D depth cameras &amp; TensorRT models.</a:t>
+            </a:r>
+          </a:p>
+        </p:txBody>
+      </p:sp>
+    </p:spTree>
+  </p:cSld>
+  <p:clrMapOvr>
+    <a:masterClrMapping/>
+  </p:clrMapOvr>
+</p:sld>
+</file>
+
+<file path=ppt/slides/slide9.xml><?xml version="1.0" encoding="utf-8"?>
+<p:sld xmlns:a="http://schemas.openxmlformats.org/drawingml/2006/main" xmlns:p="http://schemas.openxmlformats.org/presentationml/2006/main" xmlns:r="http://schemas.openxmlformats.org/officeDocument/2006/relationships">
+  <p:cSld>
+    <p:bg>
+      <p:bgPr>
+        <a:solidFill>
+          <a:srgbClr val="0F172A"/>
+        </a:solidFill>
+        <a:effectLst/>
+      </p:bgPr>
+    </p:bg>
+    <p:spTree>
+      <p:nvGrpSpPr>
+        <p:cNvPr id="1" name=""/>
+        <p:cNvGrpSpPr/>
+        <p:nvPr/>
+      </p:nvGrpSpPr>
+      <p:grpSpPr/>
+      <p:sp>
+        <p:nvSpPr>
+          <p:cNvPr id="2" name="TextBox 1"/>
+          <p:cNvSpPr txBox="1"/>
+          <p:nvPr/>
+        </p:nvSpPr>
+        <p:spPr>
+          <a:xfrm>
+            <a:off x="731520" y="457200"/>
+            <a:ext cx="10698480" cy="1005840"/>
+          </a:xfrm>
+          <a:prstGeom prst="rect">
+            <a:avLst/>
+          </a:prstGeom>
+          <a:noFill/>
+        </p:spPr>
+        <p:txBody>
+          <a:bodyPr wrap="square">
+            <a:spAutoFit/>
+          </a:bodyPr>
+          <a:lstStyle/>
+          <a:p>
+            <a:pPr>
+              <a:defRPr sz="2400" b="1">
+                <a:solidFill>
+                  <a:srgbClr val="F8FAFC"/>
+                </a:solidFill>
+              </a:defRPr>
+            </a:pPr>
+            <a:r>
+              <a:t>SLIDE 09 | Dangerous Zone Boundary Box &amp; Proximity Radar (Module 5)</a:t>
+            </a:r>
+          </a:p>
+          <a:p>
+            <a:pPr>
+              <a:defRPr sz="1300">
+                <a:solidFill>
+                  <a:srgbClr val="06B6D4"/>
+                </a:solidFill>
+              </a:defRPr>
+            </a:pPr>
+            <a:r>
+              <a:t>Geofence Safety Perimeter, Dynamic Distance Position &amp; Proximity Badges</a:t>
+            </a:r>
+          </a:p>
+        </p:txBody>
+      </p:sp>
+      <p:sp>
+        <p:nvSpPr>
+          <p:cNvPr id="3" name="TextBox 2"/>
+          <p:cNvSpPr txBox="1"/>
+          <p:nvPr/>
+        </p:nvSpPr>
+        <p:spPr>
+          <a:xfrm>
+            <a:off x="731520" y="1645920"/>
+            <a:ext cx="5212080" cy="4572000"/>
+          </a:xfrm>
+          <a:prstGeom prst="rect">
+            <a:avLst/>
+          </a:prstGeom>
+          <a:noFill/>
+        </p:spPr>
+        <p:txBody>
+          <a:bodyPr wrap="square">
+            <a:spAutoFit/>
+          </a:bodyPr>
+          <a:lstStyle/>
+          <a:p>
+            <a:pPr>
+              <a:defRPr sz="1800" b="1">
+                <a:solidFill>
+                  <a:srgbClr val="EF4444"/>
+                </a:solidFill>
+              </a:defRPr>
+            </a:pPr>
+            <a:r>
+              <a:t>Dangerous Zone Boundary Box</a:t>
+            </a:r>
+          </a:p>
+          <a:p>
+            <a:br/>
+            <a:pPr>
+              <a:defRPr sz="1300">
+                <a:solidFill>
+                  <a:srgbClr val="F8FAFC"/>
+                </a:solidFill>
+              </a:defRPr>
+            </a:pPr>
+            <a:r>
+              <a:t>• Geofence Perimeter: Visual red danger box (SAFETY BOUNDARY 2.0m) drawn around vehicles (Forklift #FLT-09) &amp; machinery.</a:t>
+            </a:r>
+            <a:br/>
+            <a:r>
+              <a:t>• Real-World Purpose: Prevents workers from entering forbidden high-risk zones (High-Voltage Transformers, Crane Swings, Conveyors).</a:t>
+            </a:r>
+            <a:br/>
+            <a:r>
+              <a:t>• Polygon Ray-Casting: Detects exact boundary intrusion using point-in-polygon math.</a:t>
+            </a:r>
+          </a:p>
+        </p:txBody>
+      </p:sp>
+      <p:sp>
+        <p:nvSpPr>
+          <p:cNvPr id="4" name="TextBox 3"/>
+          <p:cNvSpPr txBox="1"/>
+          <p:nvPr/>
+        </p:nvSpPr>
+        <p:spPr>
+          <a:xfrm>
+            <a:off x="6217920" y="1645920"/>
+            <a:ext cx="5212080" cy="4572000"/>
+          </a:xfrm>
+          <a:prstGeom prst="rect">
+            <a:avLst/>
+          </a:prstGeom>
+          <a:noFill/>
+        </p:spPr>
+        <p:txBody>
+          <a:bodyPr wrap="square">
+            <a:spAutoFit/>
+          </a:bodyPr>
+          <a:lstStyle/>
+          <a:p>
+            <a:pPr>
+              <a:defRPr sz="1800" b="1">
+                <a:solidFill>
+                  <a:srgbClr val="F59E0B"/>
+                </a:solidFill>
+              </a:defRPr>
+            </a:pPr>
+            <a:r>
+              <a:t>Dynamic Distance Radar Controls</a:t>
+            </a:r>
+          </a:p>
+          <a:p>
+            <a:br/>
+            <a:pPr>
+              <a:defRPr sz="1300">
+                <a:solidFill>
+                  <a:srgbClr val="F8FAFC"/>
+                </a:solidFill>
+              </a:defRPr>
+            </a:pPr>
+            <a:r>
+              <a:t>• Dynamic Worker Position Movement: Moving the Worker Distance slider (0.2m to 3.0m) dynamically shifts worker node position on radar screen relative to vehicle boundary!</a:t>
+            </a:r>
+            <a:br/>
+            <a:r>
+              <a:t>• Live Risk Status Badges:</a:t>
+            </a:r>
+            <a:br/>
+            <a:r>
+              <a:t>   - &lt; 1.0m: CRITICAL PROXIMITY BREACH (Red alert + pulse)</a:t>
+            </a:r>
+            <a:br/>
+            <a:r>
+              <a:t>   - 1.0m - 2.0m: HIGH PROXIMITY RISK (Amber warning)</a:t>
+            </a:r>
+            <a:br/>
+            <a:r>
+              <a:t>   - &gt; 2.0m: SAFE DISTANCE OK (Green OK)</a:t>
             </a:r>
           </a:p>
         </p:txBody>

</xml_diff>

<commit_message>
Update PowerPoint PPTX text colors to ultra-bright high-contrast white, cyan, and light slate across all 14 slides
</commit_message>
<xml_diff>
--- a/docs_and_reports/IGL_VisionGuard_AI_Presentation.pptx
+++ b/docs_and_reports/IGL_VisionGuard_AI_Presentation.pptx
@@ -3134,7 +3134,7 @@
             <a:pPr>
               <a:defRPr sz="4400" b="1">
                 <a:solidFill>
-                  <a:srgbClr val="06B6D4"/>
+                  <a:srgbClr val="38BDF8"/>
                 </a:solidFill>
               </a:defRPr>
             </a:pPr>
@@ -3146,7 +3146,7 @@
             <a:pPr>
               <a:defRPr sz="2400" b="1">
                 <a:solidFill>
-                  <a:srgbClr val="F8FAFC"/>
+                  <a:srgbClr val="FFFFFF"/>
                 </a:solidFill>
               </a:defRPr>
             </a:pPr>
@@ -3159,7 +3159,7 @@
             <a:pPr>
               <a:defRPr sz="1500">
                 <a:solidFill>
-                  <a:srgbClr val="94A3B8"/>
+                  <a:srgbClr val="F1F5F9"/>
                 </a:solidFill>
               </a:defRPr>
             </a:pPr>
@@ -3170,9 +3170,9 @@
           <a:p>
             <a:br/>
             <a:pPr>
-              <a:defRPr sz="1400">
-                <a:solidFill>
-                  <a:srgbClr val="10B981"/>
+              <a:defRPr sz="1400" b="1">
+                <a:solidFill>
+                  <a:srgbClr val="34D399"/>
                 </a:solidFill>
               </a:defRPr>
             </a:pPr>
@@ -3216,7 +3216,7 @@
         </p:nvSpPr>
         <p:spPr>
           <a:xfrm>
-            <a:off x="731520" y="457200"/>
+            <a:off x="731520" y="365760"/>
             <a:ext cx="10698480" cy="1005840"/>
           </a:xfrm>
           <a:prstGeom prst="rect">
@@ -3233,7 +3233,7 @@
             <a:pPr>
               <a:defRPr sz="2400" b="1">
                 <a:solidFill>
-                  <a:srgbClr val="F8FAFC"/>
+                  <a:srgbClr val="FFFFFF"/>
                 </a:solidFill>
               </a:defRPr>
             </a:pPr>
@@ -3245,7 +3245,7 @@
             <a:pPr>
               <a:defRPr sz="1300">
                 <a:solidFill>
-                  <a:srgbClr val="06B6D4"/>
+                  <a:srgbClr val="38BDF8"/>
                 </a:solidFill>
               </a:defRPr>
             </a:pPr>
@@ -3257,14 +3257,59 @@
       </p:sp>
       <p:sp>
         <p:nvSpPr>
-          <p:cNvPr id="3" name="TextBox 2"/>
+          <p:cNvPr id="3" name="Rounded Rectangle 2"/>
+          <p:cNvSpPr/>
+          <p:nvPr/>
+        </p:nvSpPr>
+        <p:spPr>
+          <a:xfrm>
+            <a:off x="731520" y="1554480"/>
+            <a:ext cx="10698480" cy="4754880"/>
+          </a:xfrm>
+          <a:prstGeom prst="roundRect">
+            <a:avLst/>
+          </a:prstGeom>
+          <a:solidFill>
+            <a:srgbClr val="1E293B"/>
+          </a:solidFill>
+          <a:ln w="19050">
+            <a:solidFill>
+              <a:srgbClr val="334155"/>
+            </a:solidFill>
+          </a:ln>
+        </p:spPr>
+        <p:style>
+          <a:lnRef idx="1">
+            <a:schemeClr val="accent1"/>
+          </a:lnRef>
+          <a:fillRef idx="3">
+            <a:schemeClr val="accent1"/>
+          </a:fillRef>
+          <a:effectRef idx="2">
+            <a:schemeClr val="accent1"/>
+          </a:effectRef>
+          <a:fontRef idx="minor">
+            <a:schemeClr val="lt1"/>
+          </a:fontRef>
+        </p:style>
+        <p:txBody>
+          <a:bodyPr rtlCol="0" anchor="ctr"/>
+          <a:lstStyle/>
+          <a:p>
+            <a:pPr algn="ctr"/>
+          </a:p>
+        </p:txBody>
+      </p:sp>
+      <p:sp>
+        <p:nvSpPr>
+          <p:cNvPr id="4" name="TextBox 3"/>
           <p:cNvSpPr txBox="1"/>
           <p:nvPr/>
         </p:nvSpPr>
         <p:spPr>
           <a:xfrm>
-            <a:off x="731520" y="1645920"/>
-            <a:ext cx="10698480" cy="4572000"/>
+            <a:off x="731520" y="1554480"/>
+            <a:ext cx="10698480" cy="4754880"/>
           </a:xfrm>
           <a:prstGeom prst="rect">
             <a:avLst/>
@@ -3280,7 +3325,7 @@
             <a:pPr>
               <a:defRPr sz="1800" b="1">
                 <a:solidFill>
-                  <a:srgbClr val="06B6D4"/>
+                  <a:srgbClr val="38BDF8"/>
                 </a:solidFill>
               </a:defRPr>
             </a:pPr>
@@ -3293,7 +3338,7 @@
             <a:pPr>
               <a:defRPr sz="1300">
                 <a:solidFill>
-                  <a:srgbClr val="F8FAFC"/>
+                  <a:srgbClr val="F1F5F9"/>
                 </a:solidFill>
               </a:defRPr>
             </a:pPr>
@@ -3301,13 +3346,16 @@
               <a:t>• Real-Time Alert Log Table: Synchronizes with backend SQLite database (/api/alerts) every 3 seconds.</a:t>
             </a:r>
             <a:br/>
+            <a:br/>
             <a:r>
               <a:t>• Event Information: Displays event type (PPE_VIOLATION, MOBILE_PHONE_USAGE, NEAR_MISS, RESTRICTED_ZONE), zone name, severity, confidence %, timestamp, and status.</a:t>
             </a:r>
             <a:br/>
+            <a:br/>
             <a:r>
               <a:t>• Alert Status Lifecycle: Status updates from DETECTED -&gt; ACKNOWLEDGED -&gt; RESOLVED with 1-click status patch endpoints.</a:t>
             </a:r>
+            <a:br/>
             <a:br/>
             <a:r>
               <a:t>• Photo Evidence Snapshot Modal: Clicking 'View Photo Evidence' opens modal displaying high-res base64 image snapshot captured at the exact moment of breach.</a:t>
@@ -3349,7 +3397,7 @@
         </p:nvSpPr>
         <p:spPr>
           <a:xfrm>
-            <a:off x="731520" y="457200"/>
+            <a:off x="731520" y="365760"/>
             <a:ext cx="10698480" cy="1005840"/>
           </a:xfrm>
           <a:prstGeom prst="rect">
@@ -3366,7 +3414,7 @@
             <a:pPr>
               <a:defRPr sz="2400" b="1">
                 <a:solidFill>
-                  <a:srgbClr val="F8FAFC"/>
+                  <a:srgbClr val="FFFFFF"/>
                 </a:solidFill>
               </a:defRPr>
             </a:pPr>
@@ -3378,7 +3426,7 @@
             <a:pPr>
               <a:defRPr sz="1300">
                 <a:solidFill>
-                  <a:srgbClr val="06B6D4"/>
+                  <a:srgbClr val="38BDF8"/>
                 </a:solidFill>
               </a:defRPr>
             </a:pPr>
@@ -3390,14 +3438,59 @@
       </p:sp>
       <p:sp>
         <p:nvSpPr>
-          <p:cNvPr id="3" name="TextBox 2"/>
+          <p:cNvPr id="3" name="Rounded Rectangle 2"/>
+          <p:cNvSpPr/>
+          <p:nvPr/>
+        </p:nvSpPr>
+        <p:spPr>
+          <a:xfrm>
+            <a:off x="731520" y="1554480"/>
+            <a:ext cx="10698480" cy="4754880"/>
+          </a:xfrm>
+          <a:prstGeom prst="roundRect">
+            <a:avLst/>
+          </a:prstGeom>
+          <a:solidFill>
+            <a:srgbClr val="1E293B"/>
+          </a:solidFill>
+          <a:ln w="19050">
+            <a:solidFill>
+              <a:srgbClr val="334155"/>
+            </a:solidFill>
+          </a:ln>
+        </p:spPr>
+        <p:style>
+          <a:lnRef idx="1">
+            <a:schemeClr val="accent1"/>
+          </a:lnRef>
+          <a:fillRef idx="3">
+            <a:schemeClr val="accent1"/>
+          </a:fillRef>
+          <a:effectRef idx="2">
+            <a:schemeClr val="accent1"/>
+          </a:effectRef>
+          <a:fontRef idx="minor">
+            <a:schemeClr val="lt1"/>
+          </a:fontRef>
+        </p:style>
+        <p:txBody>
+          <a:bodyPr rtlCol="0" anchor="ctr"/>
+          <a:lstStyle/>
+          <a:p>
+            <a:pPr algn="ctr"/>
+          </a:p>
+        </p:txBody>
+      </p:sp>
+      <p:sp>
+        <p:nvSpPr>
+          <p:cNvPr id="4" name="TextBox 3"/>
           <p:cNvSpPr txBox="1"/>
           <p:nvPr/>
         </p:nvSpPr>
         <p:spPr>
           <a:xfrm>
-            <a:off x="731520" y="1645920"/>
-            <a:ext cx="10698480" cy="4572000"/>
+            <a:off x="731520" y="1554480"/>
+            <a:ext cx="10698480" cy="4754880"/>
           </a:xfrm>
           <a:prstGeom prst="rect">
             <a:avLst/>
@@ -3413,7 +3506,7 @@
             <a:pPr>
               <a:defRPr sz="1800" b="1">
                 <a:solidFill>
-                  <a:srgbClr val="10B981"/>
+                  <a:srgbClr val="34D399"/>
                 </a:solidFill>
               </a:defRPr>
             </a:pPr>
@@ -3426,7 +3519,7 @@
             <a:pPr>
               <a:defRPr sz="1300">
                 <a:solidFill>
-                  <a:srgbClr val="F8FAFC"/>
+                  <a:srgbClr val="F1F5F9"/>
                 </a:solidFill>
               </a:defRPr>
             </a:pPr>
@@ -3434,9 +3527,11 @@
               <a:t>• Worker Authorization Checks: Cross-references detected worker face/body characteristics against registered roster to spot unrecognized personnel.</a:t>
             </a:r>
             <a:br/>
+            <a:br/>
             <a:r>
               <a:t>• Sleeping-on-Duty Inactivity Alert: Monitors worker head angle &amp; body pose duration to trigger sleeping-on-duty warnings when operators remain inactive in control rooms or plant bays.</a:t>
             </a:r>
+            <a:br/>
             <a:br/>
             <a:r>
               <a:t>• Audit Log Persistence: Personnel anomaly events are logged to SQLite database with timestamps and severity scores.</a:t>
@@ -3478,7 +3573,7 @@
         </p:nvSpPr>
         <p:spPr>
           <a:xfrm>
-            <a:off x="731520" y="457200"/>
+            <a:off x="731520" y="365760"/>
             <a:ext cx="10698480" cy="1005840"/>
           </a:xfrm>
           <a:prstGeom prst="rect">
@@ -3495,7 +3590,7 @@
             <a:pPr>
               <a:defRPr sz="2400" b="1">
                 <a:solidFill>
-                  <a:srgbClr val="F8FAFC"/>
+                  <a:srgbClr val="FFFFFF"/>
                 </a:solidFill>
               </a:defRPr>
             </a:pPr>
@@ -3507,7 +3602,7 @@
             <a:pPr>
               <a:defRPr sz="1300">
                 <a:solidFill>
-                  <a:srgbClr val="06B6D4"/>
+                  <a:srgbClr val="38BDF8"/>
                 </a:solidFill>
               </a:defRPr>
             </a:pPr>
@@ -3519,14 +3614,59 @@
       </p:sp>
       <p:sp>
         <p:nvSpPr>
-          <p:cNvPr id="3" name="TextBox 2"/>
+          <p:cNvPr id="3" name="Rounded Rectangle 2"/>
+          <p:cNvSpPr/>
+          <p:nvPr/>
+        </p:nvSpPr>
+        <p:spPr>
+          <a:xfrm>
+            <a:off x="731520" y="1554480"/>
+            <a:ext cx="5212080" cy="4754880"/>
+          </a:xfrm>
+          <a:prstGeom prst="roundRect">
+            <a:avLst/>
+          </a:prstGeom>
+          <a:solidFill>
+            <a:srgbClr val="1E293B"/>
+          </a:solidFill>
+          <a:ln w="19050">
+            <a:solidFill>
+              <a:srgbClr val="334155"/>
+            </a:solidFill>
+          </a:ln>
+        </p:spPr>
+        <p:style>
+          <a:lnRef idx="1">
+            <a:schemeClr val="accent1"/>
+          </a:lnRef>
+          <a:fillRef idx="3">
+            <a:schemeClr val="accent1"/>
+          </a:fillRef>
+          <a:effectRef idx="2">
+            <a:schemeClr val="accent1"/>
+          </a:effectRef>
+          <a:fontRef idx="minor">
+            <a:schemeClr val="lt1"/>
+          </a:fontRef>
+        </p:style>
+        <p:txBody>
+          <a:bodyPr rtlCol="0" anchor="ctr"/>
+          <a:lstStyle/>
+          <a:p>
+            <a:pPr algn="ctr"/>
+          </a:p>
+        </p:txBody>
+      </p:sp>
+      <p:sp>
+        <p:nvSpPr>
+          <p:cNvPr id="4" name="TextBox 3"/>
           <p:cNvSpPr txBox="1"/>
           <p:nvPr/>
         </p:nvSpPr>
         <p:spPr>
           <a:xfrm>
-            <a:off x="731520" y="1645920"/>
-            <a:ext cx="5212080" cy="4572000"/>
+            <a:off x="731520" y="1554480"/>
+            <a:ext cx="5212080" cy="4754880"/>
           </a:xfrm>
           <a:prstGeom prst="rect">
             <a:avLst/>
@@ -3542,7 +3682,7 @@
             <a:pPr>
               <a:defRPr sz="1800" b="1">
                 <a:solidFill>
-                  <a:srgbClr val="06B6D4"/>
+                  <a:srgbClr val="38BDF8"/>
                 </a:solidFill>
               </a:defRPr>
             </a:pPr>
@@ -3555,7 +3695,7 @@
             <a:pPr>
               <a:defRPr sz="1300">
                 <a:solidFill>
-                  <a:srgbClr val="F8FAFC"/>
+                  <a:srgbClr val="F1F5F9"/>
                 </a:solidFill>
               </a:defRPr>
             </a:pPr>
@@ -3563,6 +3703,7 @@
               <a:t>• Analytics Charts (Module 8): Displays historical violation distributions, hourly safety breach trends, and zone risk comparisons.</a:t>
             </a:r>
             <a:br/>
+            <a:br/>
             <a:r>
               <a:t>• Camera &amp; AI Health Grid (Module 9): Monitors camera online status, FPS stability, mean frame brightness (0-255), and Laplacian blur variance score to flag lens dirt/occlusion.</a:t>
             </a:r>
@@ -3571,14 +3712,59 @@
       </p:sp>
       <p:sp>
         <p:nvSpPr>
-          <p:cNvPr id="4" name="TextBox 3"/>
+          <p:cNvPr id="5" name="Rounded Rectangle 4"/>
+          <p:cNvSpPr/>
+          <p:nvPr/>
+        </p:nvSpPr>
+        <p:spPr>
+          <a:xfrm>
+            <a:off x="6217920" y="1554480"/>
+            <a:ext cx="5212080" cy="4754880"/>
+          </a:xfrm>
+          <a:prstGeom prst="roundRect">
+            <a:avLst/>
+          </a:prstGeom>
+          <a:solidFill>
+            <a:srgbClr val="1E293B"/>
+          </a:solidFill>
+          <a:ln w="19050">
+            <a:solidFill>
+              <a:srgbClr val="334155"/>
+            </a:solidFill>
+          </a:ln>
+        </p:spPr>
+        <p:style>
+          <a:lnRef idx="1">
+            <a:schemeClr val="accent1"/>
+          </a:lnRef>
+          <a:fillRef idx="3">
+            <a:schemeClr val="accent1"/>
+          </a:fillRef>
+          <a:effectRef idx="2">
+            <a:schemeClr val="accent1"/>
+          </a:effectRef>
+          <a:fontRef idx="minor">
+            <a:schemeClr val="lt1"/>
+          </a:fontRef>
+        </p:style>
+        <p:txBody>
+          <a:bodyPr rtlCol="0" anchor="ctr"/>
+          <a:lstStyle/>
+          <a:p>
+            <a:pPr algn="ctr"/>
+          </a:p>
+        </p:txBody>
+      </p:sp>
+      <p:sp>
+        <p:nvSpPr>
+          <p:cNvPr id="6" name="TextBox 5"/>
           <p:cNvSpPr txBox="1"/>
           <p:nvPr/>
         </p:nvSpPr>
         <p:spPr>
           <a:xfrm>
-            <a:off x="6217920" y="1645920"/>
-            <a:ext cx="5212080" cy="4572000"/>
+            <a:off x="6217920" y="1554480"/>
+            <a:ext cx="5212080" cy="4754880"/>
           </a:xfrm>
           <a:prstGeom prst="rect">
             <a:avLst/>
@@ -3594,7 +3780,7 @@
             <a:pPr>
               <a:defRPr sz="1800" b="1">
                 <a:solidFill>
-                  <a:srgbClr val="F59E0B"/>
+                  <a:srgbClr val="FBBF24"/>
                 </a:solidFill>
               </a:defRPr>
             </a:pPr>
@@ -3607,13 +3793,14 @@
             <a:pPr>
               <a:defRPr sz="1300">
                 <a:solidFill>
-                  <a:srgbClr val="F8FAFC"/>
+                  <a:srgbClr val="F1F5F9"/>
                 </a:solidFill>
               </a:defRPr>
             </a:pPr>
             <a:r>
               <a:t>• Polygon Geofence Builder (Module 10): Interactive ROI drawer allowing site admins to define custom multi-point dangerous zone polygons.</a:t>
             </a:r>
+            <a:br/>
             <a:br/>
             <a:r>
               <a:t>• Threshold Sliders: Adjustable cutoffs for PPE confidence threshold, phone threshold, min phone duration sec, and max warning escalation limits.</a:t>
@@ -3655,7 +3842,7 @@
         </p:nvSpPr>
         <p:spPr>
           <a:xfrm>
-            <a:off x="731520" y="457200"/>
+            <a:off x="731520" y="365760"/>
             <a:ext cx="10698480" cy="1005840"/>
           </a:xfrm>
           <a:prstGeom prst="rect">
@@ -3672,7 +3859,7 @@
             <a:pPr>
               <a:defRPr sz="2400" b="1">
                 <a:solidFill>
-                  <a:srgbClr val="F8FAFC"/>
+                  <a:srgbClr val="FFFFFF"/>
                 </a:solidFill>
               </a:defRPr>
             </a:pPr>
@@ -3684,7 +3871,7 @@
             <a:pPr>
               <a:defRPr sz="1300">
                 <a:solidFill>
-                  <a:srgbClr val="06B6D4"/>
+                  <a:srgbClr val="38BDF8"/>
                 </a:solidFill>
               </a:defRPr>
             </a:pPr>
@@ -3696,14 +3883,59 @@
       </p:sp>
       <p:sp>
         <p:nvSpPr>
-          <p:cNvPr id="3" name="TextBox 2"/>
+          <p:cNvPr id="3" name="Rounded Rectangle 2"/>
+          <p:cNvSpPr/>
+          <p:nvPr/>
+        </p:nvSpPr>
+        <p:spPr>
+          <a:xfrm>
+            <a:off x="731520" y="1554480"/>
+            <a:ext cx="5212080" cy="4754880"/>
+          </a:xfrm>
+          <a:prstGeom prst="roundRect">
+            <a:avLst/>
+          </a:prstGeom>
+          <a:solidFill>
+            <a:srgbClr val="1E293B"/>
+          </a:solidFill>
+          <a:ln w="19050">
+            <a:solidFill>
+              <a:srgbClr val="334155"/>
+            </a:solidFill>
+          </a:ln>
+        </p:spPr>
+        <p:style>
+          <a:lnRef idx="1">
+            <a:schemeClr val="accent1"/>
+          </a:lnRef>
+          <a:fillRef idx="3">
+            <a:schemeClr val="accent1"/>
+          </a:fillRef>
+          <a:effectRef idx="2">
+            <a:schemeClr val="accent1"/>
+          </a:effectRef>
+          <a:fontRef idx="minor">
+            <a:schemeClr val="lt1"/>
+          </a:fontRef>
+        </p:style>
+        <p:txBody>
+          <a:bodyPr rtlCol="0" anchor="ctr"/>
+          <a:lstStyle/>
+          <a:p>
+            <a:pPr algn="ctr"/>
+          </a:p>
+        </p:txBody>
+      </p:sp>
+      <p:sp>
+        <p:nvSpPr>
+          <p:cNvPr id="4" name="TextBox 3"/>
           <p:cNvSpPr txBox="1"/>
           <p:nvPr/>
         </p:nvSpPr>
         <p:spPr>
           <a:xfrm>
-            <a:off x="731520" y="1645920"/>
-            <a:ext cx="5212080" cy="4572000"/>
+            <a:off x="731520" y="1554480"/>
+            <a:ext cx="5212080" cy="4754880"/>
           </a:xfrm>
           <a:prstGeom prst="rect">
             <a:avLst/>
@@ -3719,7 +3951,7 @@
             <a:pPr>
               <a:defRPr sz="1800" b="1">
                 <a:solidFill>
-                  <a:srgbClr val="10B981"/>
+                  <a:srgbClr val="34D399"/>
                 </a:solidFill>
               </a:defRPr>
             </a:pPr>
@@ -3732,7 +3964,7 @@
             <a:pPr>
               <a:defRPr sz="1300">
                 <a:solidFill>
-                  <a:srgbClr val="F8FAFC"/>
+                  <a:srgbClr val="F1F5F9"/>
                 </a:solidFill>
               </a:defRPr>
             </a:pPr>
@@ -3740,14 +3972,17 @@
               <a:t>• Table: alerts (id, event_type, zone_name, severity, confidence, status, detected_at, evidence_image_base64, metadata_json)</a:t>
             </a:r>
             <a:br/>
+            <a:br/>
             <a:r>
               <a:t>• Table: cameras (id, name, type, status, resolution, fps, last_seen)</a:t>
             </a:r>
             <a:br/>
+            <a:br/>
             <a:r>
               <a:t>• Table: observations (id, timestamp, person_count, active_violations)</a:t>
             </a:r>
             <a:br/>
+            <a:br/>
             <a:r>
               <a:t>• Table: restricted_zones (id, zone_name, polygon_coords_json)</a:t>
             </a:r>
@@ -3756,14 +3991,59 @@
       </p:sp>
       <p:sp>
         <p:nvSpPr>
-          <p:cNvPr id="4" name="TextBox 3"/>
+          <p:cNvPr id="5" name="Rounded Rectangle 4"/>
+          <p:cNvSpPr/>
+          <p:nvPr/>
+        </p:nvSpPr>
+        <p:spPr>
+          <a:xfrm>
+            <a:off x="6217920" y="1554480"/>
+            <a:ext cx="5212080" cy="4754880"/>
+          </a:xfrm>
+          <a:prstGeom prst="roundRect">
+            <a:avLst/>
+          </a:prstGeom>
+          <a:solidFill>
+            <a:srgbClr val="1E293B"/>
+          </a:solidFill>
+          <a:ln w="19050">
+            <a:solidFill>
+              <a:srgbClr val="334155"/>
+            </a:solidFill>
+          </a:ln>
+        </p:spPr>
+        <p:style>
+          <a:lnRef idx="1">
+            <a:schemeClr val="accent1"/>
+          </a:lnRef>
+          <a:fillRef idx="3">
+            <a:schemeClr val="accent1"/>
+          </a:fillRef>
+          <a:effectRef idx="2">
+            <a:schemeClr val="accent1"/>
+          </a:effectRef>
+          <a:fontRef idx="minor">
+            <a:schemeClr val="lt1"/>
+          </a:fontRef>
+        </p:style>
+        <p:txBody>
+          <a:bodyPr rtlCol="0" anchor="ctr"/>
+          <a:lstStyle/>
+          <a:p>
+            <a:pPr algn="ctr"/>
+          </a:p>
+        </p:txBody>
+      </p:sp>
+      <p:sp>
+        <p:nvSpPr>
+          <p:cNvPr id="6" name="TextBox 5"/>
           <p:cNvSpPr txBox="1"/>
           <p:nvPr/>
         </p:nvSpPr>
         <p:spPr>
           <a:xfrm>
-            <a:off x="6217920" y="1645920"/>
-            <a:ext cx="5212080" cy="4572000"/>
+            <a:off x="6217920" y="1554480"/>
+            <a:ext cx="5212080" cy="4754880"/>
           </a:xfrm>
           <a:prstGeom prst="rect">
             <a:avLst/>
@@ -3779,7 +4059,7 @@
             <a:pPr>
               <a:defRPr sz="1800" b="1">
                 <a:solidFill>
-                  <a:srgbClr val="06B6D4"/>
+                  <a:srgbClr val="38BDF8"/>
                 </a:solidFill>
               </a:defRPr>
             </a:pPr>
@@ -3792,7 +4072,7 @@
             <a:pPr>
               <a:defRPr sz="1300">
                 <a:solidFill>
-                  <a:srgbClr val="F8FAFC"/>
+                  <a:srgbClr val="F1F5F9"/>
                 </a:solidFill>
               </a:defRPr>
             </a:pPr>
@@ -3800,13 +4080,16 @@
               <a:t>• GET /api/dashboard/stats : Live stats calculated directly from SQLite tables.</a:t>
             </a:r>
             <a:br/>
+            <a:br/>
             <a:r>
               <a:t>• GET &amp; POST /api/cameras : List and register new camera stream feeds.</a:t>
             </a:r>
             <a:br/>
+            <a:br/>
             <a:r>
               <a:t>• GET &amp; POST /api/alerts : Retrieve alert logs &amp; post violation with base64 snapshot.</a:t>
             </a:r>
+            <a:br/>
             <a:br/>
             <a:r>
               <a:t>• PATCH /api/alerts/{id}/status : Update alert status to ACKNOWLEDGED or RESOLVED.</a:t>
@@ -3848,7 +4131,7 @@
         </p:nvSpPr>
         <p:spPr>
           <a:xfrm>
-            <a:off x="731520" y="457200"/>
+            <a:off x="731520" y="365760"/>
             <a:ext cx="10698480" cy="1005840"/>
           </a:xfrm>
           <a:prstGeom prst="rect">
@@ -3865,7 +4148,7 @@
             <a:pPr>
               <a:defRPr sz="2400" b="1">
                 <a:solidFill>
-                  <a:srgbClr val="F8FAFC"/>
+                  <a:srgbClr val="FFFFFF"/>
                 </a:solidFill>
               </a:defRPr>
             </a:pPr>
@@ -3877,7 +4160,7 @@
             <a:pPr>
               <a:defRPr sz="1300">
                 <a:solidFill>
-                  <a:srgbClr val="06B6D4"/>
+                  <a:srgbClr val="38BDF8"/>
                 </a:solidFill>
               </a:defRPr>
             </a:pPr>
@@ -3889,14 +4172,59 @@
       </p:sp>
       <p:sp>
         <p:nvSpPr>
-          <p:cNvPr id="3" name="TextBox 2"/>
+          <p:cNvPr id="3" name="Rounded Rectangle 2"/>
+          <p:cNvSpPr/>
+          <p:nvPr/>
+        </p:nvSpPr>
+        <p:spPr>
+          <a:xfrm>
+            <a:off x="731520" y="1554480"/>
+            <a:ext cx="10698480" cy="4754880"/>
+          </a:xfrm>
+          <a:prstGeom prst="roundRect">
+            <a:avLst/>
+          </a:prstGeom>
+          <a:solidFill>
+            <a:srgbClr val="1E293B"/>
+          </a:solidFill>
+          <a:ln w="19050">
+            <a:solidFill>
+              <a:srgbClr val="334155"/>
+            </a:solidFill>
+          </a:ln>
+        </p:spPr>
+        <p:style>
+          <a:lnRef idx="1">
+            <a:schemeClr val="accent1"/>
+          </a:lnRef>
+          <a:fillRef idx="3">
+            <a:schemeClr val="accent1"/>
+          </a:fillRef>
+          <a:effectRef idx="2">
+            <a:schemeClr val="accent1"/>
+          </a:effectRef>
+          <a:fontRef idx="minor">
+            <a:schemeClr val="lt1"/>
+          </a:fontRef>
+        </p:style>
+        <p:txBody>
+          <a:bodyPr rtlCol="0" anchor="ctr"/>
+          <a:lstStyle/>
+          <a:p>
+            <a:pPr algn="ctr"/>
+          </a:p>
+        </p:txBody>
+      </p:sp>
+      <p:sp>
+        <p:nvSpPr>
+          <p:cNvPr id="4" name="TextBox 3"/>
           <p:cNvSpPr txBox="1"/>
           <p:nvPr/>
         </p:nvSpPr>
         <p:spPr>
           <a:xfrm>
-            <a:off x="731520" y="1645920"/>
-            <a:ext cx="10698480" cy="4572000"/>
+            <a:off x="731520" y="1554480"/>
+            <a:ext cx="10698480" cy="4754880"/>
           </a:xfrm>
           <a:prstGeom prst="rect">
             <a:avLst/>
@@ -3912,7 +4240,7 @@
             <a:pPr>
               <a:defRPr sz="1800" b="1">
                 <a:solidFill>
-                  <a:srgbClr val="10B981"/>
+                  <a:srgbClr val="34D399"/>
                 </a:solidFill>
               </a:defRPr>
             </a:pPr>
@@ -3925,7 +4253,7 @@
             <a:pPr>
               <a:defRPr sz="1300">
                 <a:solidFill>
-                  <a:srgbClr val="F8FAFC"/>
+                  <a:srgbClr val="F1F5F9"/>
                 </a:solidFill>
               </a:defRPr>
             </a:pPr>
@@ -4000,7 +4328,7 @@
         </p:nvSpPr>
         <p:spPr>
           <a:xfrm>
-            <a:off x="731520" y="457200"/>
+            <a:off x="731520" y="365760"/>
             <a:ext cx="10698480" cy="1005840"/>
           </a:xfrm>
           <a:prstGeom prst="rect">
@@ -4017,7 +4345,7 @@
             <a:pPr>
               <a:defRPr sz="2400" b="1">
                 <a:solidFill>
-                  <a:srgbClr val="F8FAFC"/>
+                  <a:srgbClr val="FFFFFF"/>
                 </a:solidFill>
               </a:defRPr>
             </a:pPr>
@@ -4029,7 +4357,7 @@
             <a:pPr>
               <a:defRPr sz="1300">
                 <a:solidFill>
-                  <a:srgbClr val="06B6D4"/>
+                  <a:srgbClr val="38BDF8"/>
                 </a:solidFill>
               </a:defRPr>
             </a:pPr>
@@ -4041,13 +4369,58 @@
       </p:sp>
       <p:sp>
         <p:nvSpPr>
-          <p:cNvPr id="3" name="TextBox 2"/>
+          <p:cNvPr id="3" name="Rounded Rectangle 2"/>
+          <p:cNvSpPr/>
+          <p:nvPr/>
+        </p:nvSpPr>
+        <p:spPr>
+          <a:xfrm>
+            <a:off x="731520" y="1508760"/>
+            <a:ext cx="5212080" cy="868680"/>
+          </a:xfrm>
+          <a:prstGeom prst="roundRect">
+            <a:avLst/>
+          </a:prstGeom>
+          <a:solidFill>
+            <a:srgbClr val="1E293B"/>
+          </a:solidFill>
+          <a:ln w="19050">
+            <a:solidFill>
+              <a:srgbClr val="334155"/>
+            </a:solidFill>
+          </a:ln>
+        </p:spPr>
+        <p:style>
+          <a:lnRef idx="1">
+            <a:schemeClr val="accent1"/>
+          </a:lnRef>
+          <a:fillRef idx="3">
+            <a:schemeClr val="accent1"/>
+          </a:fillRef>
+          <a:effectRef idx="2">
+            <a:schemeClr val="accent1"/>
+          </a:effectRef>
+          <a:fontRef idx="minor">
+            <a:schemeClr val="lt1"/>
+          </a:fontRef>
+        </p:style>
+        <p:txBody>
+          <a:bodyPr rtlCol="0" anchor="ctr"/>
+          <a:lstStyle/>
+          <a:p>
+            <a:pPr algn="ctr"/>
+          </a:p>
+        </p:txBody>
+      </p:sp>
+      <p:sp>
+        <p:nvSpPr>
+          <p:cNvPr id="4" name="TextBox 3"/>
           <p:cNvSpPr txBox="1"/>
           <p:nvPr/>
         </p:nvSpPr>
         <p:spPr>
           <a:xfrm>
-            <a:off x="731520" y="1554480"/>
+            <a:off x="731520" y="1508760"/>
             <a:ext cx="5212080" cy="868680"/>
           </a:xfrm>
           <a:prstGeom prst="rect">
@@ -4064,7 +4437,7 @@
             <a:pPr>
               <a:defRPr sz="1300" b="1">
                 <a:solidFill>
-                  <a:srgbClr val="F8FAFC"/>
+                  <a:srgbClr val="FFFFFF"/>
                 </a:solidFill>
               </a:defRPr>
             </a:pPr>
@@ -4076,7 +4449,7 @@
             <a:pPr>
               <a:defRPr sz="1100">
                 <a:solidFill>
-                  <a:srgbClr val="94A3B8"/>
+                  <a:srgbClr val="F1F5F9"/>
                 </a:solidFill>
               </a:defRPr>
             </a:pPr>
@@ -4088,13 +4461,58 @@
       </p:sp>
       <p:sp>
         <p:nvSpPr>
-          <p:cNvPr id="4" name="TextBox 3"/>
+          <p:cNvPr id="5" name="Rounded Rectangle 4"/>
+          <p:cNvSpPr/>
+          <p:nvPr/>
+        </p:nvSpPr>
+        <p:spPr>
+          <a:xfrm>
+            <a:off x="6126480" y="1508760"/>
+            <a:ext cx="5212080" cy="868680"/>
+          </a:xfrm>
+          <a:prstGeom prst="roundRect">
+            <a:avLst/>
+          </a:prstGeom>
+          <a:solidFill>
+            <a:srgbClr val="1E293B"/>
+          </a:solidFill>
+          <a:ln w="19050">
+            <a:solidFill>
+              <a:srgbClr val="334155"/>
+            </a:solidFill>
+          </a:ln>
+        </p:spPr>
+        <p:style>
+          <a:lnRef idx="1">
+            <a:schemeClr val="accent1"/>
+          </a:lnRef>
+          <a:fillRef idx="3">
+            <a:schemeClr val="accent1"/>
+          </a:fillRef>
+          <a:effectRef idx="2">
+            <a:schemeClr val="accent1"/>
+          </a:effectRef>
+          <a:fontRef idx="minor">
+            <a:schemeClr val="lt1"/>
+          </a:fontRef>
+        </p:style>
+        <p:txBody>
+          <a:bodyPr rtlCol="0" anchor="ctr"/>
+          <a:lstStyle/>
+          <a:p>
+            <a:pPr algn="ctr"/>
+          </a:p>
+        </p:txBody>
+      </p:sp>
+      <p:sp>
+        <p:nvSpPr>
+          <p:cNvPr id="6" name="TextBox 5"/>
           <p:cNvSpPr txBox="1"/>
           <p:nvPr/>
         </p:nvSpPr>
         <p:spPr>
           <a:xfrm>
-            <a:off x="6126480" y="1554480"/>
+            <a:off x="6126480" y="1508760"/>
             <a:ext cx="5212080" cy="868680"/>
           </a:xfrm>
           <a:prstGeom prst="rect">
@@ -4111,7 +4529,7 @@
             <a:pPr>
               <a:defRPr sz="1300" b="1">
                 <a:solidFill>
-                  <a:srgbClr val="F8FAFC"/>
+                  <a:srgbClr val="FFFFFF"/>
                 </a:solidFill>
               </a:defRPr>
             </a:pPr>
@@ -4123,7 +4541,7 @@
             <a:pPr>
               <a:defRPr sz="1100">
                 <a:solidFill>
-                  <a:srgbClr val="94A3B8"/>
+                  <a:srgbClr val="F1F5F9"/>
                 </a:solidFill>
               </a:defRPr>
             </a:pPr>
@@ -4135,13 +4553,58 @@
       </p:sp>
       <p:sp>
         <p:nvSpPr>
-          <p:cNvPr id="5" name="TextBox 4"/>
+          <p:cNvPr id="7" name="Rounded Rectangle 6"/>
+          <p:cNvSpPr/>
+          <p:nvPr/>
+        </p:nvSpPr>
+        <p:spPr>
+          <a:xfrm>
+            <a:off x="731520" y="2468880"/>
+            <a:ext cx="5212080" cy="868680"/>
+          </a:xfrm>
+          <a:prstGeom prst="roundRect">
+            <a:avLst/>
+          </a:prstGeom>
+          <a:solidFill>
+            <a:srgbClr val="1E293B"/>
+          </a:solidFill>
+          <a:ln w="19050">
+            <a:solidFill>
+              <a:srgbClr val="334155"/>
+            </a:solidFill>
+          </a:ln>
+        </p:spPr>
+        <p:style>
+          <a:lnRef idx="1">
+            <a:schemeClr val="accent1"/>
+          </a:lnRef>
+          <a:fillRef idx="3">
+            <a:schemeClr val="accent1"/>
+          </a:fillRef>
+          <a:effectRef idx="2">
+            <a:schemeClr val="accent1"/>
+          </a:effectRef>
+          <a:fontRef idx="minor">
+            <a:schemeClr val="lt1"/>
+          </a:fontRef>
+        </p:style>
+        <p:txBody>
+          <a:bodyPr rtlCol="0" anchor="ctr"/>
+          <a:lstStyle/>
+          <a:p>
+            <a:pPr algn="ctr"/>
+          </a:p>
+        </p:txBody>
+      </p:sp>
+      <p:sp>
+        <p:nvSpPr>
+          <p:cNvPr id="8" name="TextBox 7"/>
           <p:cNvSpPr txBox="1"/>
           <p:nvPr/>
         </p:nvSpPr>
         <p:spPr>
           <a:xfrm>
-            <a:off x="731520" y="2514600"/>
+            <a:off x="731520" y="2468880"/>
             <a:ext cx="5212080" cy="868680"/>
           </a:xfrm>
           <a:prstGeom prst="rect">
@@ -4158,7 +4621,7 @@
             <a:pPr>
               <a:defRPr sz="1300" b="1">
                 <a:solidFill>
-                  <a:srgbClr val="F8FAFC"/>
+                  <a:srgbClr val="FFFFFF"/>
                 </a:solidFill>
               </a:defRPr>
             </a:pPr>
@@ -4170,7 +4633,7 @@
             <a:pPr>
               <a:defRPr sz="1100">
                 <a:solidFill>
-                  <a:srgbClr val="94A3B8"/>
+                  <a:srgbClr val="F1F5F9"/>
                 </a:solidFill>
               </a:defRPr>
             </a:pPr>
@@ -4182,13 +4645,58 @@
       </p:sp>
       <p:sp>
         <p:nvSpPr>
-          <p:cNvPr id="6" name="TextBox 5"/>
+          <p:cNvPr id="9" name="Rounded Rectangle 8"/>
+          <p:cNvSpPr/>
+          <p:nvPr/>
+        </p:nvSpPr>
+        <p:spPr>
+          <a:xfrm>
+            <a:off x="6126480" y="2468880"/>
+            <a:ext cx="5212080" cy="868680"/>
+          </a:xfrm>
+          <a:prstGeom prst="roundRect">
+            <a:avLst/>
+          </a:prstGeom>
+          <a:solidFill>
+            <a:srgbClr val="1E293B"/>
+          </a:solidFill>
+          <a:ln w="19050">
+            <a:solidFill>
+              <a:srgbClr val="334155"/>
+            </a:solidFill>
+          </a:ln>
+        </p:spPr>
+        <p:style>
+          <a:lnRef idx="1">
+            <a:schemeClr val="accent1"/>
+          </a:lnRef>
+          <a:fillRef idx="3">
+            <a:schemeClr val="accent1"/>
+          </a:fillRef>
+          <a:effectRef idx="2">
+            <a:schemeClr val="accent1"/>
+          </a:effectRef>
+          <a:fontRef idx="minor">
+            <a:schemeClr val="lt1"/>
+          </a:fontRef>
+        </p:style>
+        <p:txBody>
+          <a:bodyPr rtlCol="0" anchor="ctr"/>
+          <a:lstStyle/>
+          <a:p>
+            <a:pPr algn="ctr"/>
+          </a:p>
+        </p:txBody>
+      </p:sp>
+      <p:sp>
+        <p:nvSpPr>
+          <p:cNvPr id="10" name="TextBox 9"/>
           <p:cNvSpPr txBox="1"/>
           <p:nvPr/>
         </p:nvSpPr>
         <p:spPr>
           <a:xfrm>
-            <a:off x="6126480" y="2514600"/>
+            <a:off x="6126480" y="2468880"/>
             <a:ext cx="5212080" cy="868680"/>
           </a:xfrm>
           <a:prstGeom prst="rect">
@@ -4205,7 +4713,7 @@
             <a:pPr>
               <a:defRPr sz="1300" b="1">
                 <a:solidFill>
-                  <a:srgbClr val="06B6D4"/>
+                  <a:srgbClr val="38BDF8"/>
                 </a:solidFill>
               </a:defRPr>
             </a:pPr>
@@ -4217,7 +4725,7 @@
             <a:pPr>
               <a:defRPr sz="1100">
                 <a:solidFill>
-                  <a:srgbClr val="94A3B8"/>
+                  <a:srgbClr val="F1F5F9"/>
                 </a:solidFill>
               </a:defRPr>
             </a:pPr>
@@ -4229,13 +4737,58 @@
       </p:sp>
       <p:sp>
         <p:nvSpPr>
-          <p:cNvPr id="7" name="TextBox 6"/>
+          <p:cNvPr id="11" name="Rounded Rectangle 10"/>
+          <p:cNvSpPr/>
+          <p:nvPr/>
+        </p:nvSpPr>
+        <p:spPr>
+          <a:xfrm>
+            <a:off x="731520" y="3429000"/>
+            <a:ext cx="5212080" cy="868680"/>
+          </a:xfrm>
+          <a:prstGeom prst="roundRect">
+            <a:avLst/>
+          </a:prstGeom>
+          <a:solidFill>
+            <a:srgbClr val="1E293B"/>
+          </a:solidFill>
+          <a:ln w="19050">
+            <a:solidFill>
+              <a:srgbClr val="334155"/>
+            </a:solidFill>
+          </a:ln>
+        </p:spPr>
+        <p:style>
+          <a:lnRef idx="1">
+            <a:schemeClr val="accent1"/>
+          </a:lnRef>
+          <a:fillRef idx="3">
+            <a:schemeClr val="accent1"/>
+          </a:fillRef>
+          <a:effectRef idx="2">
+            <a:schemeClr val="accent1"/>
+          </a:effectRef>
+          <a:fontRef idx="minor">
+            <a:schemeClr val="lt1"/>
+          </a:fontRef>
+        </p:style>
+        <p:txBody>
+          <a:bodyPr rtlCol="0" anchor="ctr"/>
+          <a:lstStyle/>
+          <a:p>
+            <a:pPr algn="ctr"/>
+          </a:p>
+        </p:txBody>
+      </p:sp>
+      <p:sp>
+        <p:nvSpPr>
+          <p:cNvPr id="12" name="TextBox 11"/>
           <p:cNvSpPr txBox="1"/>
           <p:nvPr/>
         </p:nvSpPr>
         <p:spPr>
           <a:xfrm>
-            <a:off x="731520" y="3474720"/>
+            <a:off x="731520" y="3429000"/>
             <a:ext cx="5212080" cy="868680"/>
           </a:xfrm>
           <a:prstGeom prst="rect">
@@ -4252,7 +4805,7 @@
             <a:pPr>
               <a:defRPr sz="1300" b="1">
                 <a:solidFill>
-                  <a:srgbClr val="F8FAFC"/>
+                  <a:srgbClr val="FFFFFF"/>
                 </a:solidFill>
               </a:defRPr>
             </a:pPr>
@@ -4264,7 +4817,7 @@
             <a:pPr>
               <a:defRPr sz="1100">
                 <a:solidFill>
-                  <a:srgbClr val="94A3B8"/>
+                  <a:srgbClr val="F1F5F9"/>
                 </a:solidFill>
               </a:defRPr>
             </a:pPr>
@@ -4276,13 +4829,58 @@
       </p:sp>
       <p:sp>
         <p:nvSpPr>
-          <p:cNvPr id="8" name="TextBox 7"/>
+          <p:cNvPr id="13" name="Rounded Rectangle 12"/>
+          <p:cNvSpPr/>
+          <p:nvPr/>
+        </p:nvSpPr>
+        <p:spPr>
+          <a:xfrm>
+            <a:off x="6126480" y="3429000"/>
+            <a:ext cx="5212080" cy="868680"/>
+          </a:xfrm>
+          <a:prstGeom prst="roundRect">
+            <a:avLst/>
+          </a:prstGeom>
+          <a:solidFill>
+            <a:srgbClr val="1E293B"/>
+          </a:solidFill>
+          <a:ln w="19050">
+            <a:solidFill>
+              <a:srgbClr val="334155"/>
+            </a:solidFill>
+          </a:ln>
+        </p:spPr>
+        <p:style>
+          <a:lnRef idx="1">
+            <a:schemeClr val="accent1"/>
+          </a:lnRef>
+          <a:fillRef idx="3">
+            <a:schemeClr val="accent1"/>
+          </a:fillRef>
+          <a:effectRef idx="2">
+            <a:schemeClr val="accent1"/>
+          </a:effectRef>
+          <a:fontRef idx="minor">
+            <a:schemeClr val="lt1"/>
+          </a:fontRef>
+        </p:style>
+        <p:txBody>
+          <a:bodyPr rtlCol="0" anchor="ctr"/>
+          <a:lstStyle/>
+          <a:p>
+            <a:pPr algn="ctr"/>
+          </a:p>
+        </p:txBody>
+      </p:sp>
+      <p:sp>
+        <p:nvSpPr>
+          <p:cNvPr id="14" name="TextBox 13"/>
           <p:cNvSpPr txBox="1"/>
           <p:nvPr/>
         </p:nvSpPr>
         <p:spPr>
           <a:xfrm>
-            <a:off x="6126480" y="3474720"/>
+            <a:off x="6126480" y="3429000"/>
             <a:ext cx="5212080" cy="868680"/>
           </a:xfrm>
           <a:prstGeom prst="rect">
@@ -4299,7 +4897,7 @@
             <a:pPr>
               <a:defRPr sz="1300" b="1">
                 <a:solidFill>
-                  <a:srgbClr val="F8FAFC"/>
+                  <a:srgbClr val="FFFFFF"/>
                 </a:solidFill>
               </a:defRPr>
             </a:pPr>
@@ -4311,7 +4909,7 @@
             <a:pPr>
               <a:defRPr sz="1100">
                 <a:solidFill>
-                  <a:srgbClr val="94A3B8"/>
+                  <a:srgbClr val="F1F5F9"/>
                 </a:solidFill>
               </a:defRPr>
             </a:pPr>
@@ -4323,13 +4921,58 @@
       </p:sp>
       <p:sp>
         <p:nvSpPr>
-          <p:cNvPr id="9" name="TextBox 8"/>
+          <p:cNvPr id="15" name="Rounded Rectangle 14"/>
+          <p:cNvSpPr/>
+          <p:nvPr/>
+        </p:nvSpPr>
+        <p:spPr>
+          <a:xfrm>
+            <a:off x="731520" y="4389120"/>
+            <a:ext cx="5212080" cy="868680"/>
+          </a:xfrm>
+          <a:prstGeom prst="roundRect">
+            <a:avLst/>
+          </a:prstGeom>
+          <a:solidFill>
+            <a:srgbClr val="1E293B"/>
+          </a:solidFill>
+          <a:ln w="19050">
+            <a:solidFill>
+              <a:srgbClr val="334155"/>
+            </a:solidFill>
+          </a:ln>
+        </p:spPr>
+        <p:style>
+          <a:lnRef idx="1">
+            <a:schemeClr val="accent1"/>
+          </a:lnRef>
+          <a:fillRef idx="3">
+            <a:schemeClr val="accent1"/>
+          </a:fillRef>
+          <a:effectRef idx="2">
+            <a:schemeClr val="accent1"/>
+          </a:effectRef>
+          <a:fontRef idx="minor">
+            <a:schemeClr val="lt1"/>
+          </a:fontRef>
+        </p:style>
+        <p:txBody>
+          <a:bodyPr rtlCol="0" anchor="ctr"/>
+          <a:lstStyle/>
+          <a:p>
+            <a:pPr algn="ctr"/>
+          </a:p>
+        </p:txBody>
+      </p:sp>
+      <p:sp>
+        <p:nvSpPr>
+          <p:cNvPr id="16" name="TextBox 15"/>
           <p:cNvSpPr txBox="1"/>
           <p:nvPr/>
         </p:nvSpPr>
         <p:spPr>
           <a:xfrm>
-            <a:off x="731520" y="4434840"/>
+            <a:off x="731520" y="4389120"/>
             <a:ext cx="5212080" cy="868680"/>
           </a:xfrm>
           <a:prstGeom prst="rect">
@@ -4346,7 +4989,7 @@
             <a:pPr>
               <a:defRPr sz="1300" b="1">
                 <a:solidFill>
-                  <a:srgbClr val="F8FAFC"/>
+                  <a:srgbClr val="FFFFFF"/>
                 </a:solidFill>
               </a:defRPr>
             </a:pPr>
@@ -4358,7 +5001,7 @@
             <a:pPr>
               <a:defRPr sz="1100">
                 <a:solidFill>
-                  <a:srgbClr val="94A3B8"/>
+                  <a:srgbClr val="F1F5F9"/>
                 </a:solidFill>
               </a:defRPr>
             </a:pPr>
@@ -4370,13 +5013,58 @@
       </p:sp>
       <p:sp>
         <p:nvSpPr>
-          <p:cNvPr id="10" name="TextBox 9"/>
+          <p:cNvPr id="17" name="Rounded Rectangle 16"/>
+          <p:cNvSpPr/>
+          <p:nvPr/>
+        </p:nvSpPr>
+        <p:spPr>
+          <a:xfrm>
+            <a:off x="6126480" y="4389120"/>
+            <a:ext cx="5212080" cy="868680"/>
+          </a:xfrm>
+          <a:prstGeom prst="roundRect">
+            <a:avLst/>
+          </a:prstGeom>
+          <a:solidFill>
+            <a:srgbClr val="1E293B"/>
+          </a:solidFill>
+          <a:ln w="19050">
+            <a:solidFill>
+              <a:srgbClr val="334155"/>
+            </a:solidFill>
+          </a:ln>
+        </p:spPr>
+        <p:style>
+          <a:lnRef idx="1">
+            <a:schemeClr val="accent1"/>
+          </a:lnRef>
+          <a:fillRef idx="3">
+            <a:schemeClr val="accent1"/>
+          </a:fillRef>
+          <a:effectRef idx="2">
+            <a:schemeClr val="accent1"/>
+          </a:effectRef>
+          <a:fontRef idx="minor">
+            <a:schemeClr val="lt1"/>
+          </a:fontRef>
+        </p:style>
+        <p:txBody>
+          <a:bodyPr rtlCol="0" anchor="ctr"/>
+          <a:lstStyle/>
+          <a:p>
+            <a:pPr algn="ctr"/>
+          </a:p>
+        </p:txBody>
+      </p:sp>
+      <p:sp>
+        <p:nvSpPr>
+          <p:cNvPr id="18" name="TextBox 17"/>
           <p:cNvSpPr txBox="1"/>
           <p:nvPr/>
         </p:nvSpPr>
         <p:spPr>
           <a:xfrm>
-            <a:off x="6126480" y="4434840"/>
+            <a:off x="6126480" y="4389120"/>
             <a:ext cx="5212080" cy="868680"/>
           </a:xfrm>
           <a:prstGeom prst="rect">
@@ -4393,7 +5081,7 @@
             <a:pPr>
               <a:defRPr sz="1300" b="1">
                 <a:solidFill>
-                  <a:srgbClr val="F8FAFC"/>
+                  <a:srgbClr val="FFFFFF"/>
                 </a:solidFill>
               </a:defRPr>
             </a:pPr>
@@ -4405,7 +5093,7 @@
             <a:pPr>
               <a:defRPr sz="1100">
                 <a:solidFill>
-                  <a:srgbClr val="94A3B8"/>
+                  <a:srgbClr val="F1F5F9"/>
                 </a:solidFill>
               </a:defRPr>
             </a:pPr>
@@ -4417,13 +5105,58 @@
       </p:sp>
       <p:sp>
         <p:nvSpPr>
-          <p:cNvPr id="11" name="TextBox 10"/>
+          <p:cNvPr id="19" name="Rounded Rectangle 18"/>
+          <p:cNvSpPr/>
+          <p:nvPr/>
+        </p:nvSpPr>
+        <p:spPr>
+          <a:xfrm>
+            <a:off x="731520" y="5349240"/>
+            <a:ext cx="5212080" cy="868680"/>
+          </a:xfrm>
+          <a:prstGeom prst="roundRect">
+            <a:avLst/>
+          </a:prstGeom>
+          <a:solidFill>
+            <a:srgbClr val="1E293B"/>
+          </a:solidFill>
+          <a:ln w="19050">
+            <a:solidFill>
+              <a:srgbClr val="334155"/>
+            </a:solidFill>
+          </a:ln>
+        </p:spPr>
+        <p:style>
+          <a:lnRef idx="1">
+            <a:schemeClr val="accent1"/>
+          </a:lnRef>
+          <a:fillRef idx="3">
+            <a:schemeClr val="accent1"/>
+          </a:fillRef>
+          <a:effectRef idx="2">
+            <a:schemeClr val="accent1"/>
+          </a:effectRef>
+          <a:fontRef idx="minor">
+            <a:schemeClr val="lt1"/>
+          </a:fontRef>
+        </p:style>
+        <p:txBody>
+          <a:bodyPr rtlCol="0" anchor="ctr"/>
+          <a:lstStyle/>
+          <a:p>
+            <a:pPr algn="ctr"/>
+          </a:p>
+        </p:txBody>
+      </p:sp>
+      <p:sp>
+        <p:nvSpPr>
+          <p:cNvPr id="20" name="TextBox 19"/>
           <p:cNvSpPr txBox="1"/>
           <p:nvPr/>
         </p:nvSpPr>
         <p:spPr>
           <a:xfrm>
-            <a:off x="731520" y="5394960"/>
+            <a:off x="731520" y="5349240"/>
             <a:ext cx="5212080" cy="868680"/>
           </a:xfrm>
           <a:prstGeom prst="rect">
@@ -4440,7 +5173,7 @@
             <a:pPr>
               <a:defRPr sz="1300" b="1">
                 <a:solidFill>
-                  <a:srgbClr val="F8FAFC"/>
+                  <a:srgbClr val="FFFFFF"/>
                 </a:solidFill>
               </a:defRPr>
             </a:pPr>
@@ -4452,7 +5185,7 @@
             <a:pPr>
               <a:defRPr sz="1100">
                 <a:solidFill>
-                  <a:srgbClr val="94A3B8"/>
+                  <a:srgbClr val="F1F5F9"/>
                 </a:solidFill>
               </a:defRPr>
             </a:pPr>
@@ -4464,13 +5197,58 @@
       </p:sp>
       <p:sp>
         <p:nvSpPr>
-          <p:cNvPr id="12" name="TextBox 11"/>
+          <p:cNvPr id="21" name="Rounded Rectangle 20"/>
+          <p:cNvSpPr/>
+          <p:nvPr/>
+        </p:nvSpPr>
+        <p:spPr>
+          <a:xfrm>
+            <a:off x="6126480" y="5349240"/>
+            <a:ext cx="5212080" cy="868680"/>
+          </a:xfrm>
+          <a:prstGeom prst="roundRect">
+            <a:avLst/>
+          </a:prstGeom>
+          <a:solidFill>
+            <a:srgbClr val="1E293B"/>
+          </a:solidFill>
+          <a:ln w="19050">
+            <a:solidFill>
+              <a:srgbClr val="334155"/>
+            </a:solidFill>
+          </a:ln>
+        </p:spPr>
+        <p:style>
+          <a:lnRef idx="1">
+            <a:schemeClr val="accent1"/>
+          </a:lnRef>
+          <a:fillRef idx="3">
+            <a:schemeClr val="accent1"/>
+          </a:fillRef>
+          <a:effectRef idx="2">
+            <a:schemeClr val="accent1"/>
+          </a:effectRef>
+          <a:fontRef idx="minor">
+            <a:schemeClr val="lt1"/>
+          </a:fontRef>
+        </p:style>
+        <p:txBody>
+          <a:bodyPr rtlCol="0" anchor="ctr"/>
+          <a:lstStyle/>
+          <a:p>
+            <a:pPr algn="ctr"/>
+          </a:p>
+        </p:txBody>
+      </p:sp>
+      <p:sp>
+        <p:nvSpPr>
+          <p:cNvPr id="22" name="TextBox 21"/>
           <p:cNvSpPr txBox="1"/>
           <p:nvPr/>
         </p:nvSpPr>
         <p:spPr>
           <a:xfrm>
-            <a:off x="6126480" y="5394960"/>
+            <a:off x="6126480" y="5349240"/>
             <a:ext cx="5212080" cy="868680"/>
           </a:xfrm>
           <a:prstGeom prst="rect">
@@ -4487,7 +5265,7 @@
             <a:pPr>
               <a:defRPr sz="1300" b="1">
                 <a:solidFill>
-                  <a:srgbClr val="F8FAFC"/>
+                  <a:srgbClr val="FFFFFF"/>
                 </a:solidFill>
               </a:defRPr>
             </a:pPr>
@@ -4499,7 +5277,7 @@
             <a:pPr>
               <a:defRPr sz="1100">
                 <a:solidFill>
-                  <a:srgbClr val="94A3B8"/>
+                  <a:srgbClr val="F1F5F9"/>
                 </a:solidFill>
               </a:defRPr>
             </a:pPr>
@@ -4543,7 +5321,7 @@
         </p:nvSpPr>
         <p:spPr>
           <a:xfrm>
-            <a:off x="731520" y="457200"/>
+            <a:off x="731520" y="365760"/>
             <a:ext cx="10698480" cy="1005840"/>
           </a:xfrm>
           <a:prstGeom prst="rect">
@@ -4560,7 +5338,7 @@
             <a:pPr>
               <a:defRPr sz="2400" b="1">
                 <a:solidFill>
-                  <a:srgbClr val="F8FAFC"/>
+                  <a:srgbClr val="FFFFFF"/>
                 </a:solidFill>
               </a:defRPr>
             </a:pPr>
@@ -4572,7 +5350,7 @@
             <a:pPr>
               <a:defRPr sz="1300">
                 <a:solidFill>
-                  <a:srgbClr val="06B6D4"/>
+                  <a:srgbClr val="38BDF8"/>
                 </a:solidFill>
               </a:defRPr>
             </a:pPr>
@@ -4584,14 +5362,59 @@
       </p:sp>
       <p:sp>
         <p:nvSpPr>
-          <p:cNvPr id="3" name="TextBox 2"/>
+          <p:cNvPr id="3" name="Rounded Rectangle 2"/>
+          <p:cNvSpPr/>
+          <p:nvPr/>
+        </p:nvSpPr>
+        <p:spPr>
+          <a:xfrm>
+            <a:off x="731520" y="1554480"/>
+            <a:ext cx="5212080" cy="4754880"/>
+          </a:xfrm>
+          <a:prstGeom prst="roundRect">
+            <a:avLst/>
+          </a:prstGeom>
+          <a:solidFill>
+            <a:srgbClr val="1E293B"/>
+          </a:solidFill>
+          <a:ln w="19050">
+            <a:solidFill>
+              <a:srgbClr val="334155"/>
+            </a:solidFill>
+          </a:ln>
+        </p:spPr>
+        <p:style>
+          <a:lnRef idx="1">
+            <a:schemeClr val="accent1"/>
+          </a:lnRef>
+          <a:fillRef idx="3">
+            <a:schemeClr val="accent1"/>
+          </a:fillRef>
+          <a:effectRef idx="2">
+            <a:schemeClr val="accent1"/>
+          </a:effectRef>
+          <a:fontRef idx="minor">
+            <a:schemeClr val="lt1"/>
+          </a:fontRef>
+        </p:style>
+        <p:txBody>
+          <a:bodyPr rtlCol="0" anchor="ctr"/>
+          <a:lstStyle/>
+          <a:p>
+            <a:pPr algn="ctr"/>
+          </a:p>
+        </p:txBody>
+      </p:sp>
+      <p:sp>
+        <p:nvSpPr>
+          <p:cNvPr id="4" name="TextBox 3"/>
           <p:cNvSpPr txBox="1"/>
           <p:nvPr/>
         </p:nvSpPr>
         <p:spPr>
           <a:xfrm>
-            <a:off x="731520" y="1645920"/>
-            <a:ext cx="5212080" cy="4572000"/>
+            <a:off x="731520" y="1554480"/>
+            <a:ext cx="5212080" cy="4754880"/>
           </a:xfrm>
           <a:prstGeom prst="rect">
             <a:avLst/>
@@ -4607,7 +5430,7 @@
             <a:pPr>
               <a:defRPr sz="1800" b="1">
                 <a:solidFill>
-                  <a:srgbClr val="10B981"/>
+                  <a:srgbClr val="34D399"/>
                 </a:solidFill>
               </a:defRPr>
             </a:pPr>
@@ -4620,7 +5443,7 @@
             <a:pPr>
               <a:defRPr sz="1300">
                 <a:solidFill>
-                  <a:srgbClr val="F8FAFC"/>
+                  <a:srgbClr val="F1F5F9"/>
                 </a:solidFill>
               </a:defRPr>
             </a:pPr>
@@ -4628,14 +5451,17 @@
               <a:t>• Strict AI Requirement: The person counter displays '0 Persons' when no human is present in frame.</a:t>
             </a:r>
             <a:br/>
+            <a:br/>
             <a:r>
               <a:t>• Heuristic &amp; Dummy Fallbacks Removed: Completely eliminated '|| 1' fallbacks, fake tracking IDs, or simulated persons.</a:t>
             </a:r>
             <a:br/>
+            <a:br/>
             <a:r>
               <a:t>• Direct AI Driver: Person counts are 100% driven by TensorFlow.js COCO-SSD prediction score &gt;= minConfidence (0.35).</a:t>
             </a:r>
             <a:br/>
+            <a:br/>
             <a:r>
               <a:t>• Clear Reset State: When 0 persons are detected, active tracks and phone misuse states automatically reset.</a:t>
             </a:r>
@@ -4644,14 +5470,59 @@
       </p:sp>
       <p:sp>
         <p:nvSpPr>
-          <p:cNvPr id="4" name="TextBox 3"/>
+          <p:cNvPr id="5" name="Rounded Rectangle 4"/>
+          <p:cNvSpPr/>
+          <p:nvPr/>
+        </p:nvSpPr>
+        <p:spPr>
+          <a:xfrm>
+            <a:off x="6217920" y="1554480"/>
+            <a:ext cx="5212080" cy="4754880"/>
+          </a:xfrm>
+          <a:prstGeom prst="roundRect">
+            <a:avLst/>
+          </a:prstGeom>
+          <a:solidFill>
+            <a:srgbClr val="1E293B"/>
+          </a:solidFill>
+          <a:ln w="19050">
+            <a:solidFill>
+              <a:srgbClr val="334155"/>
+            </a:solidFill>
+          </a:ln>
+        </p:spPr>
+        <p:style>
+          <a:lnRef idx="1">
+            <a:schemeClr val="accent1"/>
+          </a:lnRef>
+          <a:fillRef idx="3">
+            <a:schemeClr val="accent1"/>
+          </a:fillRef>
+          <a:effectRef idx="2">
+            <a:schemeClr val="accent1"/>
+          </a:effectRef>
+          <a:fontRef idx="minor">
+            <a:schemeClr val="lt1"/>
+          </a:fontRef>
+        </p:style>
+        <p:txBody>
+          <a:bodyPr rtlCol="0" anchor="ctr"/>
+          <a:lstStyle/>
+          <a:p>
+            <a:pPr algn="ctr"/>
+          </a:p>
+        </p:txBody>
+      </p:sp>
+      <p:sp>
+        <p:nvSpPr>
+          <p:cNvPr id="6" name="TextBox 5"/>
           <p:cNvSpPr txBox="1"/>
           <p:nvPr/>
         </p:nvSpPr>
         <p:spPr>
           <a:xfrm>
-            <a:off x="6217920" y="1645920"/>
-            <a:ext cx="5212080" cy="4572000"/>
+            <a:off x="6217920" y="1554480"/>
+            <a:ext cx="5212080" cy="4754880"/>
           </a:xfrm>
           <a:prstGeom prst="rect">
             <a:avLst/>
@@ -4667,7 +5538,7 @@
             <a:pPr>
               <a:defRPr sz="1800" b="1">
                 <a:solidFill>
-                  <a:srgbClr val="06B6D4"/>
+                  <a:srgbClr val="38BDF8"/>
                 </a:solidFill>
               </a:defRPr>
             </a:pPr>
@@ -4680,7 +5551,7 @@
             <a:pPr>
               <a:defRPr sz="1300">
                 <a:solidFill>
-                  <a:srgbClr val="F8FAFC"/>
+                  <a:srgbClr val="F1F5F9"/>
                 </a:solidFill>
               </a:defRPr>
             </a:pPr>
@@ -4688,13 +5559,16 @@
               <a:t>• Track ID Assignment: Generates unique persistent track IDs (TRK-P101, TRK-P102, etc.) for each detected worker.</a:t>
             </a:r>
             <a:br/>
+            <a:br/>
             <a:r>
               <a:t>• Centroid Distance Matching: Matches bounding box centers across frames with max distance tolerance 0.25.</a:t>
             </a:r>
             <a:br/>
+            <a:br/>
             <a:r>
               <a:t>• Track Disappearance Memory: Active tracks are maintained for 3000ms before expiration if momentarily occluded.</a:t>
             </a:r>
+            <a:br/>
             <a:br/>
             <a:r>
               <a:t>• State Synchronization: Links per-worker helmet verification and mobile phone misuse escalation states.</a:t>
@@ -4736,7 +5610,7 @@
         </p:nvSpPr>
         <p:spPr>
           <a:xfrm>
-            <a:off x="731520" y="457200"/>
+            <a:off x="731520" y="365760"/>
             <a:ext cx="10698480" cy="1005840"/>
           </a:xfrm>
           <a:prstGeom prst="rect">
@@ -4753,7 +5627,7 @@
             <a:pPr>
               <a:defRPr sz="2400" b="1">
                 <a:solidFill>
-                  <a:srgbClr val="F8FAFC"/>
+                  <a:srgbClr val="FFFFFF"/>
                 </a:solidFill>
               </a:defRPr>
             </a:pPr>
@@ -4765,7 +5639,7 @@
             <a:pPr>
               <a:defRPr sz="1300">
                 <a:solidFill>
-                  <a:srgbClr val="06B6D4"/>
+                  <a:srgbClr val="38BDF8"/>
                 </a:solidFill>
               </a:defRPr>
             </a:pPr>
@@ -4777,14 +5651,59 @@
       </p:sp>
       <p:sp>
         <p:nvSpPr>
-          <p:cNvPr id="3" name="TextBox 2"/>
+          <p:cNvPr id="3" name="Rounded Rectangle 2"/>
+          <p:cNvSpPr/>
+          <p:nvPr/>
+        </p:nvSpPr>
+        <p:spPr>
+          <a:xfrm>
+            <a:off x="731520" y="1554480"/>
+            <a:ext cx="5212080" cy="4754880"/>
+          </a:xfrm>
+          <a:prstGeom prst="roundRect">
+            <a:avLst/>
+          </a:prstGeom>
+          <a:solidFill>
+            <a:srgbClr val="1E293B"/>
+          </a:solidFill>
+          <a:ln w="19050">
+            <a:solidFill>
+              <a:srgbClr val="334155"/>
+            </a:solidFill>
+          </a:ln>
+        </p:spPr>
+        <p:style>
+          <a:lnRef idx="1">
+            <a:schemeClr val="accent1"/>
+          </a:lnRef>
+          <a:fillRef idx="3">
+            <a:schemeClr val="accent1"/>
+          </a:fillRef>
+          <a:effectRef idx="2">
+            <a:schemeClr val="accent1"/>
+          </a:effectRef>
+          <a:fontRef idx="minor">
+            <a:schemeClr val="lt1"/>
+          </a:fontRef>
+        </p:style>
+        <p:txBody>
+          <a:bodyPr rtlCol="0" anchor="ctr"/>
+          <a:lstStyle/>
+          <a:p>
+            <a:pPr algn="ctr"/>
+          </a:p>
+        </p:txBody>
+      </p:sp>
+      <p:sp>
+        <p:nvSpPr>
+          <p:cNvPr id="4" name="TextBox 3"/>
           <p:cNvSpPr txBox="1"/>
           <p:nvPr/>
         </p:nvSpPr>
         <p:spPr>
           <a:xfrm>
-            <a:off x="731520" y="1645920"/>
-            <a:ext cx="5212080" cy="4572000"/>
+            <a:off x="731520" y="1554480"/>
+            <a:ext cx="5212080" cy="4754880"/>
           </a:xfrm>
           <a:prstGeom prst="rect">
             <a:avLst/>
@@ -4800,7 +5719,7 @@
             <a:pPr>
               <a:defRPr sz="1800" b="1">
                 <a:solidFill>
-                  <a:srgbClr val="F59E0B"/>
+                  <a:srgbClr val="FBBF24"/>
                 </a:solidFill>
               </a:defRPr>
             </a:pPr>
@@ -4813,7 +5732,7 @@
             <a:pPr>
               <a:defRPr sz="1300">
                 <a:solidFill>
-                  <a:srgbClr val="F8FAFC"/>
+                  <a:srgbClr val="F1F5F9"/>
                 </a:solidFill>
               </a:defRPr>
             </a:pPr>
@@ -4821,14 +5740,17 @@
               <a:t>1. Pass 1 (Full Frame): COCO-SSD runs at low internal threshold (0.15) to capture initial phone candidates.</a:t>
             </a:r>
             <a:br/>
+            <a:br/>
             <a:r>
               <a:t>2. Pass 2 (Enlarged Upper-Body ROI): For each detected person, head, ears, face, chest &amp; hands region (+20% margins) is cropped, upscaled to 360x360 offscreen canvas, and re-inspected.</a:t>
             </a:r>
             <a:br/>
+            <a:br/>
             <a:r>
               <a:t>3. Coordinate Re-mapping: ROI phone bounding boxes are scaled back into full-frame pixel coordinates.</a:t>
             </a:r>
             <a:br/>
+            <a:br/>
             <a:r>
               <a:t>4. IoU Deduplication: Merges overlapping detections (&gt;0.30 IoU) into a clean combined detection list.</a:t>
             </a:r>
@@ -4837,14 +5759,59 @@
       </p:sp>
       <p:sp>
         <p:nvSpPr>
-          <p:cNvPr id="4" name="TextBox 3"/>
+          <p:cNvPr id="5" name="Rounded Rectangle 4"/>
+          <p:cNvSpPr/>
+          <p:nvPr/>
+        </p:nvSpPr>
+        <p:spPr>
+          <a:xfrm>
+            <a:off x="6217920" y="1554480"/>
+            <a:ext cx="5212080" cy="4754880"/>
+          </a:xfrm>
+          <a:prstGeom prst="roundRect">
+            <a:avLst/>
+          </a:prstGeom>
+          <a:solidFill>
+            <a:srgbClr val="1E293B"/>
+          </a:solidFill>
+          <a:ln w="19050">
+            <a:solidFill>
+              <a:srgbClr val="334155"/>
+            </a:solidFill>
+          </a:ln>
+        </p:spPr>
+        <p:style>
+          <a:lnRef idx="1">
+            <a:schemeClr val="accent1"/>
+          </a:lnRef>
+          <a:fillRef idx="3">
+            <a:schemeClr val="accent1"/>
+          </a:fillRef>
+          <a:effectRef idx="2">
+            <a:schemeClr val="accent1"/>
+          </a:effectRef>
+          <a:fontRef idx="minor">
+            <a:schemeClr val="lt1"/>
+          </a:fontRef>
+        </p:style>
+        <p:txBody>
+          <a:bodyPr rtlCol="0" anchor="ctr"/>
+          <a:lstStyle/>
+          <a:p>
+            <a:pPr algn="ctr"/>
+          </a:p>
+        </p:txBody>
+      </p:sp>
+      <p:sp>
+        <p:nvSpPr>
+          <p:cNvPr id="6" name="TextBox 5"/>
           <p:cNvSpPr txBox="1"/>
           <p:nvPr/>
         </p:nvSpPr>
         <p:spPr>
           <a:xfrm>
-            <a:off x="6217920" y="1645920"/>
-            <a:ext cx="5212080" cy="4572000"/>
+            <a:off x="6217920" y="1554480"/>
+            <a:ext cx="5212080" cy="4754880"/>
           </a:xfrm>
           <a:prstGeom prst="rect">
             <a:avLst/>
@@ -4860,7 +5827,7 @@
             <a:pPr>
               <a:defRPr sz="1800" b="1">
                 <a:solidFill>
-                  <a:srgbClr val="EF4444"/>
+                  <a:srgbClr val="F87171"/>
                 </a:solidFill>
               </a:defRPr>
             </a:pPr>
@@ -4873,7 +5840,7 @@
             <a:pPr>
               <a:defRPr sz="1300">
                 <a:solidFill>
-                  <a:srgbClr val="F8FAFC"/>
+                  <a:srgbClr val="F1F5F9"/>
                 </a:solidFill>
               </a:defRPr>
             </a:pPr>
@@ -4881,9 +5848,11 @@
               <a:t>• Spatial Upper-Body Association: Associates phones with nearest person's upper body (max distance = height * 0.70).</a:t>
             </a:r>
             <a:br/>
+            <a:br/>
             <a:r>
               <a:t>• Persistence &amp; Grace Frames: Requires 3 consecutive persistence frames + 3 miss grace frames to filter noise.</a:t>
             </a:r>
+            <a:br/>
             <a:br/>
             <a:r>
               <a:t>• Escalation Levels:</a:t>
@@ -4937,7 +5906,7 @@
         </p:nvSpPr>
         <p:spPr>
           <a:xfrm>
-            <a:off x="731520" y="457200"/>
+            <a:off x="731520" y="365760"/>
             <a:ext cx="10698480" cy="1005840"/>
           </a:xfrm>
           <a:prstGeom prst="rect">
@@ -4954,7 +5923,7 @@
             <a:pPr>
               <a:defRPr sz="2400" b="1">
                 <a:solidFill>
-                  <a:srgbClr val="F8FAFC"/>
+                  <a:srgbClr val="FFFFFF"/>
                 </a:solidFill>
               </a:defRPr>
             </a:pPr>
@@ -4966,7 +5935,7 @@
             <a:pPr>
               <a:defRPr sz="1300">
                 <a:solidFill>
-                  <a:srgbClr val="06B6D4"/>
+                  <a:srgbClr val="38BDF8"/>
                 </a:solidFill>
               </a:defRPr>
             </a:pPr>
@@ -4978,14 +5947,59 @@
       </p:sp>
       <p:sp>
         <p:nvSpPr>
-          <p:cNvPr id="3" name="TextBox 2"/>
+          <p:cNvPr id="3" name="Rounded Rectangle 2"/>
+          <p:cNvSpPr/>
+          <p:nvPr/>
+        </p:nvSpPr>
+        <p:spPr>
+          <a:xfrm>
+            <a:off x="731520" y="1554480"/>
+            <a:ext cx="10698480" cy="4754880"/>
+          </a:xfrm>
+          <a:prstGeom prst="roundRect">
+            <a:avLst/>
+          </a:prstGeom>
+          <a:solidFill>
+            <a:srgbClr val="1E293B"/>
+          </a:solidFill>
+          <a:ln w="19050">
+            <a:solidFill>
+              <a:srgbClr val="334155"/>
+            </a:solidFill>
+          </a:ln>
+        </p:spPr>
+        <p:style>
+          <a:lnRef idx="1">
+            <a:schemeClr val="accent1"/>
+          </a:lnRef>
+          <a:fillRef idx="3">
+            <a:schemeClr val="accent1"/>
+          </a:fillRef>
+          <a:effectRef idx="2">
+            <a:schemeClr val="accent1"/>
+          </a:effectRef>
+          <a:fontRef idx="minor">
+            <a:schemeClr val="lt1"/>
+          </a:fontRef>
+        </p:style>
+        <p:txBody>
+          <a:bodyPr rtlCol="0" anchor="ctr"/>
+          <a:lstStyle/>
+          <a:p>
+            <a:pPr algn="ctr"/>
+          </a:p>
+        </p:txBody>
+      </p:sp>
+      <p:sp>
+        <p:nvSpPr>
+          <p:cNvPr id="4" name="TextBox 3"/>
           <p:cNvSpPr txBox="1"/>
           <p:nvPr/>
         </p:nvSpPr>
         <p:spPr>
           <a:xfrm>
-            <a:off x="731520" y="1645920"/>
-            <a:ext cx="10698480" cy="4572000"/>
+            <a:off x="731520" y="1554480"/>
+            <a:ext cx="10698480" cy="4754880"/>
           </a:xfrm>
           <a:prstGeom prst="rect">
             <a:avLst/>
@@ -5001,7 +6015,7 @@
             <a:pPr>
               <a:defRPr sz="1800" b="1">
                 <a:solidFill>
-                  <a:srgbClr val="10B981"/>
+                  <a:srgbClr val="34D399"/>
                 </a:solidFill>
               </a:defRPr>
             </a:pPr>
@@ -5014,7 +6028,7 @@
             <a:pPr>
               <a:defRPr sz="1300">
                 <a:solidFill>
-                  <a:srgbClr val="F8FAFC"/>
+                  <a:srgbClr val="F1F5F9"/>
                 </a:solidFill>
               </a:defRPr>
             </a:pPr>
@@ -5022,17 +6036,21 @@
               <a:t>• Head Crop Tensor Preprocessing: Extracts top 25% head ROI from person bounding box, converts to RGB tensor, resizes to 224x224, and normalizes pixel values [0, 1].</a:t>
             </a:r>
             <a:br/>
+            <a:br/>
             <a:r>
               <a:t>• Dedicated Model Handler (detectHelmetForPerson): Asynchronously loads custom trained TFJS model (/models/helmet/model.json).</a:t>
             </a:r>
             <a:br/>
+            <a:br/>
             <a:r>
               <a:t>• Strict Conservative Safety Rule: If custom model files are unsupplied, model fails to load, or score &lt; HELMET_CONFIDENCE_THRESHOLD (0.65), system strictly defaults to hasHelmet: false with clear reason ('Dedicated ML model files unsupplied').</a:t>
             </a:r>
             <a:br/>
+            <a:br/>
             <a:r>
               <a:t>• Explicit Tensor Memory Disposal: Executes tf.dispose([cropTensor, resizedTensor, normTensor, prediction]) on every frame to guarantee zero GPU memory leaks.</a:t>
             </a:r>
+            <a:br/>
             <a:br/>
             <a:r>
               <a:t>• Temporal Persistence: Uses HELMET_PERSISTENCE_FRAMES = 3 and HELMET_MISS_GRACE_FRAMES = 3 to eliminate single-frame flickering.</a:t>
@@ -5074,7 +6092,7 @@
         </p:nvSpPr>
         <p:spPr>
           <a:xfrm>
-            <a:off x="731520" y="457200"/>
+            <a:off x="731520" y="365760"/>
             <a:ext cx="10698480" cy="1005840"/>
           </a:xfrm>
           <a:prstGeom prst="rect">
@@ -5091,7 +6109,7 @@
             <a:pPr>
               <a:defRPr sz="2400" b="1">
                 <a:solidFill>
-                  <a:srgbClr val="F8FAFC"/>
+                  <a:srgbClr val="FFFFFF"/>
                 </a:solidFill>
               </a:defRPr>
             </a:pPr>
@@ -5103,7 +6121,7 @@
             <a:pPr>
               <a:defRPr sz="1300">
                 <a:solidFill>
-                  <a:srgbClr val="06B6D4"/>
+                  <a:srgbClr val="38BDF8"/>
                 </a:solidFill>
               </a:defRPr>
             </a:pPr>
@@ -5115,14 +6133,59 @@
       </p:sp>
       <p:sp>
         <p:nvSpPr>
-          <p:cNvPr id="3" name="TextBox 2"/>
+          <p:cNvPr id="3" name="Rounded Rectangle 2"/>
+          <p:cNvSpPr/>
+          <p:nvPr/>
+        </p:nvSpPr>
+        <p:spPr>
+          <a:xfrm>
+            <a:off x="731520" y="1554480"/>
+            <a:ext cx="5212080" cy="4754880"/>
+          </a:xfrm>
+          <a:prstGeom prst="roundRect">
+            <a:avLst/>
+          </a:prstGeom>
+          <a:solidFill>
+            <a:srgbClr val="1E293B"/>
+          </a:solidFill>
+          <a:ln w="19050">
+            <a:solidFill>
+              <a:srgbClr val="334155"/>
+            </a:solidFill>
+          </a:ln>
+        </p:spPr>
+        <p:style>
+          <a:lnRef idx="1">
+            <a:schemeClr val="accent1"/>
+          </a:lnRef>
+          <a:fillRef idx="3">
+            <a:schemeClr val="accent1"/>
+          </a:fillRef>
+          <a:effectRef idx="2">
+            <a:schemeClr val="accent1"/>
+          </a:effectRef>
+          <a:fontRef idx="minor">
+            <a:schemeClr val="lt1"/>
+          </a:fontRef>
+        </p:style>
+        <p:txBody>
+          <a:bodyPr rtlCol="0" anchor="ctr"/>
+          <a:lstStyle/>
+          <a:p>
+            <a:pPr algn="ctr"/>
+          </a:p>
+        </p:txBody>
+      </p:sp>
+      <p:sp>
+        <p:nvSpPr>
+          <p:cNvPr id="4" name="TextBox 3"/>
           <p:cNvSpPr txBox="1"/>
           <p:nvPr/>
         </p:nvSpPr>
         <p:spPr>
           <a:xfrm>
-            <a:off x="731520" y="1645920"/>
-            <a:ext cx="5212080" cy="4572000"/>
+            <a:off x="731520" y="1554480"/>
+            <a:ext cx="5212080" cy="4754880"/>
           </a:xfrm>
           <a:prstGeom prst="rect">
             <a:avLst/>
@@ -5138,7 +6201,7 @@
             <a:pPr>
               <a:defRPr sz="1800" b="1">
                 <a:solidFill>
-                  <a:srgbClr val="06B6D4"/>
+                  <a:srgbClr val="38BDF8"/>
                 </a:solidFill>
               </a:defRPr>
             </a:pPr>
@@ -5151,7 +6214,7 @@
             <a:pPr>
               <a:defRPr sz="1300">
                 <a:solidFill>
-                  <a:srgbClr val="F8FAFC"/>
+                  <a:srgbClr val="F1F5F9"/>
                 </a:solidFill>
               </a:defRPr>
             </a:pPr>
@@ -5159,14 +6222,17 @@
               <a:t>1. Webcam Feed: Connects device physical webcams via navigator.mediaDevices.getUserMedia.</a:t>
             </a:r>
             <a:br/>
+            <a:br/>
             <a:r>
               <a:t>2. IP CCTV RTSP Stream: Connects factory network cameras (rtsp://192.168.1.100:554/ch01).</a:t>
             </a:r>
             <a:br/>
+            <a:br/>
             <a:r>
               <a:t>3. Recorded MP4 Video File: Upload local recorded inspection video for testing.</a:t>
             </a:r>
             <a:br/>
+            <a:br/>
             <a:r>
               <a:t>4. Frame Quality Analysis: Real-time scoring for brightness (0-255), blur variance (Laplacian score), resolution, and FPS stability.</a:t>
             </a:r>
@@ -5175,14 +6241,59 @@
       </p:sp>
       <p:sp>
         <p:nvSpPr>
-          <p:cNvPr id="4" name="TextBox 3"/>
+          <p:cNvPr id="5" name="Rounded Rectangle 4"/>
+          <p:cNvSpPr/>
+          <p:nvPr/>
+        </p:nvSpPr>
+        <p:spPr>
+          <a:xfrm>
+            <a:off x="6217920" y="1554480"/>
+            <a:ext cx="5212080" cy="4754880"/>
+          </a:xfrm>
+          <a:prstGeom prst="roundRect">
+            <a:avLst/>
+          </a:prstGeom>
+          <a:solidFill>
+            <a:srgbClr val="1E293B"/>
+          </a:solidFill>
+          <a:ln w="19050">
+            <a:solidFill>
+              <a:srgbClr val="334155"/>
+            </a:solidFill>
+          </a:ln>
+        </p:spPr>
+        <p:style>
+          <a:lnRef idx="1">
+            <a:schemeClr val="accent1"/>
+          </a:lnRef>
+          <a:fillRef idx="3">
+            <a:schemeClr val="accent1"/>
+          </a:fillRef>
+          <a:effectRef idx="2">
+            <a:schemeClr val="accent1"/>
+          </a:effectRef>
+          <a:fontRef idx="minor">
+            <a:schemeClr val="lt1"/>
+          </a:fontRef>
+        </p:style>
+        <p:txBody>
+          <a:bodyPr rtlCol="0" anchor="ctr"/>
+          <a:lstStyle/>
+          <a:p>
+            <a:pPr algn="ctr"/>
+          </a:p>
+        </p:txBody>
+      </p:sp>
+      <p:sp>
+        <p:nvSpPr>
+          <p:cNvPr id="6" name="TextBox 5"/>
           <p:cNvSpPr txBox="1"/>
           <p:nvPr/>
         </p:nvSpPr>
         <p:spPr>
           <a:xfrm>
-            <a:off x="6217920" y="1645920"/>
-            <a:ext cx="5212080" cy="4572000"/>
+            <a:off x="6217920" y="1554480"/>
+            <a:ext cx="5212080" cy="4754880"/>
           </a:xfrm>
           <a:prstGeom prst="rect">
             <a:avLst/>
@@ -5198,7 +6309,7 @@
             <a:pPr>
               <a:defRPr sz="1800" b="1">
                 <a:solidFill>
-                  <a:srgbClr val="10B981"/>
+                  <a:srgbClr val="34D399"/>
                 </a:solidFill>
               </a:defRPr>
             </a:pPr>
@@ -5211,7 +6322,7 @@
             <a:pPr>
               <a:defRPr sz="1300">
                 <a:solidFill>
-                  <a:srgbClr val="F8FAFC"/>
+                  <a:srgbClr val="F1F5F9"/>
                 </a:solidFill>
               </a:defRPr>
             </a:pPr>
@@ -5219,9 +6330,11 @@
               <a:t>• Root Cause Resolved: Browser raw camera stream does not mirror video, causing left/right inversion. Added selfie mirror transformation (scaleX(-1)).</a:t>
             </a:r>
             <a:br/>
+            <a:br/>
             <a:r>
               <a:t>• 1-Click Toggle Button: Added 'Mirror View (ON / OFF)' button in both Camera Setup and Live Monitoring headers.</a:t>
             </a:r>
+            <a:br/>
             <a:br/>
             <a:r>
               <a:t>• Auto-Aligned Bounding Box Math: Bounding boxes auto-align to flipped video (px = width - (x + w)*width), while text tags remain 100% readable &amp; non-flipped!</a:t>
@@ -5263,7 +6376,7 @@
         </p:nvSpPr>
         <p:spPr>
           <a:xfrm>
-            <a:off x="731520" y="457200"/>
+            <a:off x="731520" y="365760"/>
             <a:ext cx="10698480" cy="1005840"/>
           </a:xfrm>
           <a:prstGeom prst="rect">
@@ -5280,7 +6393,7 @@
             <a:pPr>
               <a:defRPr sz="2400" b="1">
                 <a:solidFill>
-                  <a:srgbClr val="F8FAFC"/>
+                  <a:srgbClr val="FFFFFF"/>
                 </a:solidFill>
               </a:defRPr>
             </a:pPr>
@@ -5292,7 +6405,7 @@
             <a:pPr>
               <a:defRPr sz="1300">
                 <a:solidFill>
-                  <a:srgbClr val="06B6D4"/>
+                  <a:srgbClr val="38BDF8"/>
                 </a:solidFill>
               </a:defRPr>
             </a:pPr>
@@ -5304,14 +6417,59 @@
       </p:sp>
       <p:sp>
         <p:nvSpPr>
-          <p:cNvPr id="3" name="TextBox 2"/>
+          <p:cNvPr id="3" name="Rounded Rectangle 2"/>
+          <p:cNvSpPr/>
+          <p:nvPr/>
+        </p:nvSpPr>
+        <p:spPr>
+          <a:xfrm>
+            <a:off x="731520" y="1554480"/>
+            <a:ext cx="10698480" cy="4754880"/>
+          </a:xfrm>
+          <a:prstGeom prst="roundRect">
+            <a:avLst/>
+          </a:prstGeom>
+          <a:solidFill>
+            <a:srgbClr val="1E293B"/>
+          </a:solidFill>
+          <a:ln w="19050">
+            <a:solidFill>
+              <a:srgbClr val="334155"/>
+            </a:solidFill>
+          </a:ln>
+        </p:spPr>
+        <p:style>
+          <a:lnRef idx="1">
+            <a:schemeClr val="accent1"/>
+          </a:lnRef>
+          <a:fillRef idx="3">
+            <a:schemeClr val="accent1"/>
+          </a:fillRef>
+          <a:effectRef idx="2">
+            <a:schemeClr val="accent1"/>
+          </a:effectRef>
+          <a:fontRef idx="minor">
+            <a:schemeClr val="lt1"/>
+          </a:fontRef>
+        </p:style>
+        <p:txBody>
+          <a:bodyPr rtlCol="0" anchor="ctr"/>
+          <a:lstStyle/>
+          <a:p>
+            <a:pPr algn="ctr"/>
+          </a:p>
+        </p:txBody>
+      </p:sp>
+      <p:sp>
+        <p:nvSpPr>
+          <p:cNvPr id="4" name="TextBox 3"/>
           <p:cNvSpPr txBox="1"/>
           <p:nvPr/>
         </p:nvSpPr>
         <p:spPr>
           <a:xfrm>
-            <a:off x="731520" y="1645920"/>
-            <a:ext cx="10698480" cy="4572000"/>
+            <a:off x="731520" y="1554480"/>
+            <a:ext cx="10698480" cy="4754880"/>
           </a:xfrm>
           <a:prstGeom prst="rect">
             <a:avLst/>
@@ -5327,7 +6485,7 @@
             <a:pPr>
               <a:defRPr sz="1800" b="1">
                 <a:solidFill>
-                  <a:srgbClr val="06B6D4"/>
+                  <a:srgbClr val="38BDF8"/>
                 </a:solidFill>
               </a:defRPr>
             </a:pPr>
@@ -5340,7 +6498,7 @@
             <a:pPr>
               <a:defRPr sz="1300">
                 <a:solidFill>
-                  <a:srgbClr val="F8FAFC"/>
+                  <a:srgbClr val="F1F5F9"/>
                 </a:solidFill>
               </a:defRPr>
             </a:pPr>
@@ -5348,17 +6506,21 @@
               <a:t>• Decoupled Render Loop: requestAnimationFrame runs smooth 60 FPS video canvas rendering, completely decoupled from async TensorFlow inference.</a:t>
             </a:r>
             <a:br/>
+            <a:br/>
             <a:r>
               <a:t>• Throttled Async Inference: AI object detection runs every ~150ms using a boolean concurrency lock (isDetectingRef) to prevent promise queueing &amp; UI freezes.</a:t>
             </a:r>
             <a:br/>
+            <a:br/>
             <a:r>
               <a:t>• Visual Overlay Layers: Draws Person bounding boxes, Helmet OK/NO HELMET tags, Cell Phone bboxes, Proximity distance lines, and Restricted Zone polygons.</a:t>
             </a:r>
             <a:br/>
+            <a:br/>
             <a:r>
               <a:t>• Real-Time AI Debug Inspector: Live on-screen console card showing raw prediction counts, phone candidates, and associated worker track IDs.</a:t>
             </a:r>
+            <a:br/>
             <a:br/>
             <a:r>
               <a:t>• Manual Evidence Alert Capture: 1-click button captures canvas snapshot as base64 string and triggers instant safety alert to database.</a:t>
@@ -5400,7 +6562,7 @@
         </p:nvSpPr>
         <p:spPr>
           <a:xfrm>
-            <a:off x="731520" y="457200"/>
+            <a:off x="731520" y="365760"/>
             <a:ext cx="10698480" cy="1005840"/>
           </a:xfrm>
           <a:prstGeom prst="rect">
@@ -5417,7 +6579,7 @@
             <a:pPr>
               <a:defRPr sz="2400" b="1">
                 <a:solidFill>
-                  <a:srgbClr val="F8FAFC"/>
+                  <a:srgbClr val="FFFFFF"/>
                 </a:solidFill>
               </a:defRPr>
             </a:pPr>
@@ -5429,7 +6591,7 @@
             <a:pPr>
               <a:defRPr sz="1300">
                 <a:solidFill>
-                  <a:srgbClr val="06B6D4"/>
+                  <a:srgbClr val="38BDF8"/>
                 </a:solidFill>
               </a:defRPr>
             </a:pPr>
@@ -5441,14 +6603,59 @@
       </p:sp>
       <p:sp>
         <p:nvSpPr>
-          <p:cNvPr id="3" name="TextBox 2"/>
+          <p:cNvPr id="3" name="Rounded Rectangle 2"/>
+          <p:cNvSpPr/>
+          <p:nvPr/>
+        </p:nvSpPr>
+        <p:spPr>
+          <a:xfrm>
+            <a:off x="731520" y="1554480"/>
+            <a:ext cx="5212080" cy="4754880"/>
+          </a:xfrm>
+          <a:prstGeom prst="roundRect">
+            <a:avLst/>
+          </a:prstGeom>
+          <a:solidFill>
+            <a:srgbClr val="1E293B"/>
+          </a:solidFill>
+          <a:ln w="19050">
+            <a:solidFill>
+              <a:srgbClr val="334155"/>
+            </a:solidFill>
+          </a:ln>
+        </p:spPr>
+        <p:style>
+          <a:lnRef idx="1">
+            <a:schemeClr val="accent1"/>
+          </a:lnRef>
+          <a:fillRef idx="3">
+            <a:schemeClr val="accent1"/>
+          </a:fillRef>
+          <a:effectRef idx="2">
+            <a:schemeClr val="accent1"/>
+          </a:effectRef>
+          <a:fontRef idx="minor">
+            <a:schemeClr val="lt1"/>
+          </a:fontRef>
+        </p:style>
+        <p:txBody>
+          <a:bodyPr rtlCol="0" anchor="ctr"/>
+          <a:lstStyle/>
+          <a:p>
+            <a:pPr algn="ctr"/>
+          </a:p>
+        </p:txBody>
+      </p:sp>
+      <p:sp>
+        <p:nvSpPr>
+          <p:cNvPr id="4" name="TextBox 3"/>
           <p:cNvSpPr txBox="1"/>
           <p:nvPr/>
         </p:nvSpPr>
         <p:spPr>
           <a:xfrm>
-            <a:off x="731520" y="1645920"/>
-            <a:ext cx="5212080" cy="4572000"/>
+            <a:off x="731520" y="1554480"/>
+            <a:ext cx="5212080" cy="4754880"/>
           </a:xfrm>
           <a:prstGeom prst="rect">
             <a:avLst/>
@@ -5464,7 +6671,7 @@
             <a:pPr>
               <a:defRPr sz="1800" b="1">
                 <a:solidFill>
-                  <a:srgbClr val="A855F7"/>
+                  <a:srgbClr val="C084FC"/>
                 </a:solidFill>
               </a:defRPr>
             </a:pPr>
@@ -5477,7 +6684,7 @@
             <a:pPr>
               <a:defRPr sz="1300">
                 <a:solidFill>
-                  <a:srgbClr val="F8FAFC"/>
+                  <a:srgbClr val="F1F5F9"/>
                 </a:solidFill>
               </a:defRPr>
             </a:pPr>
@@ -5485,14 +6692,17 @@
               <a:t>1. Bottle Detection &amp; ID: Tracks bottles moving through conveyor (BTL-9840, BTL-9841, etc.).</a:t>
             </a:r>
             <a:br/>
+            <a:br/>
             <a:r>
               <a:t>2. Fill-Level Inspection: PASS (88-95%), LOW FILL (60-77%), HIGH FILL (98-100%) with liquid level bar gauge.</a:t>
             </a:r>
             <a:br/>
+            <a:br/>
             <a:r>
               <a:t>3. Cap Integrity Check: PASS, MISSING, MISALIGNED, or DAMAGED.</a:t>
             </a:r>
             <a:br/>
+            <a:br/>
             <a:r>
               <a:t>4. Bottle Surface &amp; Body Anomaly: PASS, SURFACE DEFECT, SHAPE ANOMALY.</a:t>
             </a:r>
@@ -5501,14 +6711,59 @@
       </p:sp>
       <p:sp>
         <p:nvSpPr>
-          <p:cNvPr id="4" name="TextBox 3"/>
+          <p:cNvPr id="5" name="Rounded Rectangle 4"/>
+          <p:cNvSpPr/>
+          <p:nvPr/>
+        </p:nvSpPr>
+        <p:spPr>
+          <a:xfrm>
+            <a:off x="6217920" y="1554480"/>
+            <a:ext cx="5212080" cy="4754880"/>
+          </a:xfrm>
+          <a:prstGeom prst="roundRect">
+            <a:avLst/>
+          </a:prstGeom>
+          <a:solidFill>
+            <a:srgbClr val="1E293B"/>
+          </a:solidFill>
+          <a:ln w="19050">
+            <a:solidFill>
+              <a:srgbClr val="334155"/>
+            </a:solidFill>
+          </a:ln>
+        </p:spPr>
+        <p:style>
+          <a:lnRef idx="1">
+            <a:schemeClr val="accent1"/>
+          </a:lnRef>
+          <a:fillRef idx="3">
+            <a:schemeClr val="accent1"/>
+          </a:fillRef>
+          <a:effectRef idx="2">
+            <a:schemeClr val="accent1"/>
+          </a:effectRef>
+          <a:fontRef idx="minor">
+            <a:schemeClr val="lt1"/>
+          </a:fontRef>
+        </p:style>
+        <p:txBody>
+          <a:bodyPr rtlCol="0" anchor="ctr"/>
+          <a:lstStyle/>
+          <a:p>
+            <a:pPr algn="ctr"/>
+          </a:p>
+        </p:txBody>
+      </p:sp>
+      <p:sp>
+        <p:nvSpPr>
+          <p:cNvPr id="6" name="TextBox 5"/>
           <p:cNvSpPr txBox="1"/>
           <p:nvPr/>
         </p:nvSpPr>
         <p:spPr>
           <a:xfrm>
-            <a:off x="6217920" y="1645920"/>
-            <a:ext cx="5212080" cy="4572000"/>
+            <a:off x="6217920" y="1554480"/>
+            <a:ext cx="5212080" cy="4754880"/>
           </a:xfrm>
           <a:prstGeom prst="rect">
             <a:avLst/>
@@ -5524,7 +6779,7 @@
             <a:pPr>
               <a:defRPr sz="1800" b="1">
                 <a:solidFill>
-                  <a:srgbClr val="10B981"/>
+                  <a:srgbClr val="34D399"/>
                 </a:solidFill>
               </a:defRPr>
             </a:pPr>
@@ -5537,7 +6792,7 @@
             <a:pPr>
               <a:defRPr sz="1300">
                 <a:solidFill>
-                  <a:srgbClr val="F8FAFC"/>
+                  <a:srgbClr val="F1F5F9"/>
                 </a:solidFill>
               </a:defRPr>
             </a:pPr>
@@ -5545,13 +6800,16 @@
               <a:t>• Overall Decision: PASS / ACCEPT (all checks pass) vs REJECT / DISCARD (critical check fails).</a:t>
             </a:r>
             <a:br/>
+            <a:br/>
             <a:r>
               <a:t>• Air-Jet Ejector Output: Automated reject trigger state logged on inspection failure.</a:t>
             </a:r>
             <a:br/>
+            <a:br/>
             <a:r>
               <a:t>• Conveyor Live Viewport: Animated conveyor belt, 3D laser scanner beam, and real-time liquid level graphics.</a:t>
             </a:r>
+            <a:br/>
             <a:br/>
             <a:r>
               <a:t>• Modular Hardware API: Service packagingProcessor.js structured for seamless replacement with real 3D depth cameras &amp; TensorRT models.</a:t>
@@ -5593,7 +6851,7 @@
         </p:nvSpPr>
         <p:spPr>
           <a:xfrm>
-            <a:off x="731520" y="457200"/>
+            <a:off x="731520" y="365760"/>
             <a:ext cx="10698480" cy="1005840"/>
           </a:xfrm>
           <a:prstGeom prst="rect">
@@ -5610,7 +6868,7 @@
             <a:pPr>
               <a:defRPr sz="2400" b="1">
                 <a:solidFill>
-                  <a:srgbClr val="F8FAFC"/>
+                  <a:srgbClr val="FFFFFF"/>
                 </a:solidFill>
               </a:defRPr>
             </a:pPr>
@@ -5622,7 +6880,7 @@
             <a:pPr>
               <a:defRPr sz="1300">
                 <a:solidFill>
-                  <a:srgbClr val="06B6D4"/>
+                  <a:srgbClr val="38BDF8"/>
                 </a:solidFill>
               </a:defRPr>
             </a:pPr>
@@ -5634,14 +6892,59 @@
       </p:sp>
       <p:sp>
         <p:nvSpPr>
-          <p:cNvPr id="3" name="TextBox 2"/>
+          <p:cNvPr id="3" name="Rounded Rectangle 2"/>
+          <p:cNvSpPr/>
+          <p:nvPr/>
+        </p:nvSpPr>
+        <p:spPr>
+          <a:xfrm>
+            <a:off x="731520" y="1554480"/>
+            <a:ext cx="5212080" cy="4754880"/>
+          </a:xfrm>
+          <a:prstGeom prst="roundRect">
+            <a:avLst/>
+          </a:prstGeom>
+          <a:solidFill>
+            <a:srgbClr val="1E293B"/>
+          </a:solidFill>
+          <a:ln w="19050">
+            <a:solidFill>
+              <a:srgbClr val="334155"/>
+            </a:solidFill>
+          </a:ln>
+        </p:spPr>
+        <p:style>
+          <a:lnRef idx="1">
+            <a:schemeClr val="accent1"/>
+          </a:lnRef>
+          <a:fillRef idx="3">
+            <a:schemeClr val="accent1"/>
+          </a:fillRef>
+          <a:effectRef idx="2">
+            <a:schemeClr val="accent1"/>
+          </a:effectRef>
+          <a:fontRef idx="minor">
+            <a:schemeClr val="lt1"/>
+          </a:fontRef>
+        </p:style>
+        <p:txBody>
+          <a:bodyPr rtlCol="0" anchor="ctr"/>
+          <a:lstStyle/>
+          <a:p>
+            <a:pPr algn="ctr"/>
+          </a:p>
+        </p:txBody>
+      </p:sp>
+      <p:sp>
+        <p:nvSpPr>
+          <p:cNvPr id="4" name="TextBox 3"/>
           <p:cNvSpPr txBox="1"/>
           <p:nvPr/>
         </p:nvSpPr>
         <p:spPr>
           <a:xfrm>
-            <a:off x="731520" y="1645920"/>
-            <a:ext cx="5212080" cy="4572000"/>
+            <a:off x="731520" y="1554480"/>
+            <a:ext cx="5212080" cy="4754880"/>
           </a:xfrm>
           <a:prstGeom prst="rect">
             <a:avLst/>
@@ -5657,7 +6960,7 @@
             <a:pPr>
               <a:defRPr sz="1800" b="1">
                 <a:solidFill>
-                  <a:srgbClr val="EF4444"/>
+                  <a:srgbClr val="F87171"/>
                 </a:solidFill>
               </a:defRPr>
             </a:pPr>
@@ -5670,18 +6973,20 @@
             <a:pPr>
               <a:defRPr sz="1300">
                 <a:solidFill>
-                  <a:srgbClr val="F8FAFC"/>
-                </a:solidFill>
-              </a:defRPr>
-            </a:pPr>
-            <a:r>
-              <a:t>• Geofence Perimeter: Visual red danger box (SAFETY BOUNDARY 2.0m) drawn around vehicles (Forklift #FLT-09) &amp; machinery.</a:t>
-            </a:r>
+                  <a:srgbClr val="F1F5F9"/>
+                </a:solidFill>
+              </a:defRPr>
+            </a:pPr>
+            <a:r>
+              <a:t>• Geofence Perimeter: Visual red danger box (DANGEROUS ZONE BOUNDARY 2.0m) drawn around vehicles &amp; machinery.</a:t>
+            </a:r>
+            <a:br/>
             <a:br/>
             <a:r>
               <a:t>• Real-World Purpose: Prevents workers from entering forbidden high-risk zones (High-Voltage Transformers, Crane Swings, Conveyors).</a:t>
             </a:r>
             <a:br/>
+            <a:br/>
             <a:r>
               <a:t>• Polygon Ray-Casting: Detects exact boundary intrusion using point-in-polygon math.</a:t>
             </a:r>
@@ -5690,14 +6995,59 @@
       </p:sp>
       <p:sp>
         <p:nvSpPr>
-          <p:cNvPr id="4" name="TextBox 3"/>
+          <p:cNvPr id="5" name="Rounded Rectangle 4"/>
+          <p:cNvSpPr/>
+          <p:nvPr/>
+        </p:nvSpPr>
+        <p:spPr>
+          <a:xfrm>
+            <a:off x="6217920" y="1554480"/>
+            <a:ext cx="5212080" cy="4754880"/>
+          </a:xfrm>
+          <a:prstGeom prst="roundRect">
+            <a:avLst/>
+          </a:prstGeom>
+          <a:solidFill>
+            <a:srgbClr val="1E293B"/>
+          </a:solidFill>
+          <a:ln w="19050">
+            <a:solidFill>
+              <a:srgbClr val="334155"/>
+            </a:solidFill>
+          </a:ln>
+        </p:spPr>
+        <p:style>
+          <a:lnRef idx="1">
+            <a:schemeClr val="accent1"/>
+          </a:lnRef>
+          <a:fillRef idx="3">
+            <a:schemeClr val="accent1"/>
+          </a:fillRef>
+          <a:effectRef idx="2">
+            <a:schemeClr val="accent1"/>
+          </a:effectRef>
+          <a:fontRef idx="minor">
+            <a:schemeClr val="lt1"/>
+          </a:fontRef>
+        </p:style>
+        <p:txBody>
+          <a:bodyPr rtlCol="0" anchor="ctr"/>
+          <a:lstStyle/>
+          <a:p>
+            <a:pPr algn="ctr"/>
+          </a:p>
+        </p:txBody>
+      </p:sp>
+      <p:sp>
+        <p:nvSpPr>
+          <p:cNvPr id="6" name="TextBox 5"/>
           <p:cNvSpPr txBox="1"/>
           <p:nvPr/>
         </p:nvSpPr>
         <p:spPr>
           <a:xfrm>
-            <a:off x="6217920" y="1645920"/>
-            <a:ext cx="5212080" cy="4572000"/>
+            <a:off x="6217920" y="1554480"/>
+            <a:ext cx="5212080" cy="4754880"/>
           </a:xfrm>
           <a:prstGeom prst="rect">
             <a:avLst/>
@@ -5713,7 +7063,7 @@
             <a:pPr>
               <a:defRPr sz="1800" b="1">
                 <a:solidFill>
-                  <a:srgbClr val="F59E0B"/>
+                  <a:srgbClr val="FBBF24"/>
                 </a:solidFill>
               </a:defRPr>
             </a:pPr>
@@ -5726,13 +7076,14 @@
             <a:pPr>
               <a:defRPr sz="1300">
                 <a:solidFill>
-                  <a:srgbClr val="F8FAFC"/>
+                  <a:srgbClr val="F1F5F9"/>
                 </a:solidFill>
               </a:defRPr>
             </a:pPr>
             <a:r>
               <a:t>• Dynamic Worker Position Movement: Moving the Worker Distance slider (0.2m to 3.0m) dynamically shifts worker node position on radar screen relative to vehicle boundary!</a:t>
             </a:r>
+            <a:br/>
             <a:br/>
             <a:r>
               <a:t>• Live Risk Status Badges:</a:t>

</xml_diff>